<commit_message>
Add : updated presentation
</commit_message>
<xml_diff>
--- a/docs/midyear-evalutaion-presentation.pptx
+++ b/docs/midyear-evalutaion-presentation.pptx
@@ -5,24 +5,27 @@
     <p:sldMasterId id="2147483660" r:id="rId4"/>
   </p:sldMasterIdLst>
   <p:notesMasterIdLst>
-    <p:notesMasterId r:id="rId17"/>
+    <p:notesMasterId r:id="rId20"/>
   </p:notesMasterIdLst>
   <p:handoutMasterIdLst>
-    <p:handoutMasterId r:id="rId18"/>
+    <p:handoutMasterId r:id="rId21"/>
   </p:handoutMasterIdLst>
   <p:sldIdLst>
     <p:sldId id="257" r:id="rId5"/>
     <p:sldId id="268" r:id="rId6"/>
     <p:sldId id="273" r:id="rId7"/>
-    <p:sldId id="274" r:id="rId8"/>
-    <p:sldId id="275" r:id="rId9"/>
-    <p:sldId id="276" r:id="rId10"/>
-    <p:sldId id="277" r:id="rId11"/>
-    <p:sldId id="278" r:id="rId12"/>
-    <p:sldId id="281" r:id="rId13"/>
-    <p:sldId id="282" r:id="rId14"/>
-    <p:sldId id="279" r:id="rId15"/>
-    <p:sldId id="280" r:id="rId16"/>
+    <p:sldId id="275" r:id="rId8"/>
+    <p:sldId id="276" r:id="rId9"/>
+    <p:sldId id="277" r:id="rId10"/>
+    <p:sldId id="281" r:id="rId11"/>
+    <p:sldId id="282" r:id="rId12"/>
+    <p:sldId id="283" r:id="rId13"/>
+    <p:sldId id="284" r:id="rId14"/>
+    <p:sldId id="285" r:id="rId15"/>
+    <p:sldId id="286" r:id="rId16"/>
+    <p:sldId id="278" r:id="rId17"/>
+    <p:sldId id="279" r:id="rId18"/>
+    <p:sldId id="280" r:id="rId19"/>
   </p:sldIdLst>
   <p:sldSz cx="12188825" cy="6858000"/>
   <p:notesSz cx="6858000" cy="9144000"/>
@@ -236,7 +239,7 @@
           <a:p>
             <a:fld id="{FE5B4EDC-59C0-49C7-8ADA-5A781B329E02}" type="datetimeFigureOut">
               <a:rPr lang="en-US"/>
-              <a:t>6/13/2026</a:t>
+              <a:t>6/15/2026</a:t>
             </a:fld>
             <a:endParaRPr/>
           </a:p>
@@ -317,6 +320,414 @@
   </p:cSld>
   <p:clrMap bg1="lt1" tx1="dk1" bg2="lt2" tx2="dk2" accent1="accent1" accent2="accent2" accent3="accent3" accent4="accent4" accent5="accent5" accent6="accent6" hlink="hlink" folHlink="folHlink"/>
 </p:handoutMaster>
+</file>
+
+<file path=ppt/ink/ink1.xml><?xml version="1.0" encoding="utf-8"?>
+<inkml:ink xmlns:inkml="http://www.w3.org/2003/InkML">
+  <inkml:definitions>
+    <inkml:context xml:id="ctx0">
+      <inkml:inkSource xml:id="inkSrc0">
+        <inkml:traceFormat>
+          <inkml:channel name="X" type="integer" min="-2.14748E9" max="2.14748E9" units="cm"/>
+          <inkml:channel name="Y" type="integer" min="-2.14748E9" max="2.14748E9" units="cm"/>
+        </inkml:traceFormat>
+        <inkml:channelProperties>
+          <inkml:channelProperty channel="X" name="resolution" value="1000" units="1/cm"/>
+          <inkml:channelProperty channel="Y" name="resolution" value="1000" units="1/cm"/>
+        </inkml:channelProperties>
+      </inkml:inkSource>
+      <inkml:timestamp xml:id="ts0" timeString="2026-06-13T23:14:07.231"/>
+    </inkml:context>
+    <inkml:brush xml:id="br0">
+      <inkml:brushProperty name="width" value="0.3" units="cm"/>
+      <inkml:brushProperty name="height" value="0.6" units="cm"/>
+      <inkml:brushProperty name="color" value="#00F900"/>
+      <inkml:brushProperty name="tip" value="rectangle"/>
+      <inkml:brushProperty name="rasterOp" value="maskPen"/>
+      <inkml:brushProperty name="ignorePressure" value="1"/>
+    </inkml:brush>
+  </inkml:definitions>
+  <inkml:trace contextRef="#ctx0" brushRef="#br0">1 123,'1'7,"1"0,0 0,1 0,-1 0,1-1,1 1,-1-1,1 1,7 8,9 18,-1 5,44 64,-42-71,35 44,-50-68,0 0,0-1,1 0,-1 0,1-1,1 0,-1 0,1 0,0-1,10 3,-13-5,0-1,1 0,-1 0,1 0,-1-1,1 0,0 0,-1 0,1-1,-1 0,1 0,-1 0,0-1,1 0,-1 0,0 0,7-4,17-8,1 2,1 1,42-9,-37 11,186-71,-202 72,62-20,26-12,-75 26,2 2,41-10,-41 13,0-2,36-16,-31 11,74-21,-70 25,61-26,-61 20,-34 16,-1-1,1-1,-1 0,0 0,0-1,0 0,-1 0,0-1,0 0,0-1,-1 1,12-15,-12 8</inkml:trace>
+</inkml:ink>
+</file>
+
+<file path=ppt/ink/ink10.xml><?xml version="1.0" encoding="utf-8"?>
+<inkml:ink xmlns:inkml="http://www.w3.org/2003/InkML">
+  <inkml:definitions>
+    <inkml:context xml:id="ctx0">
+      <inkml:inkSource xml:id="inkSrc0">
+        <inkml:traceFormat>
+          <inkml:channel name="X" type="integer" min="-2.14748E9" max="2.14748E9" units="cm"/>
+          <inkml:channel name="Y" type="integer" min="-2.14748E9" max="2.14748E9" units="cm"/>
+        </inkml:traceFormat>
+        <inkml:channelProperties>
+          <inkml:channelProperty channel="X" name="resolution" value="1000" units="1/cm"/>
+          <inkml:channelProperty channel="Y" name="resolution" value="1000" units="1/cm"/>
+        </inkml:channelProperties>
+      </inkml:inkSource>
+      <inkml:timestamp xml:id="ts0" timeString="2026-06-13T23:18:55.920"/>
+    </inkml:context>
+    <inkml:brush xml:id="br0">
+      <inkml:brushProperty name="width" value="0.3" units="cm"/>
+      <inkml:brushProperty name="height" value="0.6" units="cm"/>
+      <inkml:brushProperty name="color" value="#FFFC00"/>
+      <inkml:brushProperty name="tip" value="rectangle"/>
+      <inkml:brushProperty name="rasterOp" value="maskPen"/>
+      <inkml:brushProperty name="ignorePressure" value="1"/>
+    </inkml:brush>
+  </inkml:definitions>
+  <inkml:trace contextRef="#ctx0" brushRef="#br0">0 0,'0'0</inkml:trace>
+</inkml:ink>
+</file>
+
+<file path=ppt/ink/ink11.xml><?xml version="1.0" encoding="utf-8"?>
+<inkml:ink xmlns:inkml="http://www.w3.org/2003/InkML">
+  <inkml:definitions>
+    <inkml:context xml:id="ctx0">
+      <inkml:inkSource xml:id="inkSrc0">
+        <inkml:traceFormat>
+          <inkml:channel name="X" type="integer" min="-2.14748E9" max="2.14748E9" units="cm"/>
+          <inkml:channel name="Y" type="integer" min="-2.14748E9" max="2.14748E9" units="cm"/>
+        </inkml:traceFormat>
+        <inkml:channelProperties>
+          <inkml:channelProperty channel="X" name="resolution" value="1000" units="1/cm"/>
+          <inkml:channelProperty channel="Y" name="resolution" value="1000" units="1/cm"/>
+        </inkml:channelProperties>
+      </inkml:inkSource>
+      <inkml:timestamp xml:id="ts0" timeString="2026-06-13T23:19:03.799"/>
+    </inkml:context>
+    <inkml:brush xml:id="br0">
+      <inkml:brushProperty name="width" value="0.3" units="cm"/>
+      <inkml:brushProperty name="height" value="0.6" units="cm"/>
+      <inkml:brushProperty name="color" value="#FFFC00"/>
+      <inkml:brushProperty name="tip" value="rectangle"/>
+      <inkml:brushProperty name="rasterOp" value="maskPen"/>
+      <inkml:brushProperty name="ignorePressure" value="1"/>
+    </inkml:brush>
+  </inkml:definitions>
+  <inkml:trace contextRef="#ctx0" brushRef="#br0">1 0,'0'0</inkml:trace>
+</inkml:ink>
+</file>
+
+<file path=ppt/ink/ink12.xml><?xml version="1.0" encoding="utf-8"?>
+<inkml:ink xmlns:inkml="http://www.w3.org/2003/InkML">
+  <inkml:definitions>
+    <inkml:context xml:id="ctx0">
+      <inkml:inkSource xml:id="inkSrc0">
+        <inkml:traceFormat>
+          <inkml:channel name="X" type="integer" min="-2.14748E9" max="2.14748E9" units="cm"/>
+          <inkml:channel name="Y" type="integer" min="-2.14748E9" max="2.14748E9" units="cm"/>
+        </inkml:traceFormat>
+        <inkml:channelProperties>
+          <inkml:channelProperty channel="X" name="resolution" value="1000" units="1/cm"/>
+          <inkml:channelProperty channel="Y" name="resolution" value="1000" units="1/cm"/>
+        </inkml:channelProperties>
+      </inkml:inkSource>
+      <inkml:timestamp xml:id="ts0" timeString="2026-06-13T23:19:03.959"/>
+    </inkml:context>
+    <inkml:brush xml:id="br0">
+      <inkml:brushProperty name="width" value="0.3" units="cm"/>
+      <inkml:brushProperty name="height" value="0.6" units="cm"/>
+      <inkml:brushProperty name="color" value="#FFFC00"/>
+      <inkml:brushProperty name="tip" value="rectangle"/>
+      <inkml:brushProperty name="rasterOp" value="maskPen"/>
+      <inkml:brushProperty name="ignorePressure" value="1"/>
+    </inkml:brush>
+  </inkml:definitions>
+  <inkml:trace contextRef="#ctx0" brushRef="#br0">1 0,'0'0</inkml:trace>
+</inkml:ink>
+</file>
+
+<file path=ppt/ink/ink13.xml><?xml version="1.0" encoding="utf-8"?>
+<inkml:ink xmlns:inkml="http://www.w3.org/2003/InkML">
+  <inkml:definitions>
+    <inkml:context xml:id="ctx0">
+      <inkml:inkSource xml:id="inkSrc0">
+        <inkml:traceFormat>
+          <inkml:channel name="X" type="integer" min="-2.14748E9" max="2.14748E9" units="cm"/>
+          <inkml:channel name="Y" type="integer" min="-2.14748E9" max="2.14748E9" units="cm"/>
+        </inkml:traceFormat>
+        <inkml:channelProperties>
+          <inkml:channelProperty channel="X" name="resolution" value="1000" units="1/cm"/>
+          <inkml:channelProperty channel="Y" name="resolution" value="1000" units="1/cm"/>
+        </inkml:channelProperties>
+      </inkml:inkSource>
+      <inkml:timestamp xml:id="ts0" timeString="2026-06-13T23:21:26.413"/>
+    </inkml:context>
+    <inkml:brush xml:id="br0">
+      <inkml:brushProperty name="width" value="0.3" units="cm"/>
+      <inkml:brushProperty name="height" value="0.6" units="cm"/>
+      <inkml:brushProperty name="color" value="#FFFC00"/>
+      <inkml:brushProperty name="tip" value="rectangle"/>
+      <inkml:brushProperty name="rasterOp" value="maskPen"/>
+      <inkml:brushProperty name="ignorePressure" value="1"/>
+    </inkml:brush>
+  </inkml:definitions>
+  <inkml:trace contextRef="#ctx0" brushRef="#br0">3600 218,'-100'1,"-110"-3,172-3,-53-14,9 1,-90-21,-6-1,128 31,-35-6,-166-7,79 11,-1-1,-316 13,471 0,0 1,-31 7,-31 3,-1-4,76-8,-1 1,1 0,-1 1,1-1,-1 1,1 0,0 0,0 1,0 0,0 0,-8 6,13-9,-1 1,1 0,-1-1,1 1,0-1,-1 1,1 0,0 0,-1-1,1 1,0 0,0-1,-1 1,1 0,0 0,0-1,0 1,0 0,0 0,0-1,0 1,0 0,1 0,-1-1,0 1,0 0,1 0,-1-1,0 1,1 1,23 18,33 4,30 7,-44-14,0-3,46 10,-9-1,-60-15,0-2,30 6,95 18,-86-17,77 9,-80-14,81 22,-89-18,0-2,79 6,-65-10,63 12,-72-8,-1-3,60 1,-83-7,52 9,-50-5,44 2,-22-6,90 15,-73-10,112-6,-154-1,-53-1,0-1,-45-11,35 6,-40-11,46 10,-53-8,-35-6,-9-1,-117 0,153 13,52 5,-56-1,-238 8,366 1,50 8,28 3,-104-13,36 1,82 12,-44 1,1-4,96 0,-168-10,32 0,0 1,61 11,-46-5,0-2,0-2,63-6,-8 0,381 3,-471-2,1-2,0 0,-1-2,0 0,0-2,-1 0,40-22,49-17,-108 46,-1 1,0-1,0 0,0 0,0 0,1 0,-2 0,1-1,0 1,0 0,0-1,-1 0,1 1,0-1,-1 0,2-2,-3 3,1 0,-1-1,1 1,-1 0,0-1,0 1,1 0,-1-1,0 1,0-1,-1 1,1 0,0-1,0 1,-1-1,1 1,0 0,-1 0,-1-3,0 0,0 1,-1 0,1 0,-1 0,0 0,1 0,-2 1,1-1,0 1,0 0,-1 0,1 0,-1 0,0 1,1 0,-1-1,-4 0,-79-20,63 15,0 0,-1 2,1 0,-30 0,-60-7,77 7,-50-1,27 4,38 0,-1 2,1 0,-1 1,-41 8,58-7,-1 1,1 0,0 0,0 0,0 1,0 0,1 0,-1 1,1 0,0 0,-5 6,9-9,-1-1,1 1,0 0,-1-1,1 1,0 0,0-1,0 1,1 0,-1 0,0 0,1 0,-1 0,1 0,0 0,-1 0,1 0,0 0,0 0,0 0,1 0,-1 0,0 0,1 0,0 0,-1 0,1 0,0 0,0 0,0 0,0-1,0 1,0 0,1-1,-1 1,0-1,1 1,-1-1,1 0,0 1,2 0,9 5,1 0,0-1,1-1,-1 0,1-1,30 4,33 10,-78-18,1 0,-1 0,1 0,-1 0,1 0,0 0,-1 0,1 0,-1 0,1 0,-1 1,1-1,-1 0,1 0,-1 1,0-1,1 0,-1 1,1-1,-1 1,0-1,1 0,-1 1,0-1,1 1,-1-1,0 1,0-1,1 1,-1-1,0 1,0-1,0 1,0-1,0 1,0-1,0 1,0-1,0 2,-17 15,-8 8,25-24,-1 0,1 0,-1 0,1 0,0 0,0 0,0 0,0 1,0-1,0 0,0 0,0 0,0 0,0 0,0 0,1 0,-1 0,0 0,1 0,-1 0,1 0,-1 0,1 0,0 0,-1 0,1 0,0-1,0 1,-1 0,1 0,0-1,1 1,6 6,0-2,1 1,0-1,0 0,0-1,0 0,1-1,-1 0,1 0,0-1,17 2,12-2,67-2,-49-2,-53 2,0 0,0-1,0 1,0-1,0 0,0 0,0 0,0 0,0-1,-1 0,8-4,-11 6,1-1,0 1,-1-1,1 0,-1 1,1-1,-1 0,1 1,-1-1,1 0,-1 0,1 1,-1-1,0 0,0 0,1 0,-1 1,0-1,0 0,0 0,0 0,0 0,0-1,-1 1,1-1,-1 0,0 0,0 1,0-1,0 0,0 1,0-1,-1 1,1-1,0 1,-1 0,1-1,-4-1,-11-8,-1 0,-1 1,0 0,0 2,-1 0,0 1,-22-5,-14 0,-72-6,56 8,30 4,-66-2,80 8,1 1,0 1,-47 10,15 1,-86 9,20 1,93-16,0-1,0-1,-39 1,-605-7,627-1,-57-10,30 2,-273-34,262 31,-125-3,51 5,-5-1,-195 13,934-1,-547-1,53-10,-52 6,51-3,-65 8,35-2,-47 2,0 0,0-1,0 1,0-1,0 1,0-1,0 0,0 0,-1 1,1-1,0-1,0 1,-1 0,1 0,-1-1,1 1,-1-1,1 1,0-3,-2 4,1-1,-1 1,0-1,0 1,0-1,0 0,0 1,0-1,0 1,0-1,0 1,0-1,0 1,0-1,-1 1,1-1,0 1,0-1,0 1,-1-1,1 1,0-1,-1 1,1-1,0 1,-1 0,1-1,-1 1,1-1,-1 1,1 0,0 0,-1-1,1 1,-1 0,1 0,-1 0,1-1,-1 1,0 0,0 0,-29-6,25 5,-83-18,54 10,0 2,0 2,-50-3,44 7,-47-9,47 4,-50 0,36 3,-103-18,102 11,-98-4,10 2,-7 1,78 10,-69 3,140-2,-1 0,1 0,0 0,0 0,-1 0,1 0,0 1,0-1,-1 0,1 1,0-1,0 1,0-1,0 1,0-1,-1 1,1 0,0-1,0 1,1 0,-2 1,2-1,0 0,0-1,0 1,1 0,-1 0,0 0,1-1,-1 1,1 0,-1-1,1 1,-1 0,1-1,-1 1,1 0,0-1,-1 1,1-1,0 1,-1-1,1 0,1 1,53 26,-21-17,1-1,0-2,40 3,-55-7,149 20,-96-16,-48-6,0 2,0 1,40 11,-39-8,2-1,48 5,15 2,-59-8,1-2,0-1,39-3,-49 0,-54 1,0-2,0-2,1-1,-53-15,40 10,-2 1,-63-5,81 12,-112-24,99 17,1 2,-81-5,82 10,-46-7,46 3,-48 0,66 6,15-1,0 0,0 1,-1 0,1 0,0 0,0 0,0 1,0 0,0 0,0 0,0 1,0 0,1 0,-10 5,14-7,0 0,-1 1,1-1,-1 1,1-1,0 0,0 1,-1-1,1 1,0-1,0 1,-1-1,1 1,0-1,0 1,0-1,0 1,0-1,0 1,0-1,0 1,0 0,0-1,0 1,0-1,0 1,0-1,1 1,-1-1,0 1,0-1,1 0,-1 1,0-1,0 1,1 0,23 14,28 1,150 13,-128-21,74 18,-98-17,85 6,-24-4,-61-6,53-3,-61-2,0 2,54 8,-71-5,0-2,1 0,-1-2,38-3,-62 2,0 0,0 0,0 0,-1 0,1 0,0 0,0 0,-1 0,1 0,0 0,0-1,-1 1,1 0,0 0,-1-1,1 1,0 0,-1-1,1 1,0-1,-1 1,1-1,-1 1,1-1,-1 0,1 0,-14-11,-33-7,-4 4,-22-8,-100-19,89 19,66 17,0 1,0 0,-1 2,-19-3,-10 1,-57-14,66 11,0 1,-67-2,29 8,-108 4,180-3,0 0,1 1,-1 0,1 0,-1 0,1 0,-1 0,1 1,0-1,0 1,-1 0,1 0,1 0,-1 1,0-1,-4 5,7-6,-1 1,0-1,0 1,1-1,-1 1,1-1,-1 1,1 0,0-1,0 1,-1-1,1 1,0 0,1-1,-1 1,0 0,0-1,1 1,-1-1,1 1,-1 0,1-1,0 1,-1-1,1 0,0 1,0-1,0 0,0 1,0-1,1 0,-1 0,0 0,0 0,1 0,-1 0,3 1,25 19,0-1,49 25,53 15,3-7,1-5,154 33,-107-37,18 3,-15-9,22 5,-157-31,92 8,-158-23,0-2,0 0,-21-11,-55-17,20 17,-77-30,-16-2,-13 1,78 24,-199-55,56 23,66 17,140 24,32 11,-1 0,1 1,0 0,-1 0,1 0,-1 1,0 0,1 0,-1 0,0 1,-7 0,13 0,0 1,0-1,0 0,0 1,0-1,1 1,-1-1,0 0,0 1,0-1,0 1,1-1,-1 0,0 1,0-1,1 0,-1 1,0-1,1 0,-1 1,0-1,1 0,-1 0,1 0,-1 1,0-1,1 0,-1 0,1 0,-1 0,1 0,-1 0,0 0,1 0,-1 0,1 0,0 0,22 10,255 66,-240-67,-8-2,220 44,-221-46,42 13,-47-11,-1-1,49 5,100 12,-117-13,107 4,-16-2,8 0,-110-10,-31-1,0 0,0-1,0 0,0-1,1 0,23-7,-36 8,0 0,1 0,-1-1,0 1,0 0,0-1,-1 1,1-1,0 1,0-1,0 0,0 1,0-1,-1 0,1 1,0-1,0 0,-1 0,1 0,-1 0,1 0,-1 0,1 0,-1 0,1 0,-1 0,0 0,0 0,0 0,1 0,-1 0,0 0,0 0,0 0,-1 0,1 0,0 0,0 0,0 0,-1 0,1 0,-1 0,1 0,-1 0,1 0,-1 0,1 0,-1 0,0 1,1-1,-1 0,0 0,-1 0,-3-4,-1 0,1 0,-1 1,0 0,0 0,-10-5,-167-54,139 46,-52-12,-14-4,-511-154,598 181,-230-53,199 48,44 8,-1 1,1 0,0 1,-1 0,0 0,1 1,-1 1,-17 3,28-4,-1 0,1 0,-1 0,1 0,0 0,-1 0,1 0,-1 0,1 0,-1 0,1 1,0-1,-1 0,1 0,0 1,-1-1,1 0,-1 0,1 1,0-1,0 0,-1 1,1-1,0 1,0-1,-1 0,1 1,0-1,0 1,0-1,0 1,0-1,-1 0,1 1,0-1,0 1,0 0,15 12,33 8,-44-19,63 20,136 28,-87-24,31 1,15 5,-78-14,102 8,-43-8,126 10,-46-7,17 2,259-8,-445-15,65-1,136 16,-147-6,146-7,-128-3,-126 1,0 0,0 0,0 0,0 0,0 0,0 0,0 0,0-1,0 1,0 0,0 0,0 0,-1 0,1 0,0 0,0 0,0 0,0 0,0 0,0 0,0 0,0-1,0 1,0 0,0 0,0 0,0 0,0 0,0 0,0 0,1 0,-1 0,0 0,0 0,0 0,0-1,0 1,0 0,0 0,0 0,0 0,0 0,0 0,0 0,0 0,0 0,0 0,0 0,0 0,1 0,-1 0,0 0,0 0,0 0,0 0,0 0,-11-7,-16-6,-109-36,-230-49,167 48,137 37,20 4,0 1,-78-4,69 11,-1-3,-52-9,90 10,0 0,-1 2,1-1,-1 2,1 0,-1 0,1 2,-24 4,36-6,1 1,0-1,-1 1,1-1,-1 1,1-1,0 1,0 0,-1 0,1 0,0-1,0 1,0 0,0 1,0-1,0 0,0 0,1 0,-1 0,0 1,0-1,1 0,-1 1,1-1,0 1,-1-1,1 0,0 1,0-1,0 1,-1-1,2 1,-1-1,0 1,0-1,0 0,1 1,-1-1,1 1,-1-1,1 0,-1 1,1-1,0 0,0 0,0 1,1 0,2 4,1 0,0-1,0 0,1 0,-1 0,1-1,0 0,7 4,26 12,2-1,0-3,80 21,-74-25,75 15,-11-4,7 1,82 0,-67-1,-98-15,1-2,67 4,-70-8,48 8,-50-5,51 1,-138-9,-75-13,68 11,49 4,43 1,80 3,170-6,-260 0,1-1,-1-1,0-1,25-12,-3 3,-24 9,1 1,-1-2,-1 0,21-10,-35 15,0 1,1 0,-1 0,0-1,0 1,1-1,-1 0,0 1,-1-1,1 0,0 0,-1 0,1-1,-1 1,1 0,-1-1,0 1,0 0,0-1,0 1,-1-1,1 0,-1 1,1-1,-1 1,0-1,0 0,0 1,-1-5,-1 3,0 1,0-1,0 1,-1 0,1-1,-1 1,0 0,0 1,0-1,0 0,0 1,0 0,-1 0,1 0,-7-3,-58-20,5 7,14 5,-89-35,116 39,-1 1,-42-9,41 12,0-1,-36-15,21 7,0 2,-1 1,-81-11,-1 0,69 8,-40-9,85 21,0 1,0 0,0 1,0 0,0 0,0 1,0 0,-14 3,22-4,-1 0,1 0,-1 0,0 0,1 1,-1-1,0 0,1 0,-1 1,1-1,-1 0,1 0,-1 1,1-1,-1 1,1-1,-1 1,1-1,-1 1,1-1,0 1,-1-1,1 1,0-1,-1 1,1-1,0 1,0 0,0-1,-1 1,1 0,0-1,0 2,15 16,32 9,-3-7,18 7,73 21,245 56,41-24,-391-75,337 48,-278-45,-40-5,-1 2,62 16,-80-15,-1-1,1-2,34 0,-27-1,53 8,-10-2,-61-6,-23-2,-30-1,1-2,-1-2,0-1,1-1,0-2,-33-13,26 8,-1 3,-55-8,-14-4,-39-4,-7-2,113 21,0 1,-1 3,0 2,-78 5,16 0,101-3,1 1,0-1,0 1,0-1,0 1,0 0,0 1,0-1,0 1,1 0,-1 0,-6 4,9-5,0 0,1-1,-1 1,0 0,1 0,-1-1,0 1,1 0,-1 0,1 0,-1 0,1 0,0 0,-1 0,1 0,0 0,0 0,0 0,0 0,0 0,0 2,0-2,1 1,0 0,0 0,0 0,0-1,0 1,0 0,0-1,0 1,1-1,-1 1,1-1,-1 0,1 1,2 0,12 8,-1 0,2-2,-1 0,1-1,23 7,93 18,-126-30,170 45,-142-38,42 4,-49-9,0 1,-1 1,35 13,-22-6,2-1,-1-2,54 5,-10-2,-51-9,0-1,61-3,26 2,-92 2,54 15,-58-12,1-1,49 5,85 4,-130-11</inkml:trace>
+</inkml:ink>
+</file>
+
+<file path=ppt/ink/ink14.xml><?xml version="1.0" encoding="utf-8"?>
+<inkml:ink xmlns:inkml="http://www.w3.org/2003/InkML">
+  <inkml:definitions>
+    <inkml:context xml:id="ctx0">
+      <inkml:inkSource xml:id="inkSrc0">
+        <inkml:traceFormat>
+          <inkml:channel name="X" type="integer" min="-2.14748E9" max="2.14748E9" units="cm"/>
+          <inkml:channel name="Y" type="integer" min="-2.14748E9" max="2.14748E9" units="cm"/>
+        </inkml:traceFormat>
+        <inkml:channelProperties>
+          <inkml:channelProperty channel="X" name="resolution" value="1000" units="1/cm"/>
+          <inkml:channelProperty channel="Y" name="resolution" value="1000" units="1/cm"/>
+        </inkml:channelProperties>
+      </inkml:inkSource>
+      <inkml:timestamp xml:id="ts0" timeString="2026-06-13T23:27:46.471"/>
+    </inkml:context>
+    <inkml:brush xml:id="br0">
+      <inkml:brushProperty name="width" value="0.3" units="cm"/>
+      <inkml:brushProperty name="height" value="0.6" units="cm"/>
+      <inkml:brushProperty name="color" value="#FFFC00"/>
+      <inkml:brushProperty name="tip" value="rectangle"/>
+      <inkml:brushProperty name="rasterOp" value="maskPen"/>
+      <inkml:brushProperty name="ignorePressure" value="1"/>
+    </inkml:brush>
+  </inkml:definitions>
+  <inkml:trace contextRef="#ctx0" brushRef="#br0">971 78,'-71'-22,"3"15,-174-12,213 20,-3 0,0-1,-1-2,1-1,-34-8,27 5,-1 1,0 2,0 1,-52 6,-2-1,73-3</inkml:trace>
+</inkml:ink>
+</file>
+
+<file path=ppt/ink/ink2.xml><?xml version="1.0" encoding="utf-8"?>
+<inkml:ink xmlns:inkml="http://www.w3.org/2003/InkML">
+  <inkml:definitions>
+    <inkml:context xml:id="ctx0">
+      <inkml:inkSource xml:id="inkSrc0">
+        <inkml:traceFormat>
+          <inkml:channel name="X" type="integer" min="-2.14748E9" max="2.14748E9" units="cm"/>
+          <inkml:channel name="Y" type="integer" min="-2.14748E9" max="2.14748E9" units="cm"/>
+        </inkml:traceFormat>
+        <inkml:channelProperties>
+          <inkml:channelProperty channel="X" name="resolution" value="1000" units="1/cm"/>
+          <inkml:channelProperty channel="Y" name="resolution" value="1000" units="1/cm"/>
+        </inkml:channelProperties>
+      </inkml:inkSource>
+      <inkml:timestamp xml:id="ts0" timeString="2026-06-13T23:14:07.837"/>
+    </inkml:context>
+    <inkml:brush xml:id="br0">
+      <inkml:brushProperty name="width" value="0.3" units="cm"/>
+      <inkml:brushProperty name="height" value="0.6" units="cm"/>
+      <inkml:brushProperty name="color" value="#00F900"/>
+      <inkml:brushProperty name="tip" value="rectangle"/>
+      <inkml:brushProperty name="rasterOp" value="maskPen"/>
+      <inkml:brushProperty name="ignorePressure" value="1"/>
+    </inkml:brush>
+  </inkml:definitions>
+  <inkml:trace contextRef="#ctx0" brushRef="#br0">0 0,'879'0,"-860"1,-1 1,31 7,31 3,19 1,-18-2,-76-10,-10-1,-3 0</inkml:trace>
+</inkml:ink>
+</file>
+
+<file path=ppt/ink/ink3.xml><?xml version="1.0" encoding="utf-8"?>
+<inkml:ink xmlns:inkml="http://www.w3.org/2003/InkML">
+  <inkml:definitions>
+    <inkml:context xml:id="ctx0">
+      <inkml:inkSource xml:id="inkSrc0">
+        <inkml:traceFormat>
+          <inkml:channel name="X" type="integer" min="-2.14748E9" max="2.14748E9" units="cm"/>
+          <inkml:channel name="Y" type="integer" min="-2.14748E9" max="2.14748E9" units="cm"/>
+          <inkml:channel name="F" type="integer" max="32767" units="dev"/>
+        </inkml:traceFormat>
+        <inkml:channelProperties>
+          <inkml:channelProperty channel="X" name="resolution" value="1000" units="1/cm"/>
+          <inkml:channelProperty channel="Y" name="resolution" value="1000" units="1/cm"/>
+          <inkml:channelProperty channel="F" name="resolution" value="0" units="1/dev"/>
+        </inkml:channelProperties>
+      </inkml:inkSource>
+      <inkml:timestamp xml:id="ts0" timeString="2026-06-13T23:14:10.350"/>
+    </inkml:context>
+    <inkml:brush xml:id="br0">
+      <inkml:brushProperty name="width" value="0.3" units="cm"/>
+      <inkml:brushProperty name="height" value="0.6" units="cm"/>
+      <inkml:brushProperty name="color" value="#00F900"/>
+      <inkml:brushProperty name="tip" value="rectangle"/>
+      <inkml:brushProperty name="rasterOp" value="maskPen"/>
+      <inkml:brushProperty name="ignorePressure" value="1"/>
+    </inkml:brush>
+  </inkml:definitions>
+  <inkml:trace contextRef="#ctx0" brushRef="#br0">0 0 0,'10089'24'0</inkml:trace>
+</inkml:ink>
+</file>
+
+<file path=ppt/ink/ink4.xml><?xml version="1.0" encoding="utf-8"?>
+<inkml:ink xmlns:inkml="http://www.w3.org/2003/InkML">
+  <inkml:definitions>
+    <inkml:context xml:id="ctx0">
+      <inkml:inkSource xml:id="inkSrc0">
+        <inkml:traceFormat>
+          <inkml:channel name="X" type="integer" min="-2.14748E9" max="2.14748E9" units="cm"/>
+          <inkml:channel name="Y" type="integer" min="-2.14748E9" max="2.14748E9" units="cm"/>
+        </inkml:traceFormat>
+        <inkml:channelProperties>
+          <inkml:channelProperty channel="X" name="resolution" value="1000" units="1/cm"/>
+          <inkml:channelProperty channel="Y" name="resolution" value="1000" units="1/cm"/>
+        </inkml:channelProperties>
+      </inkml:inkSource>
+      <inkml:timestamp xml:id="ts0" timeString="2026-06-13T23:14:12.773"/>
+    </inkml:context>
+    <inkml:brush xml:id="br0">
+      <inkml:brushProperty name="width" value="0.3" units="cm"/>
+      <inkml:brushProperty name="height" value="0.6" units="cm"/>
+      <inkml:brushProperty name="color" value="#00F900"/>
+      <inkml:brushProperty name="tip" value="rectangle"/>
+      <inkml:brushProperty name="rasterOp" value="maskPen"/>
+      <inkml:brushProperty name="ignorePressure" value="1"/>
+    </inkml:brush>
+  </inkml:definitions>
+  <inkml:trace contextRef="#ctx0" brushRef="#br0">0 0,'20'1,"0"2,35 7,-8 0,6 0,-29-5,0-1,42 2,92-9,131 5,-197 9,30 2,-50-13,11 1,87 12,-89-6,129-4,-124-4,103 10,89 15,-129-14,-114-7,469 23,-290-14,-13-1,116 3,221-2,-328-14,-88 1,13-1,157 19,-163-7,178-8,-139-5,6 16,4-1,2576-13,-2720 0,51-10,-51 5,55-1,64-4,3-1,-42 15,151-6,-194-9,-50 8,0 0,32 0,-33 2,0 0,25-6,37-3,-13 0,-18 1,-32 8</inkml:trace>
+</inkml:ink>
+</file>
+
+<file path=ppt/ink/ink5.xml><?xml version="1.0" encoding="utf-8"?>
+<inkml:ink xmlns:inkml="http://www.w3.org/2003/InkML">
+  <inkml:definitions>
+    <inkml:context xml:id="ctx0">
+      <inkml:inkSource xml:id="inkSrc0">
+        <inkml:traceFormat>
+          <inkml:channel name="X" type="integer" min="-2.14748E9" max="2.14748E9" units="cm"/>
+          <inkml:channel name="Y" type="integer" min="-2.14748E9" max="2.14748E9" units="cm"/>
+        </inkml:traceFormat>
+        <inkml:channelProperties>
+          <inkml:channelProperty channel="X" name="resolution" value="1000" units="1/cm"/>
+          <inkml:channelProperty channel="Y" name="resolution" value="1000" units="1/cm"/>
+        </inkml:channelProperties>
+      </inkml:inkSource>
+      <inkml:timestamp xml:id="ts0" timeString="2026-06-13T23:14:17.932"/>
+    </inkml:context>
+    <inkml:brush xml:id="br0">
+      <inkml:brushProperty name="width" value="0.3" units="cm"/>
+      <inkml:brushProperty name="height" value="0.6" units="cm"/>
+      <inkml:brushProperty name="color" value="#00F900"/>
+      <inkml:brushProperty name="tip" value="rectangle"/>
+      <inkml:brushProperty name="rasterOp" value="maskPen"/>
+      <inkml:brushProperty name="ignorePressure" value="1"/>
+    </inkml:brush>
+  </inkml:definitions>
+  <inkml:trace contextRef="#ctx0" brushRef="#br0">21570 767,'-67'-1,"10"0,-1 2,-94 14,-37 10,68-11,74-10,-56 12,12 0,-128 7,196-21,-228 4,-25 2,-154 18,266-19,-294 12,67-6,15-2,-682 41,408-33,282 3,-283 14,452-27,-289 6,-55 9,-4 0,236-13,15 1,-2579-13,2665-11,5 0,-682 12,739-12,2-1,-21 15,48 0,-187-19,47-12,241 28,-419-26,374 24,-108-18,104 10,-85-2,84 9,-82-16,83 10,-84-4,88 10,-86-16,89 10,-102-3,89 9,-96-16,98 9,-98-2,117 10,-98-17,94 10,-68-3,2 1,-23-1,101 11,0-3,-52-11,51 7,-91-6,-130-9,112 7,115 11,-18-5,34 6,0 1,-30-1,-86-6,-15-1,118 10,-48-8,-25-1,-9-1,81 6,-56-1,-477 8,542-2,-51-10,50 6,-48-2,-1253 8,8002-1,-6393 12,-8 0,1603-13,-1908 1,-16-1,0 3,-81 12,83-7,-81 1,-1 1,-153 1,19-2,-221 6,44-5,-85 25,372-25,-421 12,280-10,10 1,-9 0,-1 0,-1465-13,1584-11,1-1,157 13,-65 0,0-3,-107-18,133 11,1 3,-113 1,201 4,55-10,-38 5,-1 2,2 3,80 5,-23-1,928-2,-1034 0,-1 0,1-1,0 1,0 0,0 0,0 0,-1 0,1 0,0 0,0 0,0 0,0 0,0 0,-1 0,1 1,0-1,0 0,0 1,-1-1,1 1,0-1,0 0,-1 1,1 0,0-1,0 2,-19 10,-39 9,-92 3,119-20,0 0,0-2,-44-3,43 0,1 1,-1 2,-38 6,-80 11,51-9,-8-1,-179-7,133-4,-9 14,-3 1,75-12,-103 15,171-14,-27 4,46-6,0 1,0-1,0 1,0 0,0 0,0-1,0 1,0 1,0-1,0 0,1 0,-1 1,1-1,-1 1,1-1,-1 1,-1 2,3-3,0 0,0 0,0 0,0-1,0 1,0 0,0 0,0 0,0 0,0 0,1 0,-1-1,0 1,1 0,-1 0,0 0,1-1,-1 1,1 0,-1 0,1-1,0 1,-1 0,1-1,0 1,-1-1,1 1,0-1,0 1,-1-1,1 0,0 1,1-1,30 13,-10-8,1-2,0 0,0-1,0-2,29-2,-26 1,-1 0,1 2,49 8,-14 0,0-2,0-3,106-7,-44 0,219 27,11 1,-285-25,97 13,-46-4,157-8,-197-2,-210 3,-147-4,70-22,121 14,-101-4,-79 1,190 4,-259-17,270 23,1-3,-90-20,88 12,1 4,-85-2,104 10,-62-11,63 6,98 10,62-4,-24-1,1001 2,-1085 0,-3 0,-1 1,1-1,0 0,0 0,0-1,0 1,0-1,0 1,-1-1,1 0,0 0,-1 0,1 0,3-3,-6 4,0-1,0 1,-1-1,1 0,0 1,0-1,-1 1,1-1,0 1,-1-1,1 1,-1-1,1 1,-1 0,1-1,-1 1,1 0,-1-1,1 1,-1 0,1-1,-1 1,0 0,1 0,-1 0,1 0,-1 0,0 0,1 0,-1 0,0 0,1 0,-1 0,1 0,-2 0,-26-4,-122 2,92 3,-1-3,-60-9,-113-14,135 16,-165 4,152 7,-110-13,-93-18,-31 25,43 3,193-10,-42-2,-104 0,120 2,-185 9,146 5,64-3,189-30,-41 22,0 1,1 3,-1 1,1 2,52 5,6-2,70-4,179 5,-152 19,-113-10,97 1,64 2,-134-5,-10 0,69 2,689-12,-840 1,0 0,33 9,31 2,-33-8,90 19,-17-2,-60-11,-28-4,51 1,-31-3,87 16,-87-10,90 4,-101-13,263 12,712 44,-401-43,263 32,-352-20,120-2,-517-18,717 21,-398-15,-11 0,320 1,489-1,-755-15,2396 3,-2587-12,3 0,-285 12,454-14,156 2,-386 15,-101-15,-3-1,838 14,-949 1,51 8,-50-5,48 3,635-9,-684-1,52-8,-52 5,50-3,-56 9,42-3,-61 2,-1-1,1 1,-1-1,1 1,-1-1,0 0,1 0,-1 0,0 0,0-1,0 1,1-1,-1 1,-1-1,1 1,0-1,0 0,-1 0,1 0,2-4,-4 5,0-1,0 1,0-1,1 1,-1-1,-1 1,1 0,0-1,0 1,0-1,-1 1,1-1,-1 1,1 0,-1-1,1 1,-1 0,0 0,0-1,0 1,0 0,1 0,-1 0,-1 0,1 0,0 0,0 0,0 1,0-1,-1 0,1 1,0-1,-1 1,1-1,-3 0,-54-18,55 18,-170-47,-39-10,-194-12,271 50,-515-65,229 42,118 15,-737-59,530 50,-506-13,-184-1,495 12,-1103-62,1575 84,-237-12,-56-8,59 3,132-1,198 17,-148 0,229 16,-58-11,40 4,65 8,-1 0,1-1,0 0,-17-6,26 8,0 0,0 0,0 0,0 0,0 0,0 0,-1 0,1 0,0 0,0 0,0 0,0 0,0-1,0 1,0 0,0 0,0 0,0 0,0 0,-1 0,1 0,0-1,0 1,0 0,0 0,0 0,0 0,0 0,0 0,0-1,0 1,0 0,0 0,0 0,0 0,0 0,1 0,-1-1,0 1,0 0,0 0,0 0,0 0,0 0,0 0,0 0,0 0,0-1,0 1,1 0,-1 0,0 0,0 0,0 0,0 0,0 0,1 0,11-8,17-3,8 5,1 2,-1 1,1 2,50 4,0 0,72-5,149 5,-186 8,52 2,242 12,-92-2,39 13,-20-1,220 21,29 2,350 17,-430-45,-62-6,555 42,-773-56,172 2,1057-13,-1438 3,1 1,-1 1,29 8,-47-11,-122 2,-266-1,-246-5,411-8,-97-3,-2068 15,1590 36,33-1,65 13,215-7,-104 4,256-27,-275 14,289-33,360-1,52 1,129 15,35 10,-147-16,180-7,-134-5,935 3,-890 13,-5-1,-29-14,136 4,-201 9,46 2,140-14,-353 1,-64 1,-228-28,-123-20,233 24,-59-1,5 10,129 4,8 1,-220-5,-397 15,714 5,60-6,-1 0,1 1,-1-1,1 0,-1 0,1 1,-1-1,1 1,-1 0,1-1,0 1,-1 0,1 0,0 0,0 0,-1 0,1 0,0 0,0 0,0 1,0-1,1 0,-1 0,0 1,0-1,1 1,-1-1,1 1,-1-1,1 1,0-1,0 1,-1-1,1 1,1 2,-1-3,1 1,0-1,0 1,0-1,0 1,0-1,0 0,1 1,-1-1,0 0,1 0,-1 0,1 0,-1 0,1 0,0 0,-1-1,1 1,0-1,1 1,45 11,-35-10,29 6,83 2,-3 0,-104-7,480 51,172-3,-327-21,347 7,-567-32,668 36,1861 8,-1938-35,-349-4,375 9,746 10,1345-30,-2289-46,-382 26,33 2,-182 18,25-4,-35 5,0 0,0 0,-1 0,1 0,0-1,0 1,0 0,0 0,0-1,0 1,0-1,0 1,-1 0,1-1,0 0,0 1,-1-1,1 1,0-1,-1 0,1 0,0 1,-1-1,1-1,-1 1,-1 0,1 0,-1 1,1-1,-1 0,0 1,1-1,-1 1,0-1,0 1,1-1,-1 1,0-1,0 1,0-1,1 1,-1 0,0 0,0-1,0 1,0 0,0 0,-1 0,-29-3,21 2,-34-6,-1 0,-79-3,-178 13,-441-5,544-10,-93-1,-754 14,761 14,153-6,-233 35,265-30,-138 25,65-6,119-21,52-12,1 0,-1 0,1 1,-1-1,1 0,-1 1,1-1,0 1,-1-1,1 1,0 0,-1 0,1-1,0 1,-2 2,16 5,42-1,998-5,-505-5,-284-9,3 0,-172 8,166-29,-135 16,238 0,-336 15,0 0,37-10,-22 5,-42 7,0 0,1 0,-1 0,0-1,0 1,1 0,-1-1,0 1,1 0,-1-1,0 1,0-1,0 0,0 1,0-1,0 0,0 0,0 0,0 0,0 0,0 0,1-1,-2 1,0 0,0 0,-1 0,1 0,0 0,0 0,-1 0,1 0,0 0,-1 1,1-1,-1 0,1 0,-1 0,0 1,1-1,-1 0,0 0,1 1,-1-1,0 1,-1-1,-4-4,-1 1,0-1,0 2,0-1,-1 1,-8-3,-464-79,309 56,-73-8,-14 5,-136-8,-150 4,-75 1,-810 36,1533-2,319 16,-182-1,-44-4,-32 5,525 28,-332-32,-4 1,1225-13,-1605 0,-48-9,-17-2,36 8,-71-16,72 10,-79-4,-131-10,-42-1,-360 27,648-2,0 1,0 2,1-1,-1 2,0 0,1 2,0-1,0 2,1 1,-1 0,-15 10,30-16,1-1,-1 0,0 1,0-1,1 1,-1 0,1-1,-1 1,1 0,0 0,-1 0,1 0,0 0,1 0,-1 0,0 1,0 3,1-4,0 0,0-1,0 1,1 0,-1-1,1 1,-1 0,1-1,0 1,-1-1,1 1,0-1,0 1,0-1,0 0,1 0,-1 1,2 1,3 1,0 0,1 0,-1 0,1-1,0 0,0 0,0-1,0 1,10 0,58 11,-15-2,0-2,89 2,-90-12,83 13,-33-3,195-8,-144-5,37 6,217-6,-235-23,-43 4,-105 17,52-15,17-3,-46 12,63-20,-42 10,-19 4,-2-2,67-33,-117 49,0 1,0-1,-1 0,1-1,-1 1,1-1,-1 1,0-1,-1 0,1 0,-1 0,1-1,-1 1,-1 0,1-1,-1 0,1 1,0-8,3-5,0 1</inkml:trace>
+</inkml:ink>
+</file>
+
+<file path=ppt/ink/ink6.xml><?xml version="1.0" encoding="utf-8"?>
+<inkml:ink xmlns:inkml="http://www.w3.org/2003/InkML">
+  <inkml:definitions>
+    <inkml:context xml:id="ctx0">
+      <inkml:inkSource xml:id="inkSrc0">
+        <inkml:traceFormat>
+          <inkml:channel name="X" type="integer" min="-2.14748E9" max="2.14748E9" units="cm"/>
+          <inkml:channel name="Y" type="integer" min="-2.14748E9" max="2.14748E9" units="cm"/>
+        </inkml:traceFormat>
+        <inkml:channelProperties>
+          <inkml:channelProperty channel="X" name="resolution" value="1000" units="1/cm"/>
+          <inkml:channelProperty channel="Y" name="resolution" value="1000" units="1/cm"/>
+        </inkml:channelProperties>
+      </inkml:inkSource>
+      <inkml:timestamp xml:id="ts0" timeString="2026-06-13T23:14:19.296"/>
+    </inkml:context>
+    <inkml:brush xml:id="br0">
+      <inkml:brushProperty name="width" value="0.3" units="cm"/>
+      <inkml:brushProperty name="height" value="0.6" units="cm"/>
+      <inkml:brushProperty name="color" value="#00F900"/>
+      <inkml:brushProperty name="tip" value="rectangle"/>
+      <inkml:brushProperty name="rasterOp" value="maskPen"/>
+      <inkml:brushProperty name="ignorePressure" value="1"/>
+    </inkml:brush>
+  </inkml:definitions>
+  <inkml:trace contextRef="#ctx0" brushRef="#br0">320 0,'-10'1,"0"0,1 1,-1 0,-12 4,-34 6,-14-13,54-1,0 1,0 1,0 1,0 0,-21 6,36-7,0 0,1 0,-1 0,0 0,1 0,-1 0,0 1,1-1,-1 0,1 0,-1 1,0-1,1 0,-1 1,1-1,-1 1,1-1,-1 1,1-1,-1 1,1-1,0 1,-1-1,1 1,0 0,-1-1,1 1,0 1,12 12,36 10,-41-21,16 7,0-1,1-2,0 0,1-1,27 2,125 3,-71-7,147 21,-162-16,73 4,500-14,-753-20,-223-7,213 19,-104-4,131 12,-125-16,112 10,85 7,0 0,0 0,0 0,0 0,0 0,0 1,0-1,0 0,0 0,0 0,0 0,0 0,1 0,-1 0,0 0,0 0,0 0,0 0,-1 0,1 1,0-1,0 0,0 0,0 0,0 0,0 0,0 0,0 0,0 0,0 0,0 0,0 0,0 0,0 0,0 0,0 0,0 1,0-1,0 0,0 0,0 0,0 0,-1 0,1 0,0 0,0 0,0 0,0 0,0 0,0 0,0 0,0 0,0 0,0 0,10 6,18 5,66 3,135 3,98-17,-133-2,-74 4,130-5,-228-2,-22 5,1 0,-1 0,0-1,0 1,0 0,0 0,0 0,0 0,1 0,-1 0,0-1,0 1,0 0,0 0,0 0,0 0,0 0,0-1,0 1,0 0,0 0,0 0,0 0,0-1,0 1,0 0,0 0,0 0,0 0,0-1,0 1,0 0,0 0,0 0,0 0,0 0,-1-1,1 1,0 0,0 0,0 0,0 0,0 0,0 0,0-1,-1 1,1 0,0 0,0 0,0 0,0 0,0 0,-1 0,-2-2,-1 1,0-1,0 1,1 0,-1 0,0 0,0 0,-5 1,-27-4,-66-16,70 12,0 2,-62-5,35 10,-85-12,102 7,1 2,-1 2,-78 5,119-3,-1 0,1 0,-1 0,1 0,-1 0,0 1,1-1,-1 0,1 1,-1-1,1 1,0 0,-1-1,1 1,-3 2,5-3,-1 1,0-1,0 1,1-1,-1 1,0-1,1 1,-1-1,1 1,-1-1,1 1,-1-1,1 1,-1-1,1 0,-1 1,1-1,-1 0,1 1,-1-1,1 0,0 0,-1 0,2 1,52 15,-30-11,14 5,1-2,0-1,65 2,-62-7,44 7,32 2,92 1,35 1,-181-13,543 13,-19 21,65 5,174 33,-316-38,171 15,47 4,-397-32,729 20,-699-30,189 1,-180-10,408-5,-242-33,-52 2,268-22,-483 38,-40 5,52-15,-242 25,75 2,13 0,-90-8,-23 4</inkml:trace>
+</inkml:ink>
+</file>
+
+<file path=ppt/ink/ink7.xml><?xml version="1.0" encoding="utf-8"?>
+<inkml:ink xmlns:inkml="http://www.w3.org/2003/InkML">
+  <inkml:definitions>
+    <inkml:context xml:id="ctx0">
+      <inkml:inkSource xml:id="inkSrc0">
+        <inkml:traceFormat>
+          <inkml:channel name="X" type="integer" min="-2.14748E9" max="2.14748E9" units="cm"/>
+          <inkml:channel name="Y" type="integer" min="-2.14748E9" max="2.14748E9" units="cm"/>
+        </inkml:traceFormat>
+        <inkml:channelProperties>
+          <inkml:channelProperty channel="X" name="resolution" value="1000" units="1/cm"/>
+          <inkml:channelProperty channel="Y" name="resolution" value="1000" units="1/cm"/>
+        </inkml:channelProperties>
+      </inkml:inkSource>
+      <inkml:timestamp xml:id="ts0" timeString="2026-06-13T23:14:20.121"/>
+    </inkml:context>
+    <inkml:brush xml:id="br0">
+      <inkml:brushProperty name="width" value="0.3" units="cm"/>
+      <inkml:brushProperty name="height" value="0.6" units="cm"/>
+      <inkml:brushProperty name="color" value="#00F900"/>
+      <inkml:brushProperty name="tip" value="rectangle"/>
+      <inkml:brushProperty name="rasterOp" value="maskPen"/>
+      <inkml:brushProperty name="ignorePressure" value="1"/>
+    </inkml:brush>
+  </inkml:definitions>
+  <inkml:trace contextRef="#ctx0" brushRef="#br0">1060 1,'-34'0,"0"1,0 2,0 1,1 1,-51 16,63-15,-1-1,-27 2,-19 4,33-5,0-2,0-2,0-1,-43-4,29 0,-55 5,85 1,0 1,1 1,-27 9,-22 7,51-18,-1 2,-30 12,45-16,0 0,0 0,0 0,0 0,0 0,0 1,0-1,1 1,-1-1,0 1,1 0,-1 0,1 0,-1 2,1-3,1 0,0 0,0 1,0-1,0 0,0 0,0 0,1 0,-1 1,0-1,1 0,-1 0,1 0,-1 0,1 0,-1 0,1 0,0 0,-1 0,1 0,0 0,0 0,0 0,0-1,0 1,0 0,0-1,0 1,2 0,12 8,1-2,0 1,0-2,1 0,0-2,0 1,23 1,11 5,-220-48,152 32</inkml:trace>
+</inkml:ink>
+</file>
+
+<file path=ppt/ink/ink8.xml><?xml version="1.0" encoding="utf-8"?>
+<inkml:ink xmlns:inkml="http://www.w3.org/2003/InkML">
+  <inkml:definitions>
+    <inkml:context xml:id="ctx0">
+      <inkml:inkSource xml:id="inkSrc0">
+        <inkml:traceFormat>
+          <inkml:channel name="X" type="integer" min="-2.14748E9" max="2.14748E9" units="cm"/>
+          <inkml:channel name="Y" type="integer" min="-2.14748E9" max="2.14748E9" units="cm"/>
+        </inkml:traceFormat>
+        <inkml:channelProperties>
+          <inkml:channelProperty channel="X" name="resolution" value="1000" units="1/cm"/>
+          <inkml:channelProperty channel="Y" name="resolution" value="1000" units="1/cm"/>
+        </inkml:channelProperties>
+      </inkml:inkSource>
+      <inkml:timestamp xml:id="ts0" timeString="2026-06-13T23:18:52.595"/>
+    </inkml:context>
+    <inkml:brush xml:id="br0">
+      <inkml:brushProperty name="width" value="0.3" units="cm"/>
+      <inkml:brushProperty name="height" value="0.6" units="cm"/>
+      <inkml:brushProperty name="color" value="#FFFC00"/>
+      <inkml:brushProperty name="tip" value="rectangle"/>
+      <inkml:brushProperty name="rasterOp" value="maskPen"/>
+      <inkml:brushProperty name="ignorePressure" value="1"/>
+    </inkml:brush>
+  </inkml:definitions>
+  <inkml:trace contextRef="#ctx0" brushRef="#br0">1 1,'0'0</inkml:trace>
+</inkml:ink>
+</file>
+
+<file path=ppt/ink/ink9.xml><?xml version="1.0" encoding="utf-8"?>
+<inkml:ink xmlns:inkml="http://www.w3.org/2003/InkML">
+  <inkml:definitions>
+    <inkml:context xml:id="ctx0">
+      <inkml:inkSource xml:id="inkSrc0">
+        <inkml:traceFormat>
+          <inkml:channel name="X" type="integer" min="-2.14748E9" max="2.14748E9" units="cm"/>
+          <inkml:channel name="Y" type="integer" min="-2.14748E9" max="2.14748E9" units="cm"/>
+        </inkml:traceFormat>
+        <inkml:channelProperties>
+          <inkml:channelProperty channel="X" name="resolution" value="1000" units="1/cm"/>
+          <inkml:channelProperty channel="Y" name="resolution" value="1000" units="1/cm"/>
+        </inkml:channelProperties>
+      </inkml:inkSource>
+      <inkml:timestamp xml:id="ts0" timeString="2026-06-13T23:18:55.777"/>
+    </inkml:context>
+    <inkml:brush xml:id="br0">
+      <inkml:brushProperty name="width" value="0.3" units="cm"/>
+      <inkml:brushProperty name="height" value="0.6" units="cm"/>
+      <inkml:brushProperty name="color" value="#FFFC00"/>
+      <inkml:brushProperty name="tip" value="rectangle"/>
+      <inkml:brushProperty name="rasterOp" value="maskPen"/>
+      <inkml:brushProperty name="ignorePressure" value="1"/>
+    </inkml:brush>
+  </inkml:definitions>
+  <inkml:trace contextRef="#ctx0" brushRef="#br0">0 0,'0'0</inkml:trace>
+</inkml:ink>
 </file>
 
 <file path=ppt/notesMasters/notesMaster1.xml><?xml version="1.0" encoding="utf-8"?>
@@ -401,7 +812,7 @@
           <a:p>
             <a:fld id="{F2D8D46A-B586-417D-BFBD-8C8FE0AAF762}" type="datetimeFigureOut">
               <a:rPr lang="en-US"/>
-              <a:t>6/13/2026</a:t>
+              <a:t>6/15/2026</a:t>
             </a:fld>
             <a:endParaRPr/>
           </a:p>
@@ -1419,7 +1830,7 @@
           <a:p>
             <a:fld id="{F0DFD029-FB74-4578-B929-F66AA97659CA}" type="datetimeFigureOut">
               <a:rPr lang="en-US"/>
-              <a:t>6/13/2026</a:t>
+              <a:t>6/15/2026</a:t>
             </a:fld>
             <a:endParaRPr/>
           </a:p>
@@ -1617,7 +2028,7 @@
           <a:p>
             <a:fld id="{F0DFD029-FB74-4578-B929-F66AA97659CA}" type="datetimeFigureOut">
               <a:rPr lang="en-US"/>
-              <a:t>6/13/2026</a:t>
+              <a:t>6/15/2026</a:t>
             </a:fld>
             <a:endParaRPr/>
           </a:p>
@@ -1825,7 +2236,7 @@
           <a:p>
             <a:fld id="{F0DFD029-FB74-4578-B929-F66AA97659CA}" type="datetimeFigureOut">
               <a:rPr lang="en-US"/>
-              <a:t>6/13/2026</a:t>
+              <a:t>6/15/2026</a:t>
             </a:fld>
             <a:endParaRPr/>
           </a:p>
@@ -2023,7 +2434,7 @@
           <a:p>
             <a:fld id="{F0DFD029-FB74-4578-B929-F66AA97659CA}" type="datetimeFigureOut">
               <a:rPr lang="en-US"/>
-              <a:t>6/13/2026</a:t>
+              <a:t>6/15/2026</a:t>
             </a:fld>
             <a:endParaRPr/>
           </a:p>
@@ -2455,7 +2866,7 @@
           <a:p>
             <a:fld id="{F0DFD029-FB74-4578-B929-F66AA97659CA}" type="datetimeFigureOut">
               <a:rPr lang="en-US"/>
-              <a:t>6/13/2026</a:t>
+              <a:t>6/15/2026</a:t>
             </a:fld>
             <a:endParaRPr/>
           </a:p>
@@ -2759,7 +3170,7 @@
           <a:p>
             <a:fld id="{F0DFD029-FB74-4578-B929-F66AA97659CA}" type="datetimeFigureOut">
               <a:rPr lang="en-US"/>
-              <a:t>6/13/2026</a:t>
+              <a:t>6/15/2026</a:t>
             </a:fld>
             <a:endParaRPr/>
           </a:p>
@@ -3215,7 +3626,7 @@
           <a:p>
             <a:fld id="{F0DFD029-FB74-4578-B929-F66AA97659CA}" type="datetimeFigureOut">
               <a:rPr lang="en-US"/>
-              <a:t>6/13/2026</a:t>
+              <a:t>6/15/2026</a:t>
             </a:fld>
             <a:endParaRPr/>
           </a:p>
@@ -3345,7 +3756,7 @@
           <a:p>
             <a:fld id="{F0DFD029-FB74-4578-B929-F66AA97659CA}" type="datetimeFigureOut">
               <a:rPr lang="en-US"/>
-              <a:t>6/13/2026</a:t>
+              <a:t>6/15/2026</a:t>
             </a:fld>
             <a:endParaRPr/>
           </a:p>
@@ -3452,7 +3863,7 @@
           <a:p>
             <a:fld id="{F0DFD029-FB74-4578-B929-F66AA97659CA}" type="datetimeFigureOut">
               <a:rPr lang="en-US"/>
-              <a:t>6/13/2026</a:t>
+              <a:t>6/15/2026</a:t>
             </a:fld>
             <a:endParaRPr/>
           </a:p>
@@ -3751,7 +4162,7 @@
           <a:p>
             <a:fld id="{F0DFD029-FB74-4578-B929-F66AA97659CA}" type="datetimeFigureOut">
               <a:rPr lang="en-US"/>
-              <a:t>6/13/2026</a:t>
+              <a:t>6/15/2026</a:t>
             </a:fld>
             <a:endParaRPr/>
           </a:p>
@@ -4039,7 +4450,7 @@
           <a:p>
             <a:fld id="{F0DFD029-FB74-4578-B929-F66AA97659CA}" type="datetimeFigureOut">
               <a:rPr lang="en-US"/>
-              <a:t>6/13/2026</a:t>
+              <a:t>6/15/2026</a:t>
             </a:fld>
             <a:endParaRPr/>
           </a:p>
@@ -4662,7 +5073,7 @@
             <a:fld id="{F0DFD029-FB74-4578-B929-F66AA97659CA}" type="datetimeFigureOut">
               <a:rPr lang="en-US"/>
               <a:pPr/>
-              <a:t>6/13/2026</a:t>
+              <a:t>6/15/2026</a:t>
             </a:fld>
             <a:endParaRPr/>
           </a:p>
@@ -5315,7 +5726,7 @@
         <p:cNvPr id="1" name="">
           <a:extLst>
             <a:ext uri="{FF2B5EF4-FFF2-40B4-BE49-F238E27FC236}">
-              <a16:creationId xmlns:a16="http://schemas.microsoft.com/office/drawing/2014/main" id="{5DFBA20C-7563-087C-658C-9299E2531ECA}"/>
+              <a16:creationId xmlns:a16="http://schemas.microsoft.com/office/drawing/2014/main" id="{3CA2E923-41D4-14D2-77BC-F70A91B244B7}"/>
             </a:ext>
           </a:extLst>
         </p:cNvPr>
@@ -5332,10 +5743,10 @@
       </p:grpSpPr>
       <p:sp>
         <p:nvSpPr>
-          <p:cNvPr id="2" name="Title 1">
+          <p:cNvPr id="13" name="Title 12">
             <a:extLst>
               <a:ext uri="{FF2B5EF4-FFF2-40B4-BE49-F238E27FC236}">
-                <a16:creationId xmlns:a16="http://schemas.microsoft.com/office/drawing/2014/main" id="{89D4BC4C-96EA-F45C-8CAC-FBB75059BE6C}"/>
+                <a16:creationId xmlns:a16="http://schemas.microsoft.com/office/drawing/2014/main" id="{6D7031FA-ADEF-5C30-831D-1BF250DADCB9}"/>
               </a:ext>
             </a:extLst>
           </p:cNvPr>
@@ -5343,52 +5754,244 @@
             <a:spLocks noGrp="1"/>
           </p:cNvSpPr>
           <p:nvPr>
-            <p:ph type="ctrTitle"/>
+            <p:ph type="title"/>
           </p:nvPr>
         </p:nvSpPr>
-        <p:spPr>
-          <a:xfrm>
-            <a:off x="1053852" y="34506"/>
-            <a:ext cx="8735325" cy="756568"/>
-          </a:xfrm>
-        </p:spPr>
+        <p:spPr/>
         <p:txBody>
           <a:bodyPr>
             <a:normAutofit/>
           </a:bodyPr>
           <a:lstStyle/>
           <a:p>
-            <a:pPr algn="ctr"/>
-            <a:r>
-              <a:rPr lang="en-US" sz="3600" dirty="0" err="1">
+            <a:br>
+              <a:rPr lang="en-US" dirty="0"/>
+            </a:br>
+            <a:r>
+              <a:rPr lang="en-US" dirty="0">
+                <a:solidFill>
+                  <a:schemeClr val="accent1">
+                    <a:lumMod val="20000"/>
+                    <a:lumOff val="80000"/>
+                  </a:schemeClr>
+                </a:solidFill>
+              </a:rPr>
+              <a:t>Keccak Engine - Design</a:t>
+            </a:r>
+          </a:p>
+        </p:txBody>
+      </p:sp>
+      <p:sp>
+        <p:nvSpPr>
+          <p:cNvPr id="14" name="Content Placeholder 13">
+            <a:extLst>
+              <a:ext uri="{FF2B5EF4-FFF2-40B4-BE49-F238E27FC236}">
+                <a16:creationId xmlns:a16="http://schemas.microsoft.com/office/drawing/2014/main" id="{3AA8BD2D-BE62-8A93-9071-D8E84129C24B}"/>
+              </a:ext>
+            </a:extLst>
+          </p:cNvPr>
+          <p:cNvSpPr>
+            <a:spLocks noGrp="1"/>
+          </p:cNvSpPr>
+          <p:nvPr>
+            <p:ph idx="1"/>
+          </p:nvPr>
+        </p:nvSpPr>
+        <p:spPr/>
+        <p:txBody>
+          <a:bodyPr>
+            <a:normAutofit/>
+          </a:bodyPr>
+          <a:lstStyle/>
+          <a:p>
+            <a:r>
+              <a:rPr lang="en-US" sz="2100" dirty="0"/>
+              <a:t>SHAKE128/SHAKE256 support</a:t>
+            </a:r>
+          </a:p>
+          <a:p>
+            <a:r>
+              <a:rPr lang="en-US" sz="2100" dirty="0"/>
+              <a:t>64-bit bus</a:t>
+            </a:r>
+          </a:p>
+          <a:p>
+            <a:r>
+              <a:rPr lang="en-US" sz="2100" dirty="0"/>
+              <a:t>one-round-per-cycle core</a:t>
+            </a:r>
+          </a:p>
+          <a:p>
+            <a:r>
+              <a:rPr lang="en-US" sz="2100" dirty="0"/>
+              <a:t>parameterized parallel lanes</a:t>
+            </a:r>
+          </a:p>
+          <a:p>
+            <a:r>
+              <a:rPr lang="en-US" sz="2100" dirty="0"/>
+              <a:t>4-lane speedup: 3.84x</a:t>
+            </a:r>
+          </a:p>
+        </p:txBody>
+      </p:sp>
+      <p:sp>
+        <p:nvSpPr>
+          <p:cNvPr id="3" name="Rectangle 2">
+            <a:extLst>
+              <a:ext uri="{FF2B5EF4-FFF2-40B4-BE49-F238E27FC236}">
+                <a16:creationId xmlns:a16="http://schemas.microsoft.com/office/drawing/2014/main" id="{B647DD3C-8411-E505-AFC6-8EF659A18779}"/>
+              </a:ext>
+            </a:extLst>
+          </p:cNvPr>
+          <p:cNvSpPr>
+            <a:spLocks noChangeArrowheads="1"/>
+          </p:cNvSpPr>
+          <p:nvPr/>
+        </p:nvSpPr>
+        <p:spPr bwMode="auto">
+          <a:xfrm>
+            <a:off x="0" y="0"/>
+            <a:ext cx="12188825" cy="0"/>
+          </a:xfrm>
+          <a:prstGeom prst="rect">
+            <a:avLst/>
+          </a:prstGeom>
+          <a:noFill/>
+          <a:ln>
+            <a:noFill/>
+          </a:ln>
+          <a:effectLst/>
+          <a:extLst>
+            <a:ext uri="{909E8E84-426E-40DD-AFC4-6F175D3DCCD1}">
+              <a14:hiddenFill xmlns:a14="http://schemas.microsoft.com/office/drawing/2010/main">
                 <a:solidFill>
                   <a:schemeClr val="accent1"/>
                 </a:solidFill>
+              </a14:hiddenFill>
+            </a:ext>
+            <a:ext uri="{91240B29-F687-4F45-9708-019B960494DF}">
+              <a14:hiddenLine xmlns:a14="http://schemas.microsoft.com/office/drawing/2010/main" w="9525">
+                <a:solidFill>
+                  <a:schemeClr val="tx1"/>
+                </a:solidFill>
+                <a:miter lim="800000"/>
+                <a:headEnd/>
+                <a:tailEnd/>
+              </a14:hiddenLine>
+            </a:ext>
+            <a:ext uri="{AF507438-7753-43E0-B8FC-AC1667EBCBE1}">
+              <a14:hiddenEffects xmlns:a14="http://schemas.microsoft.com/office/drawing/2010/main">
+                <a:effectLst>
+                  <a:outerShdw dist="35921" dir="2700000" algn="ctr" rotWithShape="0">
+                    <a:schemeClr val="bg2"/>
+                  </a:outerShdw>
+                </a:effectLst>
+              </a14:hiddenEffects>
+            </a:ext>
+          </a:extLst>
+        </p:spPr>
+        <p:txBody>
+          <a:bodyPr vert="horz" wrap="none" lIns="91440" tIns="45720" rIns="91440" bIns="45720" numCol="1" anchor="ctr" anchorCtr="0" compatLnSpc="1">
+            <a:prstTxWarp prst="textNoShape">
+              <a:avLst/>
+            </a:prstTxWarp>
+            <a:spAutoFit/>
+          </a:bodyPr>
+          <a:lstStyle/>
+          <a:p>
+            <a:pPr marL="0" marR="0" lvl="0" indent="0" algn="l" defTabSz="914400" rtl="0" eaLnBrk="0" fontAlgn="base" latinLnBrk="0" hangingPunct="0">
+              <a:lnSpc>
+                <a:spcPct val="100000"/>
+              </a:lnSpc>
+              <a:spcBef>
+                <a:spcPct val="0"/>
+              </a:spcBef>
+              <a:spcAft>
+                <a:spcPct val="0"/>
+              </a:spcAft>
+              <a:buClrTx/>
+              <a:buSzTx/>
+              <a:buFontTx/>
+              <a:buChar char="•"/>
+              <a:tabLst/>
+            </a:pPr>
+            <a:r>
+              <a:rPr kumimoji="0" lang="en-PK" altLang="en-PK" sz="1800" b="0" i="0" u="none" strike="noStrike" cap="none" normalizeH="0" baseline="0">
+                <a:ln>
+                  <a:noFill/>
+                </a:ln>
+                <a:solidFill>
+                  <a:schemeClr val="tx1"/>
+                </a:solidFill>
+                <a:effectLst/>
+                <a:latin typeface="Arial" panose="020B0604020202020204" pitchFamily="34" charset="0"/>
               </a:rPr>
-              <a:t>Dilithium</a:t>
-            </a:r>
-            <a:r>
-              <a:rPr lang="en-US" sz="3600" dirty="0">
+              <a:t>Classical schemes (RSA, ECC) rely on </a:t>
+            </a:r>
+            <a:r>
+              <a:rPr kumimoji="0" lang="en-PK" altLang="en-PK" sz="1800" b="1" i="0" u="none" strike="noStrike" cap="none" normalizeH="0" baseline="0">
+                <a:ln>
+                  <a:noFill/>
+                </a:ln>
                 <a:solidFill>
-                  <a:schemeClr val="accent1"/>
+                  <a:schemeClr val="tx1"/>
                 </a:solidFill>
+                <a:effectLst/>
+                <a:latin typeface="Arial" panose="020B0604020202020204" pitchFamily="34" charset="0"/>
               </a:rPr>
-              <a:t> High-Level Architecture</a:t>
-            </a:r>
-            <a:endParaRPr lang="en-PK" sz="3600" dirty="0">
+              <a:t>hard math problems</a:t>
+            </a:r>
+            <a:r>
+              <a:rPr kumimoji="0" lang="en-PK" altLang="en-PK" sz="1800" b="0" i="0" u="none" strike="noStrike" cap="none" normalizeH="0" baseline="0">
+                <a:ln>
+                  <a:noFill/>
+                </a:ln>
+                <a:solidFill>
+                  <a:schemeClr val="tx1"/>
+                </a:solidFill>
+                <a:effectLst/>
+                <a:latin typeface="Arial" panose="020B0604020202020204" pitchFamily="34" charset="0"/>
+              </a:rPr>
+              <a:t>.</a:t>
+            </a:r>
+          </a:p>
+          <a:p>
+            <a:pPr marL="0" marR="0" lvl="0" indent="0" algn="l" defTabSz="914400" rtl="0" eaLnBrk="0" fontAlgn="base" latinLnBrk="0" hangingPunct="0">
+              <a:lnSpc>
+                <a:spcPct val="100000"/>
+              </a:lnSpc>
+              <a:spcBef>
+                <a:spcPct val="0"/>
+              </a:spcBef>
+              <a:spcAft>
+                <a:spcPct val="0"/>
+              </a:spcAft>
+              <a:buClrTx/>
+              <a:buSzTx/>
+              <a:buFontTx/>
+              <a:buChar char="•"/>
+              <a:tabLst/>
+            </a:pPr>
+            <a:endParaRPr kumimoji="0" lang="en-PK" altLang="en-PK" sz="1800" b="0" i="0" u="none" strike="noStrike" cap="none" normalizeH="0" baseline="0">
+              <a:ln>
+                <a:noFill/>
+              </a:ln>
               <a:solidFill>
-                <a:schemeClr val="accent1"/>
+                <a:schemeClr val="tx1"/>
               </a:solidFill>
+              <a:effectLst/>
+              <a:latin typeface="Arial" panose="020B0604020202020204" pitchFamily="34" charset="0"/>
             </a:endParaRPr>
           </a:p>
         </p:txBody>
       </p:sp>
       <p:pic>
         <p:nvPicPr>
-          <p:cNvPr id="5" name="Picture 4">
+          <p:cNvPr id="2" name="f4" descr="Figure 4&#10;Module hierarchy of the Keccak engine: a parameterised parallel wrapper over N independent cores, each split into parameter, absorb, step and output units.">
             <a:extLst>
               <a:ext uri="{FF2B5EF4-FFF2-40B4-BE49-F238E27FC236}">
-                <a16:creationId xmlns:a16="http://schemas.microsoft.com/office/drawing/2014/main" id="{88A32EA7-F5C3-DF67-8C83-9EF34FEA2D8F}"/>
+                <a16:creationId xmlns:a16="http://schemas.microsoft.com/office/drawing/2014/main" id="{5DE65C66-46C4-57B8-7A77-0CE320A168AB}"/>
               </a:ext>
             </a:extLst>
           </p:cNvPr>
@@ -5403,63 +6006,930 @@
             <a:fillRect/>
           </a:stretch>
         </p:blipFill>
-        <p:spPr>
+        <p:spPr bwMode="auto">
           <a:xfrm>
-            <a:off x="2205980" y="791074"/>
-            <a:ext cx="6706536" cy="5553850"/>
-          </a:xfrm>
-          <a:prstGeom prst="rect">
-            <a:avLst/>
-          </a:prstGeom>
-        </p:spPr>
-      </p:pic>
-      <p:sp>
-        <p:nvSpPr>
-          <p:cNvPr id="6" name="TextBox 5">
-            <a:extLst>
-              <a:ext uri="{FF2B5EF4-FFF2-40B4-BE49-F238E27FC236}">
-                <a16:creationId xmlns:a16="http://schemas.microsoft.com/office/drawing/2014/main" id="{6EAECE4F-8045-73FF-FAAE-EBBC0C417926}"/>
-              </a:ext>
-            </a:extLst>
-          </p:cNvPr>
-          <p:cNvSpPr txBox="1"/>
-          <p:nvPr/>
-        </p:nvSpPr>
-        <p:spPr>
-          <a:xfrm>
-            <a:off x="9334772" y="5589240"/>
-            <a:ext cx="2088232" cy="646331"/>
+            <a:off x="5518348" y="1701797"/>
+            <a:ext cx="5839692" cy="3887443"/>
           </a:xfrm>
           <a:prstGeom prst="rect">
             <a:avLst/>
           </a:prstGeom>
           <a:noFill/>
         </p:spPr>
+      </p:pic>
+    </p:spTree>
+    <p:extLst>
+      <p:ext uri="{BB962C8B-B14F-4D97-AF65-F5344CB8AC3E}">
+        <p14:creationId xmlns:p14="http://schemas.microsoft.com/office/powerpoint/2010/main" val="168890123"/>
+      </p:ext>
+    </p:extLst>
+  </p:cSld>
+  <p:clrMapOvr>
+    <a:masterClrMapping/>
+  </p:clrMapOvr>
+  <mc:AlternateContent xmlns:mc="http://schemas.openxmlformats.org/markup-compatibility/2006" xmlns:p14="http://schemas.microsoft.com/office/powerpoint/2010/main">
+    <mc:Choice Requires="p14">
+      <p:transition spd="med" p14:dur="700">
+        <p:fade/>
+      </p:transition>
+    </mc:Choice>
+    <mc:Fallback xmlns="">
+      <p:transition spd="med">
+        <p:fade/>
+      </p:transition>
+    </mc:Fallback>
+  </mc:AlternateContent>
+</p:sld>
+</file>
+
+<file path=ppt/slides/slide11.xml><?xml version="1.0" encoding="utf-8"?>
+<p:sld xmlns:a="http://schemas.openxmlformats.org/drawingml/2006/main" xmlns:r="http://schemas.openxmlformats.org/officeDocument/2006/relationships" xmlns:p="http://schemas.openxmlformats.org/presentationml/2006/main">
+  <p:cSld>
+    <p:spTree>
+      <p:nvGrpSpPr>
+        <p:cNvPr id="1" name="">
+          <a:extLst>
+            <a:ext uri="{FF2B5EF4-FFF2-40B4-BE49-F238E27FC236}">
+              <a16:creationId xmlns:a16="http://schemas.microsoft.com/office/drawing/2014/main" id="{95987B23-0558-0D0E-B7DB-A1A8D9119D8A}"/>
+            </a:ext>
+          </a:extLst>
+        </p:cNvPr>
+        <p:cNvGrpSpPr/>
+        <p:nvPr/>
+      </p:nvGrpSpPr>
+      <p:grpSpPr>
+        <a:xfrm>
+          <a:off x="0" y="0"/>
+          <a:ext cx="0" cy="0"/>
+          <a:chOff x="0" y="0"/>
+          <a:chExt cx="0" cy="0"/>
+        </a:xfrm>
+      </p:grpSpPr>
+      <p:sp>
+        <p:nvSpPr>
+          <p:cNvPr id="13" name="Title 12">
+            <a:extLst>
+              <a:ext uri="{FF2B5EF4-FFF2-40B4-BE49-F238E27FC236}">
+                <a16:creationId xmlns:a16="http://schemas.microsoft.com/office/drawing/2014/main" id="{3FD7B2D2-8357-2C61-A956-966AABD800C8}"/>
+              </a:ext>
+            </a:extLst>
+          </p:cNvPr>
+          <p:cNvSpPr>
+            <a:spLocks noGrp="1"/>
+          </p:cNvSpPr>
+          <p:nvPr>
+            <p:ph type="title"/>
+          </p:nvPr>
+        </p:nvSpPr>
+        <p:spPr/>
         <p:txBody>
-          <a:bodyPr wrap="square" rtlCol="0">
+          <a:bodyPr>
+            <a:normAutofit/>
+          </a:bodyPr>
+          <a:lstStyle/>
+          <a:p>
+            <a:br>
+              <a:rPr lang="en-US" dirty="0"/>
+            </a:br>
+            <a:r>
+              <a:rPr lang="en-US" dirty="0">
+                <a:solidFill>
+                  <a:schemeClr val="accent1">
+                    <a:lumMod val="20000"/>
+                    <a:lumOff val="80000"/>
+                  </a:schemeClr>
+                </a:solidFill>
+              </a:rPr>
+              <a:t>Keccak Engine – Verification and Synthesis</a:t>
+            </a:r>
+          </a:p>
+        </p:txBody>
+      </p:sp>
+      <p:sp>
+        <p:nvSpPr>
+          <p:cNvPr id="3" name="Rectangle 2">
+            <a:extLst>
+              <a:ext uri="{FF2B5EF4-FFF2-40B4-BE49-F238E27FC236}">
+                <a16:creationId xmlns:a16="http://schemas.microsoft.com/office/drawing/2014/main" id="{5DD72153-9084-AF07-F9B8-9BB252B3EC70}"/>
+              </a:ext>
+            </a:extLst>
+          </p:cNvPr>
+          <p:cNvSpPr>
+            <a:spLocks noChangeArrowheads="1"/>
+          </p:cNvSpPr>
+          <p:nvPr/>
+        </p:nvSpPr>
+        <p:spPr bwMode="auto">
+          <a:xfrm>
+            <a:off x="0" y="0"/>
+            <a:ext cx="12188825" cy="0"/>
+          </a:xfrm>
+          <a:prstGeom prst="rect">
+            <a:avLst/>
+          </a:prstGeom>
+          <a:noFill/>
+          <a:ln>
+            <a:noFill/>
+          </a:ln>
+          <a:effectLst/>
+          <a:extLst>
+            <a:ext uri="{909E8E84-426E-40DD-AFC4-6F175D3DCCD1}">
+              <a14:hiddenFill xmlns:a14="http://schemas.microsoft.com/office/drawing/2010/main">
+                <a:solidFill>
+                  <a:schemeClr val="accent1"/>
+                </a:solidFill>
+              </a14:hiddenFill>
+            </a:ext>
+            <a:ext uri="{91240B29-F687-4F45-9708-019B960494DF}">
+              <a14:hiddenLine xmlns:a14="http://schemas.microsoft.com/office/drawing/2010/main" w="9525">
+                <a:solidFill>
+                  <a:schemeClr val="tx1"/>
+                </a:solidFill>
+                <a:miter lim="800000"/>
+                <a:headEnd/>
+                <a:tailEnd/>
+              </a14:hiddenLine>
+            </a:ext>
+            <a:ext uri="{AF507438-7753-43E0-B8FC-AC1667EBCBE1}">
+              <a14:hiddenEffects xmlns:a14="http://schemas.microsoft.com/office/drawing/2010/main">
+                <a:effectLst>
+                  <a:outerShdw dist="35921" dir="2700000" algn="ctr" rotWithShape="0">
+                    <a:schemeClr val="bg2"/>
+                  </a:outerShdw>
+                </a:effectLst>
+              </a14:hiddenEffects>
+            </a:ext>
+          </a:extLst>
+        </p:spPr>
+        <p:txBody>
+          <a:bodyPr vert="horz" wrap="none" lIns="91440" tIns="45720" rIns="91440" bIns="45720" numCol="1" anchor="ctr" anchorCtr="0" compatLnSpc="1">
+            <a:prstTxWarp prst="textNoShape">
+              <a:avLst/>
+            </a:prstTxWarp>
             <a:spAutoFit/>
           </a:bodyPr>
           <a:lstStyle/>
           <a:p>
-            <a:r>
-              <a:rPr lang="en-US" sz="1200" dirty="0"/>
-              <a:t>Fig. </a:t>
-            </a:r>
-            <a:r>
-              <a:rPr lang="en-US" sz="1200" dirty="0" err="1"/>
-              <a:t>Dilithium</a:t>
-            </a:r>
-            <a:r>
-              <a:rPr lang="en-US" sz="1200" dirty="0"/>
-              <a:t> High-Level Architecture. Reproduced from [4]</a:t>
-            </a:r>
+            <a:pPr marL="0" marR="0" lvl="0" indent="0" algn="l" defTabSz="914400" rtl="0" eaLnBrk="0" fontAlgn="base" latinLnBrk="0" hangingPunct="0">
+              <a:lnSpc>
+                <a:spcPct val="100000"/>
+              </a:lnSpc>
+              <a:spcBef>
+                <a:spcPct val="0"/>
+              </a:spcBef>
+              <a:spcAft>
+                <a:spcPct val="0"/>
+              </a:spcAft>
+              <a:buClrTx/>
+              <a:buSzTx/>
+              <a:buFontTx/>
+              <a:buChar char="•"/>
+              <a:tabLst/>
+            </a:pPr>
+            <a:r>
+              <a:rPr kumimoji="0" lang="en-PK" altLang="en-PK" sz="1800" b="0" i="0" u="none" strike="noStrike" cap="none" normalizeH="0" baseline="0">
+                <a:ln>
+                  <a:noFill/>
+                </a:ln>
+                <a:solidFill>
+                  <a:schemeClr val="tx1"/>
+                </a:solidFill>
+                <a:effectLst/>
+                <a:latin typeface="Arial" panose="020B0604020202020204" pitchFamily="34" charset="0"/>
+              </a:rPr>
+              <a:t>Classical schemes (RSA, ECC) rely on </a:t>
+            </a:r>
+            <a:r>
+              <a:rPr kumimoji="0" lang="en-PK" altLang="en-PK" sz="1800" b="1" i="0" u="none" strike="noStrike" cap="none" normalizeH="0" baseline="0">
+                <a:ln>
+                  <a:noFill/>
+                </a:ln>
+                <a:solidFill>
+                  <a:schemeClr val="tx1"/>
+                </a:solidFill>
+                <a:effectLst/>
+                <a:latin typeface="Arial" panose="020B0604020202020204" pitchFamily="34" charset="0"/>
+              </a:rPr>
+              <a:t>hard math problems</a:t>
+            </a:r>
+            <a:r>
+              <a:rPr kumimoji="0" lang="en-PK" altLang="en-PK" sz="1800" b="0" i="0" u="none" strike="noStrike" cap="none" normalizeH="0" baseline="0">
+                <a:ln>
+                  <a:noFill/>
+                </a:ln>
+                <a:solidFill>
+                  <a:schemeClr val="tx1"/>
+                </a:solidFill>
+                <a:effectLst/>
+                <a:latin typeface="Arial" panose="020B0604020202020204" pitchFamily="34" charset="0"/>
+              </a:rPr>
+              <a:t>.</a:t>
+            </a:r>
+          </a:p>
+          <a:p>
+            <a:pPr marL="0" marR="0" lvl="0" indent="0" algn="l" defTabSz="914400" rtl="0" eaLnBrk="0" fontAlgn="base" latinLnBrk="0" hangingPunct="0">
+              <a:lnSpc>
+                <a:spcPct val="100000"/>
+              </a:lnSpc>
+              <a:spcBef>
+                <a:spcPct val="0"/>
+              </a:spcBef>
+              <a:spcAft>
+                <a:spcPct val="0"/>
+              </a:spcAft>
+              <a:buClrTx/>
+              <a:buSzTx/>
+              <a:buFontTx/>
+              <a:buChar char="•"/>
+              <a:tabLst/>
+            </a:pPr>
+            <a:endParaRPr kumimoji="0" lang="en-PK" altLang="en-PK" sz="1800" b="0" i="0" u="none" strike="noStrike" cap="none" normalizeH="0" baseline="0">
+              <a:ln>
+                <a:noFill/>
+              </a:ln>
+              <a:solidFill>
+                <a:schemeClr val="tx1"/>
+              </a:solidFill>
+              <a:effectLst/>
+              <a:latin typeface="Arial" panose="020B0604020202020204" pitchFamily="34" charset="0"/>
+            </a:endParaRPr>
+          </a:p>
+        </p:txBody>
+      </p:sp>
+      <p:sp>
+        <p:nvSpPr>
+          <p:cNvPr id="5" name="Rectangle 2">
+            <a:extLst>
+              <a:ext uri="{FF2B5EF4-FFF2-40B4-BE49-F238E27FC236}">
+                <a16:creationId xmlns:a16="http://schemas.microsoft.com/office/drawing/2014/main" id="{346E9812-4E76-8E78-A069-54DCA47E0E74}"/>
+              </a:ext>
+            </a:extLst>
+          </p:cNvPr>
+          <p:cNvSpPr>
+            <a:spLocks noGrp="1" noChangeArrowheads="1"/>
+          </p:cNvSpPr>
+          <p:nvPr>
+            <p:ph idx="1"/>
+          </p:nvPr>
+        </p:nvSpPr>
+        <p:spPr bwMode="auto">
+          <a:xfrm>
+            <a:off x="1221844" y="1466036"/>
+            <a:ext cx="7848871" cy="4801314"/>
+          </a:xfrm>
+          <a:prstGeom prst="rect">
+            <a:avLst/>
+          </a:prstGeom>
+          <a:noFill/>
+          <a:ln>
+            <a:noFill/>
+          </a:ln>
+          <a:effectLst/>
+          <a:extLst>
+            <a:ext uri="{909E8E84-426E-40DD-AFC4-6F175D3DCCD1}">
+              <a14:hiddenFill xmlns:a14="http://schemas.microsoft.com/office/drawing/2010/main">
+                <a:solidFill>
+                  <a:schemeClr val="accent1"/>
+                </a:solidFill>
+              </a14:hiddenFill>
+            </a:ext>
+            <a:ext uri="{91240B29-F687-4F45-9708-019B960494DF}">
+              <a14:hiddenLine xmlns:a14="http://schemas.microsoft.com/office/drawing/2010/main" w="9525">
+                <a:solidFill>
+                  <a:schemeClr val="tx1"/>
+                </a:solidFill>
+                <a:miter lim="800000"/>
+                <a:headEnd/>
+                <a:tailEnd/>
+              </a14:hiddenLine>
+            </a:ext>
+            <a:ext uri="{AF507438-7753-43E0-B8FC-AC1667EBCBE1}">
+              <a14:hiddenEffects xmlns:a14="http://schemas.microsoft.com/office/drawing/2010/main">
+                <a:effectLst>
+                  <a:outerShdw dist="35921" dir="2700000" algn="ctr" rotWithShape="0">
+                    <a:schemeClr val="bg2"/>
+                  </a:outerShdw>
+                </a:effectLst>
+              </a14:hiddenEffects>
+            </a:ext>
+          </a:extLst>
+        </p:spPr>
+        <p:txBody>
+          <a:bodyPr vert="horz" wrap="square" lIns="91440" tIns="45720" rIns="91440" bIns="45720" numCol="1" anchor="ctr" anchorCtr="0" compatLnSpc="1">
+            <a:prstTxWarp prst="textNoShape">
+              <a:avLst/>
+            </a:prstTxWarp>
+            <a:spAutoFit/>
+          </a:bodyPr>
+          <a:lstStyle/>
+          <a:p>
+            <a:pPr defTabSz="914400" eaLnBrk="0" fontAlgn="base" hangingPunct="0">
+              <a:lnSpc>
+                <a:spcPct val="100000"/>
+              </a:lnSpc>
+              <a:spcBef>
+                <a:spcPct val="0"/>
+              </a:spcBef>
+              <a:spcAft>
+                <a:spcPct val="0"/>
+              </a:spcAft>
+              <a:buClrTx/>
+              <a:buSzTx/>
+            </a:pPr>
+            <a:r>
+              <a:rPr kumimoji="0" lang="en-PK" altLang="en-PK" sz="1800" b="0" i="0" u="none" strike="noStrike" cap="none" normalizeH="0" baseline="0" dirty="0">
+                <a:ln>
+                  <a:noFill/>
+                </a:ln>
+                <a:solidFill>
+                  <a:schemeClr val="tx1"/>
+                </a:solidFill>
+                <a:effectLst/>
+                <a:latin typeface="Arial" panose="020B0604020202020204" pitchFamily="34" charset="0"/>
+              </a:rPr>
+              <a:t>Cover</a:t>
+            </a:r>
+            <a:r>
+              <a:rPr kumimoji="0" lang="en-US" altLang="en-PK" sz="1800" b="0" i="0" u="none" strike="noStrike" cap="none" normalizeH="0" baseline="0" dirty="0">
+                <a:ln>
+                  <a:noFill/>
+                </a:ln>
+                <a:solidFill>
+                  <a:schemeClr val="tx1"/>
+                </a:solidFill>
+                <a:effectLst/>
+                <a:latin typeface="Arial" panose="020B0604020202020204" pitchFamily="34" charset="0"/>
+              </a:rPr>
+              <a:t> </a:t>
+            </a:r>
+            <a:r>
+              <a:rPr kumimoji="0" lang="en-PK" altLang="en-PK" sz="1800" b="0" i="0" u="none" strike="noStrike" cap="none" normalizeH="0" baseline="0" dirty="0">
+                <a:ln>
+                  <a:noFill/>
+                </a:ln>
+                <a:solidFill>
+                  <a:schemeClr val="tx1"/>
+                </a:solidFill>
+                <a:effectLst/>
+                <a:latin typeface="Arial" panose="020B0604020202020204" pitchFamily="34" charset="0"/>
+              </a:rPr>
+              <a:t>group samples each completed SHAKE </a:t>
+            </a:r>
+            <a:r>
+              <a:rPr kumimoji="0" lang="en-PK" altLang="en-PK" sz="1800" b="0" i="0" u="none" strike="noStrike" cap="none" normalizeH="0" baseline="0" dirty="0" err="1">
+                <a:ln>
+                  <a:noFill/>
+                </a:ln>
+                <a:solidFill>
+                  <a:schemeClr val="tx1"/>
+                </a:solidFill>
+                <a:effectLst/>
+                <a:latin typeface="Arial" panose="020B0604020202020204" pitchFamily="34" charset="0"/>
+              </a:rPr>
+              <a:t>transactio</a:t>
+            </a:r>
+            <a:r>
+              <a:rPr kumimoji="0" lang="en-US" altLang="en-PK" sz="1800" b="0" i="0" u="none" strike="noStrike" cap="none" normalizeH="0" baseline="0" dirty="0">
+                <a:ln>
+                  <a:noFill/>
+                </a:ln>
+                <a:solidFill>
+                  <a:schemeClr val="tx1"/>
+                </a:solidFill>
+                <a:effectLst/>
+                <a:latin typeface="Arial" panose="020B0604020202020204" pitchFamily="34" charset="0"/>
+              </a:rPr>
+              <a:t>n</a:t>
+            </a:r>
+          </a:p>
+          <a:p>
+            <a:pPr marL="0" indent="0" defTabSz="914400" eaLnBrk="0" fontAlgn="base" hangingPunct="0">
+              <a:lnSpc>
+                <a:spcPct val="100000"/>
+              </a:lnSpc>
+              <a:spcBef>
+                <a:spcPct val="0"/>
+              </a:spcBef>
+              <a:spcAft>
+                <a:spcPct val="0"/>
+              </a:spcAft>
+              <a:buClrTx/>
+              <a:buSzTx/>
+              <a:buNone/>
+            </a:pPr>
+            <a:endParaRPr kumimoji="0" lang="en-US" altLang="en-PK" sz="1800" b="0" i="0" u="none" strike="noStrike" cap="none" normalizeH="0" baseline="0" dirty="0">
+              <a:ln>
+                <a:noFill/>
+              </a:ln>
+              <a:solidFill>
+                <a:schemeClr val="tx1"/>
+              </a:solidFill>
+              <a:effectLst/>
+              <a:latin typeface="Arial" panose="020B0604020202020204" pitchFamily="34" charset="0"/>
+            </a:endParaRPr>
+          </a:p>
+          <a:p>
+            <a:pPr defTabSz="914400" eaLnBrk="0" fontAlgn="base" hangingPunct="0">
+              <a:lnSpc>
+                <a:spcPct val="100000"/>
+              </a:lnSpc>
+              <a:spcBef>
+                <a:spcPct val="0"/>
+              </a:spcBef>
+              <a:spcAft>
+                <a:spcPct val="0"/>
+              </a:spcAft>
+              <a:buClrTx/>
+              <a:buSzTx/>
+            </a:pPr>
+            <a:r>
+              <a:rPr kumimoji="0" lang="en-PK" altLang="en-PK" sz="1800" b="0" i="0" u="none" strike="noStrike" cap="none" normalizeH="0" baseline="0" dirty="0">
+                <a:ln>
+                  <a:noFill/>
+                </a:ln>
+                <a:solidFill>
+                  <a:schemeClr val="tx1"/>
+                </a:solidFill>
+                <a:effectLst/>
+                <a:latin typeface="Arial" panose="020B0604020202020204" pitchFamily="34" charset="0"/>
+              </a:rPr>
+              <a:t>Cover</a:t>
+            </a:r>
+            <a:r>
+              <a:rPr kumimoji="0" lang="en-US" altLang="en-PK" sz="1800" b="0" i="0" u="none" strike="noStrike" cap="none" normalizeH="0" baseline="0" dirty="0">
+                <a:ln>
+                  <a:noFill/>
+                </a:ln>
+                <a:solidFill>
+                  <a:schemeClr val="tx1"/>
+                </a:solidFill>
+                <a:effectLst/>
+                <a:latin typeface="Arial" panose="020B0604020202020204" pitchFamily="34" charset="0"/>
+              </a:rPr>
+              <a:t> </a:t>
+            </a:r>
+            <a:r>
+              <a:rPr kumimoji="0" lang="en-PK" altLang="en-PK" sz="1800" b="0" i="0" u="none" strike="noStrike" cap="none" normalizeH="0" baseline="0" dirty="0">
+                <a:ln>
+                  <a:noFill/>
+                </a:ln>
+                <a:solidFill>
+                  <a:schemeClr val="tx1"/>
+                </a:solidFill>
+                <a:effectLst/>
+                <a:latin typeface="Arial" panose="020B0604020202020204" pitchFamily="34" charset="0"/>
+              </a:rPr>
+              <a:t>points:</a:t>
+            </a:r>
+            <a:endParaRPr kumimoji="0" lang="en-US" altLang="en-PK" sz="1800" b="0" i="0" u="none" strike="noStrike" cap="none" normalizeH="0" baseline="0" dirty="0">
+              <a:ln>
+                <a:noFill/>
+              </a:ln>
+              <a:solidFill>
+                <a:schemeClr val="tx1"/>
+              </a:solidFill>
+              <a:effectLst/>
+              <a:latin typeface="Arial" panose="020B0604020202020204" pitchFamily="34" charset="0"/>
+            </a:endParaRPr>
+          </a:p>
+          <a:p>
+            <a:pPr lvl="1" defTabSz="914400" eaLnBrk="0" fontAlgn="base" hangingPunct="0">
+              <a:lnSpc>
+                <a:spcPct val="100000"/>
+              </a:lnSpc>
+              <a:spcBef>
+                <a:spcPct val="0"/>
+              </a:spcBef>
+              <a:spcAft>
+                <a:spcPct val="0"/>
+              </a:spcAft>
+              <a:buClrTx/>
+              <a:buSzTx/>
+            </a:pPr>
+            <a:r>
+              <a:rPr kumimoji="0" lang="en-PK" altLang="en-PK" sz="1800" b="0" i="0" u="none" strike="noStrike" cap="none" normalizeH="0" baseline="0" dirty="0">
+                <a:ln>
+                  <a:noFill/>
+                </a:ln>
+                <a:solidFill>
+                  <a:schemeClr val="tx1"/>
+                </a:solidFill>
+                <a:effectLst/>
+                <a:latin typeface="Arial" panose="020B0604020202020204" pitchFamily="34" charset="0"/>
+              </a:rPr>
+              <a:t>SHAKE mode: SHAKE128, SHAKE256</a:t>
+            </a:r>
+          </a:p>
+          <a:p>
+            <a:pPr lvl="1" defTabSz="914400" eaLnBrk="0" fontAlgn="base" hangingPunct="0">
+              <a:lnSpc>
+                <a:spcPct val="100000"/>
+              </a:lnSpc>
+              <a:spcBef>
+                <a:spcPct val="0"/>
+              </a:spcBef>
+              <a:spcAft>
+                <a:spcPct val="0"/>
+              </a:spcAft>
+              <a:buClrTx/>
+              <a:buSzTx/>
+            </a:pPr>
+            <a:r>
+              <a:rPr kumimoji="0" lang="en-PK" altLang="en-PK" sz="1800" b="0" i="0" u="none" strike="noStrike" cap="none" normalizeH="0" baseline="0" dirty="0">
+                <a:ln>
+                  <a:noFill/>
+                </a:ln>
+                <a:solidFill>
+                  <a:schemeClr val="tx1"/>
+                </a:solidFill>
+                <a:effectLst/>
+                <a:latin typeface="Arial" panose="020B0604020202020204" pitchFamily="34" charset="0"/>
+              </a:rPr>
+              <a:t>message length: empty, short, rate-boundary, multi-block</a:t>
+            </a:r>
+          </a:p>
+          <a:p>
+            <a:pPr lvl="1" defTabSz="914400" eaLnBrk="0" fontAlgn="base" hangingPunct="0">
+              <a:lnSpc>
+                <a:spcPct val="100000"/>
+              </a:lnSpc>
+              <a:spcBef>
+                <a:spcPct val="0"/>
+              </a:spcBef>
+              <a:spcAft>
+                <a:spcPct val="0"/>
+              </a:spcAft>
+              <a:buClrTx/>
+              <a:buSzTx/>
+            </a:pPr>
+            <a:r>
+              <a:rPr kumimoji="0" lang="en-PK" altLang="en-PK" sz="1800" b="0" i="0" u="none" strike="noStrike" cap="none" normalizeH="0" baseline="0" dirty="0">
+                <a:ln>
+                  <a:noFill/>
+                </a:ln>
+                <a:solidFill>
+                  <a:schemeClr val="tx1"/>
+                </a:solidFill>
+                <a:effectLst/>
+                <a:latin typeface="Arial" panose="020B0604020202020204" pitchFamily="34" charset="0"/>
+              </a:rPr>
+              <a:t>XOF length: continuous, small, medium, large</a:t>
+            </a:r>
+            <a:endParaRPr kumimoji="0" lang="en-US" altLang="en-PK" sz="1800" b="0" i="0" u="none" strike="noStrike" cap="none" normalizeH="0" baseline="0" dirty="0">
+              <a:ln>
+                <a:noFill/>
+              </a:ln>
+              <a:solidFill>
+                <a:schemeClr val="tx1"/>
+              </a:solidFill>
+              <a:effectLst/>
+              <a:latin typeface="Arial" panose="020B0604020202020204" pitchFamily="34" charset="0"/>
+            </a:endParaRPr>
+          </a:p>
+          <a:p>
+            <a:pPr marL="377886" lvl="1" indent="0" defTabSz="914400" eaLnBrk="0" fontAlgn="base" hangingPunct="0">
+              <a:lnSpc>
+                <a:spcPct val="100000"/>
+              </a:lnSpc>
+              <a:spcBef>
+                <a:spcPct val="0"/>
+              </a:spcBef>
+              <a:spcAft>
+                <a:spcPct val="0"/>
+              </a:spcAft>
+              <a:buClrTx/>
+              <a:buSzTx/>
+              <a:buNone/>
+            </a:pPr>
+            <a:endParaRPr kumimoji="0" lang="en-PK" altLang="en-PK" sz="1800" b="0" i="0" u="none" strike="noStrike" cap="none" normalizeH="0" baseline="0" dirty="0">
+              <a:ln>
+                <a:noFill/>
+              </a:ln>
+              <a:solidFill>
+                <a:schemeClr val="tx1"/>
+              </a:solidFill>
+              <a:effectLst/>
+              <a:latin typeface="Arial" panose="020B0604020202020204" pitchFamily="34" charset="0"/>
+            </a:endParaRPr>
+          </a:p>
+          <a:p>
+            <a:pPr defTabSz="914400" eaLnBrk="0" fontAlgn="base" hangingPunct="0">
+              <a:lnSpc>
+                <a:spcPct val="100000"/>
+              </a:lnSpc>
+              <a:spcBef>
+                <a:spcPct val="0"/>
+              </a:spcBef>
+              <a:spcAft>
+                <a:spcPct val="0"/>
+              </a:spcAft>
+              <a:buClrTx/>
+              <a:buSzTx/>
+            </a:pPr>
+            <a:r>
+              <a:rPr kumimoji="0" lang="en-PK" altLang="en-PK" sz="1800" b="0" i="0" u="none" strike="noStrike" cap="none" normalizeH="0" baseline="0" dirty="0">
+                <a:ln>
+                  <a:noFill/>
+                </a:ln>
+                <a:solidFill>
+                  <a:schemeClr val="tx1"/>
+                </a:solidFill>
+                <a:effectLst/>
+                <a:latin typeface="Arial" panose="020B0604020202020204" pitchFamily="34" charset="0"/>
+              </a:rPr>
+              <a:t>Cross coverage:</a:t>
+            </a:r>
+          </a:p>
+          <a:p>
+            <a:pPr lvl="1" defTabSz="914400" eaLnBrk="0" fontAlgn="base" hangingPunct="0">
+              <a:lnSpc>
+                <a:spcPct val="100000"/>
+              </a:lnSpc>
+              <a:spcBef>
+                <a:spcPct val="0"/>
+              </a:spcBef>
+              <a:spcAft>
+                <a:spcPct val="0"/>
+              </a:spcAft>
+              <a:buClrTx/>
+              <a:buSzTx/>
+            </a:pPr>
+            <a:r>
+              <a:rPr kumimoji="0" lang="en-PK" altLang="en-PK" sz="1800" b="0" i="0" u="none" strike="noStrike" cap="none" normalizeH="0" baseline="0" dirty="0">
+                <a:ln>
+                  <a:noFill/>
+                </a:ln>
+                <a:solidFill>
+                  <a:schemeClr val="tx1"/>
+                </a:solidFill>
+                <a:effectLst/>
+                <a:latin typeface="Arial" panose="020B0604020202020204" pitchFamily="34" charset="0"/>
+              </a:rPr>
+              <a:t>mode x message length</a:t>
+            </a:r>
+          </a:p>
+          <a:p>
+            <a:pPr lvl="1" defTabSz="914400" eaLnBrk="0" fontAlgn="base" hangingPunct="0">
+              <a:lnSpc>
+                <a:spcPct val="100000"/>
+              </a:lnSpc>
+              <a:spcBef>
+                <a:spcPct val="0"/>
+              </a:spcBef>
+              <a:spcAft>
+                <a:spcPct val="0"/>
+              </a:spcAft>
+              <a:buClrTx/>
+              <a:buSzTx/>
+            </a:pPr>
+            <a:r>
+              <a:rPr kumimoji="0" lang="en-PK" altLang="en-PK" sz="1800" b="0" i="0" u="none" strike="noStrike" cap="none" normalizeH="0" baseline="0" dirty="0">
+                <a:ln>
+                  <a:noFill/>
+                </a:ln>
+                <a:solidFill>
+                  <a:schemeClr val="tx1"/>
+                </a:solidFill>
+                <a:effectLst/>
+                <a:latin typeface="Arial" panose="020B0604020202020204" pitchFamily="34" charset="0"/>
+              </a:rPr>
+              <a:t>mode x XOF length</a:t>
+            </a:r>
+            <a:endParaRPr kumimoji="0" lang="en-US" altLang="en-PK" sz="1800" b="0" i="0" u="none" strike="noStrike" cap="none" normalizeH="0" baseline="0" dirty="0">
+              <a:ln>
+                <a:noFill/>
+              </a:ln>
+              <a:solidFill>
+                <a:schemeClr val="tx1"/>
+              </a:solidFill>
+              <a:effectLst/>
+              <a:latin typeface="Arial" panose="020B0604020202020204" pitchFamily="34" charset="0"/>
+            </a:endParaRPr>
+          </a:p>
+          <a:p>
+            <a:pPr marL="377886" lvl="1" indent="0" defTabSz="914400" eaLnBrk="0" fontAlgn="base" hangingPunct="0">
+              <a:lnSpc>
+                <a:spcPct val="100000"/>
+              </a:lnSpc>
+              <a:spcBef>
+                <a:spcPct val="0"/>
+              </a:spcBef>
+              <a:spcAft>
+                <a:spcPct val="0"/>
+              </a:spcAft>
+              <a:buClrTx/>
+              <a:buSzTx/>
+              <a:buNone/>
+            </a:pPr>
+            <a:endParaRPr kumimoji="0" lang="en-PK" altLang="en-PK" sz="1800" b="0" i="0" u="none" strike="noStrike" cap="none" normalizeH="0" baseline="0" dirty="0">
+              <a:ln>
+                <a:noFill/>
+              </a:ln>
+              <a:solidFill>
+                <a:schemeClr val="tx1"/>
+              </a:solidFill>
+              <a:effectLst/>
+              <a:latin typeface="Arial" panose="020B0604020202020204" pitchFamily="34" charset="0"/>
+            </a:endParaRPr>
+          </a:p>
+          <a:p>
+            <a:pPr defTabSz="914400" eaLnBrk="0" fontAlgn="base" hangingPunct="0">
+              <a:lnSpc>
+                <a:spcPct val="100000"/>
+              </a:lnSpc>
+              <a:spcBef>
+                <a:spcPct val="0"/>
+              </a:spcBef>
+              <a:spcAft>
+                <a:spcPct val="0"/>
+              </a:spcAft>
+              <a:buClrTx/>
+              <a:buSzTx/>
+            </a:pPr>
+            <a:r>
+              <a:rPr kumimoji="0" lang="en-PK" altLang="en-PK" sz="1800" b="0" i="0" u="none" strike="noStrike" cap="none" normalizeH="0" baseline="0" dirty="0">
+                <a:ln>
+                  <a:noFill/>
+                </a:ln>
+                <a:solidFill>
+                  <a:schemeClr val="tx1"/>
+                </a:solidFill>
+                <a:effectLst/>
+                <a:latin typeface="Arial" panose="020B0604020202020204" pitchFamily="34" charset="0"/>
+              </a:rPr>
+              <a:t>Result</a:t>
+            </a:r>
+            <a:r>
+              <a:rPr kumimoji="0" lang="en-US" altLang="en-PK" sz="1800" b="0" i="0" u="none" strike="noStrike" cap="none" normalizeH="0" baseline="0" dirty="0">
+                <a:ln>
+                  <a:noFill/>
+                </a:ln>
+                <a:solidFill>
+                  <a:schemeClr val="tx1"/>
+                </a:solidFill>
+                <a:effectLst/>
+                <a:latin typeface="Arial" panose="020B0604020202020204" pitchFamily="34" charset="0"/>
+              </a:rPr>
+              <a:t>s</a:t>
+            </a:r>
+            <a:r>
+              <a:rPr kumimoji="0" lang="en-PK" altLang="en-PK" sz="1800" b="0" i="0" u="none" strike="noStrike" cap="none" normalizeH="0" baseline="0" dirty="0">
+                <a:ln>
+                  <a:noFill/>
+                </a:ln>
+                <a:solidFill>
+                  <a:schemeClr val="tx1"/>
+                </a:solidFill>
+                <a:effectLst/>
+                <a:latin typeface="Arial" panose="020B0604020202020204" pitchFamily="34" charset="0"/>
+              </a:rPr>
+              <a:t>:</a:t>
+            </a:r>
+          </a:p>
+          <a:p>
+            <a:pPr lvl="1" defTabSz="914400" eaLnBrk="0" fontAlgn="base" hangingPunct="0">
+              <a:lnSpc>
+                <a:spcPct val="100000"/>
+              </a:lnSpc>
+              <a:spcBef>
+                <a:spcPct val="0"/>
+              </a:spcBef>
+              <a:spcAft>
+                <a:spcPct val="0"/>
+              </a:spcAft>
+              <a:buClrTx/>
+              <a:buSzTx/>
+            </a:pPr>
+            <a:r>
+              <a:rPr kumimoji="0" lang="en-PK" altLang="en-PK" sz="1800" b="0" i="0" u="none" strike="noStrike" cap="none" normalizeH="0" baseline="0" dirty="0">
+                <a:ln>
+                  <a:noFill/>
+                </a:ln>
+                <a:solidFill>
+                  <a:schemeClr val="tx1"/>
+                </a:solidFill>
+                <a:effectLst/>
+                <a:latin typeface="Arial" panose="020B0604020202020204" pitchFamily="34" charset="0"/>
+              </a:rPr>
+              <a:t>208/208 tests passed</a:t>
+            </a:r>
+          </a:p>
+          <a:p>
+            <a:pPr lvl="1" defTabSz="914400" eaLnBrk="0" fontAlgn="base" hangingPunct="0">
+              <a:lnSpc>
+                <a:spcPct val="100000"/>
+              </a:lnSpc>
+              <a:spcBef>
+                <a:spcPct val="0"/>
+              </a:spcBef>
+              <a:spcAft>
+                <a:spcPct val="0"/>
+              </a:spcAft>
+              <a:buClrTx/>
+              <a:buSzTx/>
+            </a:pPr>
+            <a:r>
+              <a:rPr kumimoji="0" lang="en-PK" altLang="en-PK" sz="1800" b="0" i="0" u="none" strike="noStrike" cap="none" normalizeH="0" baseline="0" dirty="0">
+                <a:ln>
+                  <a:noFill/>
+                </a:ln>
+                <a:solidFill>
+                  <a:schemeClr val="tx1"/>
+                </a:solidFill>
+                <a:effectLst/>
+                <a:latin typeface="Arial" panose="020B0604020202020204" pitchFamily="34" charset="0"/>
+              </a:rPr>
+              <a:t>100% functional coverage</a:t>
+            </a:r>
+            <a:endParaRPr kumimoji="0" lang="en-US" altLang="en-PK" sz="1800" b="0" i="0" u="none" strike="noStrike" cap="none" normalizeH="0" baseline="0" dirty="0">
+              <a:ln>
+                <a:noFill/>
+              </a:ln>
+              <a:solidFill>
+                <a:schemeClr val="tx1"/>
+              </a:solidFill>
+              <a:effectLst/>
+              <a:latin typeface="Arial" panose="020B0604020202020204" pitchFamily="34" charset="0"/>
+            </a:endParaRPr>
+          </a:p>
+          <a:p>
+            <a:pPr lvl="1" defTabSz="914400" eaLnBrk="0" fontAlgn="base" hangingPunct="0">
+              <a:lnSpc>
+                <a:spcPct val="100000"/>
+              </a:lnSpc>
+              <a:spcBef>
+                <a:spcPct val="0"/>
+              </a:spcBef>
+              <a:spcAft>
+                <a:spcPct val="0"/>
+              </a:spcAft>
+              <a:buClrTx/>
+              <a:buSzTx/>
+            </a:pPr>
+            <a:r>
+              <a:rPr lang="en-US" sz="1800" dirty="0"/>
+              <a:t>Fmax: 84.31 MHz</a:t>
+            </a:r>
+          </a:p>
+          <a:p>
+            <a:pPr lvl="1" defTabSz="914400" eaLnBrk="0" fontAlgn="base" hangingPunct="0">
+              <a:lnSpc>
+                <a:spcPct val="100000"/>
+              </a:lnSpc>
+              <a:spcBef>
+                <a:spcPct val="0"/>
+              </a:spcBef>
+              <a:spcAft>
+                <a:spcPct val="0"/>
+              </a:spcAft>
+              <a:buClrTx/>
+              <a:buSzTx/>
+            </a:pPr>
+            <a:endParaRPr kumimoji="0" lang="en-PK" altLang="en-PK" sz="1800" b="0" i="0" u="none" strike="noStrike" cap="none" normalizeH="0" baseline="0" dirty="0">
+              <a:ln>
+                <a:noFill/>
+              </a:ln>
+              <a:solidFill>
+                <a:schemeClr val="tx1"/>
+              </a:solidFill>
+              <a:effectLst/>
+              <a:latin typeface="Arial" panose="020B0604020202020204" pitchFamily="34" charset="0"/>
+            </a:endParaRPr>
+          </a:p>
+          <a:p>
+            <a:pPr marL="0" marR="0" lvl="0" indent="0" algn="l" defTabSz="914400" rtl="0" eaLnBrk="0" fontAlgn="base" latinLnBrk="0" hangingPunct="0">
+              <a:lnSpc>
+                <a:spcPct val="100000"/>
+              </a:lnSpc>
+              <a:spcBef>
+                <a:spcPct val="0"/>
+              </a:spcBef>
+              <a:spcAft>
+                <a:spcPct val="0"/>
+              </a:spcAft>
+              <a:buClrTx/>
+              <a:buSzTx/>
+              <a:buFontTx/>
+              <a:buNone/>
+              <a:tabLst/>
+            </a:pPr>
+            <a:endParaRPr kumimoji="0" lang="en-PK" altLang="en-PK" sz="1800" b="0" i="0" u="none" strike="noStrike" cap="none" normalizeH="0" baseline="0" dirty="0">
+              <a:ln>
+                <a:noFill/>
+              </a:ln>
+              <a:solidFill>
+                <a:schemeClr val="tx1"/>
+              </a:solidFill>
+              <a:effectLst/>
+              <a:latin typeface="Arial" panose="020B0604020202020204" pitchFamily="34" charset="0"/>
+            </a:endParaRPr>
           </a:p>
         </p:txBody>
       </p:sp>
     </p:spTree>
     <p:extLst>
       <p:ext uri="{BB962C8B-B14F-4D97-AF65-F5344CB8AC3E}">
-        <p14:creationId xmlns:p14="http://schemas.microsoft.com/office/powerpoint/2010/main" val="3478977026"/>
+        <p14:creationId xmlns:p14="http://schemas.microsoft.com/office/powerpoint/2010/main" val="712897892"/>
       </p:ext>
     </p:extLst>
   </p:cSld>
@@ -5481,7 +6951,490 @@
 </p:sld>
 </file>
 
-<file path=ppt/slides/slide11.xml><?xml version="1.0" encoding="utf-8"?>
+<file path=ppt/slides/slide12.xml><?xml version="1.0" encoding="utf-8"?>
+<p:sld xmlns:a="http://schemas.openxmlformats.org/drawingml/2006/main" xmlns:r="http://schemas.openxmlformats.org/officeDocument/2006/relationships" xmlns:p="http://schemas.openxmlformats.org/presentationml/2006/main">
+  <p:cSld>
+    <p:spTree>
+      <p:nvGrpSpPr>
+        <p:cNvPr id="1" name="">
+          <a:extLst>
+            <a:ext uri="{FF2B5EF4-FFF2-40B4-BE49-F238E27FC236}">
+              <a16:creationId xmlns:a16="http://schemas.microsoft.com/office/drawing/2014/main" id="{73B62BDB-FAF0-916C-9A6C-33E999ACD652}"/>
+            </a:ext>
+          </a:extLst>
+        </p:cNvPr>
+        <p:cNvGrpSpPr/>
+        <p:nvPr/>
+      </p:nvGrpSpPr>
+      <p:grpSpPr>
+        <a:xfrm>
+          <a:off x="0" y="0"/>
+          <a:ext cx="0" cy="0"/>
+          <a:chOff x="0" y="0"/>
+          <a:chExt cx="0" cy="0"/>
+        </a:xfrm>
+      </p:grpSpPr>
+      <p:sp>
+        <p:nvSpPr>
+          <p:cNvPr id="13" name="Title 12">
+            <a:extLst>
+              <a:ext uri="{FF2B5EF4-FFF2-40B4-BE49-F238E27FC236}">
+                <a16:creationId xmlns:a16="http://schemas.microsoft.com/office/drawing/2014/main" id="{1D835DAB-9C3B-709A-9226-59719CB781EC}"/>
+              </a:ext>
+            </a:extLst>
+          </p:cNvPr>
+          <p:cNvSpPr>
+            <a:spLocks noGrp="1"/>
+          </p:cNvSpPr>
+          <p:nvPr>
+            <p:ph type="title"/>
+          </p:nvPr>
+        </p:nvSpPr>
+        <p:spPr/>
+        <p:txBody>
+          <a:bodyPr>
+            <a:normAutofit/>
+          </a:bodyPr>
+          <a:lstStyle/>
+          <a:p>
+            <a:br>
+              <a:rPr lang="en-US" dirty="0"/>
+            </a:br>
+            <a:r>
+              <a:rPr lang="en-US" dirty="0">
+                <a:solidFill>
+                  <a:schemeClr val="accent1">
+                    <a:lumMod val="20000"/>
+                    <a:lumOff val="80000"/>
+                  </a:schemeClr>
+                </a:solidFill>
+              </a:rPr>
+              <a:t>Keccak Engine – Verification and Synthesis</a:t>
+            </a:r>
+          </a:p>
+        </p:txBody>
+      </p:sp>
+      <p:sp>
+        <p:nvSpPr>
+          <p:cNvPr id="3" name="Rectangle 2">
+            <a:extLst>
+              <a:ext uri="{FF2B5EF4-FFF2-40B4-BE49-F238E27FC236}">
+                <a16:creationId xmlns:a16="http://schemas.microsoft.com/office/drawing/2014/main" id="{BC38DA8F-9816-6C95-2ADC-21AB123BFF55}"/>
+              </a:ext>
+            </a:extLst>
+          </p:cNvPr>
+          <p:cNvSpPr>
+            <a:spLocks noChangeArrowheads="1"/>
+          </p:cNvSpPr>
+          <p:nvPr/>
+        </p:nvSpPr>
+        <p:spPr bwMode="auto">
+          <a:xfrm>
+            <a:off x="0" y="0"/>
+            <a:ext cx="12188825" cy="0"/>
+          </a:xfrm>
+          <a:prstGeom prst="rect">
+            <a:avLst/>
+          </a:prstGeom>
+          <a:noFill/>
+          <a:ln>
+            <a:noFill/>
+          </a:ln>
+          <a:effectLst/>
+          <a:extLst>
+            <a:ext uri="{909E8E84-426E-40DD-AFC4-6F175D3DCCD1}">
+              <a14:hiddenFill xmlns:a14="http://schemas.microsoft.com/office/drawing/2010/main">
+                <a:solidFill>
+                  <a:schemeClr val="accent1"/>
+                </a:solidFill>
+              </a14:hiddenFill>
+            </a:ext>
+            <a:ext uri="{91240B29-F687-4F45-9708-019B960494DF}">
+              <a14:hiddenLine xmlns:a14="http://schemas.microsoft.com/office/drawing/2010/main" w="9525">
+                <a:solidFill>
+                  <a:schemeClr val="tx1"/>
+                </a:solidFill>
+                <a:miter lim="800000"/>
+                <a:headEnd/>
+                <a:tailEnd/>
+              </a14:hiddenLine>
+            </a:ext>
+            <a:ext uri="{AF507438-7753-43E0-B8FC-AC1667EBCBE1}">
+              <a14:hiddenEffects xmlns:a14="http://schemas.microsoft.com/office/drawing/2010/main">
+                <a:effectLst>
+                  <a:outerShdw dist="35921" dir="2700000" algn="ctr" rotWithShape="0">
+                    <a:schemeClr val="bg2"/>
+                  </a:outerShdw>
+                </a:effectLst>
+              </a14:hiddenEffects>
+            </a:ext>
+          </a:extLst>
+        </p:spPr>
+        <p:txBody>
+          <a:bodyPr vert="horz" wrap="none" lIns="91440" tIns="45720" rIns="91440" bIns="45720" numCol="1" anchor="ctr" anchorCtr="0" compatLnSpc="1">
+            <a:prstTxWarp prst="textNoShape">
+              <a:avLst/>
+            </a:prstTxWarp>
+            <a:spAutoFit/>
+          </a:bodyPr>
+          <a:lstStyle/>
+          <a:p>
+            <a:pPr marL="0" marR="0" lvl="0" indent="0" algn="l" defTabSz="914400" rtl="0" eaLnBrk="0" fontAlgn="base" latinLnBrk="0" hangingPunct="0">
+              <a:lnSpc>
+                <a:spcPct val="100000"/>
+              </a:lnSpc>
+              <a:spcBef>
+                <a:spcPct val="0"/>
+              </a:spcBef>
+              <a:spcAft>
+                <a:spcPct val="0"/>
+              </a:spcAft>
+              <a:buClrTx/>
+              <a:buSzTx/>
+              <a:buFontTx/>
+              <a:buChar char="•"/>
+              <a:tabLst/>
+            </a:pPr>
+            <a:r>
+              <a:rPr kumimoji="0" lang="en-PK" altLang="en-PK" sz="1800" b="0" i="0" u="none" strike="noStrike" cap="none" normalizeH="0" baseline="0">
+                <a:ln>
+                  <a:noFill/>
+                </a:ln>
+                <a:solidFill>
+                  <a:schemeClr val="tx1"/>
+                </a:solidFill>
+                <a:effectLst/>
+                <a:latin typeface="Arial" panose="020B0604020202020204" pitchFamily="34" charset="0"/>
+              </a:rPr>
+              <a:t>Classical schemes (RSA, ECC) rely on </a:t>
+            </a:r>
+            <a:r>
+              <a:rPr kumimoji="0" lang="en-PK" altLang="en-PK" sz="1800" b="1" i="0" u="none" strike="noStrike" cap="none" normalizeH="0" baseline="0">
+                <a:ln>
+                  <a:noFill/>
+                </a:ln>
+                <a:solidFill>
+                  <a:schemeClr val="tx1"/>
+                </a:solidFill>
+                <a:effectLst/>
+                <a:latin typeface="Arial" panose="020B0604020202020204" pitchFamily="34" charset="0"/>
+              </a:rPr>
+              <a:t>hard math problems</a:t>
+            </a:r>
+            <a:r>
+              <a:rPr kumimoji="0" lang="en-PK" altLang="en-PK" sz="1800" b="0" i="0" u="none" strike="noStrike" cap="none" normalizeH="0" baseline="0">
+                <a:ln>
+                  <a:noFill/>
+                </a:ln>
+                <a:solidFill>
+                  <a:schemeClr val="tx1"/>
+                </a:solidFill>
+                <a:effectLst/>
+                <a:latin typeface="Arial" panose="020B0604020202020204" pitchFamily="34" charset="0"/>
+              </a:rPr>
+              <a:t>.</a:t>
+            </a:r>
+          </a:p>
+          <a:p>
+            <a:pPr marL="0" marR="0" lvl="0" indent="0" algn="l" defTabSz="914400" rtl="0" eaLnBrk="0" fontAlgn="base" latinLnBrk="0" hangingPunct="0">
+              <a:lnSpc>
+                <a:spcPct val="100000"/>
+              </a:lnSpc>
+              <a:spcBef>
+                <a:spcPct val="0"/>
+              </a:spcBef>
+              <a:spcAft>
+                <a:spcPct val="0"/>
+              </a:spcAft>
+              <a:buClrTx/>
+              <a:buSzTx/>
+              <a:buFontTx/>
+              <a:buChar char="•"/>
+              <a:tabLst/>
+            </a:pPr>
+            <a:endParaRPr kumimoji="0" lang="en-PK" altLang="en-PK" sz="1800" b="0" i="0" u="none" strike="noStrike" cap="none" normalizeH="0" baseline="0">
+              <a:ln>
+                <a:noFill/>
+              </a:ln>
+              <a:solidFill>
+                <a:schemeClr val="tx1"/>
+              </a:solidFill>
+              <a:effectLst/>
+              <a:latin typeface="Arial" panose="020B0604020202020204" pitchFamily="34" charset="0"/>
+            </a:endParaRPr>
+          </a:p>
+        </p:txBody>
+      </p:sp>
+      <p:sp>
+        <p:nvSpPr>
+          <p:cNvPr id="5" name="Rectangle 2">
+            <a:extLst>
+              <a:ext uri="{FF2B5EF4-FFF2-40B4-BE49-F238E27FC236}">
+                <a16:creationId xmlns:a16="http://schemas.microsoft.com/office/drawing/2014/main" id="{64BB1897-1057-E9C5-0E15-94A30A3FD353}"/>
+              </a:ext>
+            </a:extLst>
+          </p:cNvPr>
+          <p:cNvSpPr>
+            <a:spLocks noGrp="1" noChangeArrowheads="1"/>
+          </p:cNvSpPr>
+          <p:nvPr>
+            <p:ph idx="1"/>
+          </p:nvPr>
+        </p:nvSpPr>
+        <p:spPr bwMode="auto">
+          <a:xfrm>
+            <a:off x="1221844" y="3543527"/>
+            <a:ext cx="7848871" cy="646331"/>
+          </a:xfrm>
+          <a:prstGeom prst="rect">
+            <a:avLst/>
+          </a:prstGeom>
+          <a:noFill/>
+          <a:ln>
+            <a:noFill/>
+          </a:ln>
+          <a:effectLst/>
+          <a:extLst>
+            <a:ext uri="{909E8E84-426E-40DD-AFC4-6F175D3DCCD1}">
+              <a14:hiddenFill xmlns:a14="http://schemas.microsoft.com/office/drawing/2010/main">
+                <a:solidFill>
+                  <a:schemeClr val="accent1"/>
+                </a:solidFill>
+              </a14:hiddenFill>
+            </a:ext>
+            <a:ext uri="{91240B29-F687-4F45-9708-019B960494DF}">
+              <a14:hiddenLine xmlns:a14="http://schemas.microsoft.com/office/drawing/2010/main" w="9525">
+                <a:solidFill>
+                  <a:schemeClr val="tx1"/>
+                </a:solidFill>
+                <a:miter lim="800000"/>
+                <a:headEnd/>
+                <a:tailEnd/>
+              </a14:hiddenLine>
+            </a:ext>
+            <a:ext uri="{AF507438-7753-43E0-B8FC-AC1667EBCBE1}">
+              <a14:hiddenEffects xmlns:a14="http://schemas.microsoft.com/office/drawing/2010/main">
+                <a:effectLst>
+                  <a:outerShdw dist="35921" dir="2700000" algn="ctr" rotWithShape="0">
+                    <a:schemeClr val="bg2"/>
+                  </a:outerShdw>
+                </a:effectLst>
+              </a14:hiddenEffects>
+            </a:ext>
+          </a:extLst>
+        </p:spPr>
+        <p:txBody>
+          <a:bodyPr vert="horz" wrap="square" lIns="91440" tIns="45720" rIns="91440" bIns="45720" numCol="1" anchor="ctr" anchorCtr="0" compatLnSpc="1">
+            <a:prstTxWarp prst="textNoShape">
+              <a:avLst/>
+            </a:prstTxWarp>
+            <a:spAutoFit/>
+          </a:bodyPr>
+          <a:lstStyle/>
+          <a:p>
+            <a:pPr lvl="1" defTabSz="914400" eaLnBrk="0" fontAlgn="base" hangingPunct="0">
+              <a:lnSpc>
+                <a:spcPct val="100000"/>
+              </a:lnSpc>
+              <a:spcBef>
+                <a:spcPct val="0"/>
+              </a:spcBef>
+              <a:spcAft>
+                <a:spcPct val="0"/>
+              </a:spcAft>
+              <a:buClrTx/>
+              <a:buSzTx/>
+            </a:pPr>
+            <a:endParaRPr kumimoji="0" lang="en-PK" altLang="en-PK" sz="1800" b="0" i="0" u="none" strike="noStrike" cap="none" normalizeH="0" baseline="0" dirty="0">
+              <a:ln>
+                <a:noFill/>
+              </a:ln>
+              <a:solidFill>
+                <a:schemeClr val="tx1"/>
+              </a:solidFill>
+              <a:effectLst/>
+              <a:latin typeface="Arial" panose="020B0604020202020204" pitchFamily="34" charset="0"/>
+            </a:endParaRPr>
+          </a:p>
+          <a:p>
+            <a:pPr marL="0" marR="0" lvl="0" indent="0" algn="l" defTabSz="914400" rtl="0" eaLnBrk="0" fontAlgn="base" latinLnBrk="0" hangingPunct="0">
+              <a:lnSpc>
+                <a:spcPct val="100000"/>
+              </a:lnSpc>
+              <a:spcBef>
+                <a:spcPct val="0"/>
+              </a:spcBef>
+              <a:spcAft>
+                <a:spcPct val="0"/>
+              </a:spcAft>
+              <a:buClrTx/>
+              <a:buSzTx/>
+              <a:buFontTx/>
+              <a:buNone/>
+              <a:tabLst/>
+            </a:pPr>
+            <a:endParaRPr kumimoji="0" lang="en-PK" altLang="en-PK" sz="1800" b="0" i="0" u="none" strike="noStrike" cap="none" normalizeH="0" baseline="0" dirty="0">
+              <a:ln>
+                <a:noFill/>
+              </a:ln>
+              <a:solidFill>
+                <a:schemeClr val="tx1"/>
+              </a:solidFill>
+              <a:effectLst/>
+              <a:latin typeface="Arial" panose="020B0604020202020204" pitchFamily="34" charset="0"/>
+            </a:endParaRPr>
+          </a:p>
+        </p:txBody>
+      </p:sp>
+    </p:spTree>
+    <p:extLst>
+      <p:ext uri="{BB962C8B-B14F-4D97-AF65-F5344CB8AC3E}">
+        <p14:creationId xmlns:p14="http://schemas.microsoft.com/office/powerpoint/2010/main" val="2426162218"/>
+      </p:ext>
+    </p:extLst>
+  </p:cSld>
+  <p:clrMapOvr>
+    <a:masterClrMapping/>
+  </p:clrMapOvr>
+  <mc:AlternateContent xmlns:mc="http://schemas.openxmlformats.org/markup-compatibility/2006">
+    <mc:Choice xmlns:p14="http://schemas.microsoft.com/office/powerpoint/2010/main" Requires="p14">
+      <p:transition spd="med" p14:dur="700">
+        <p:fade/>
+      </p:transition>
+    </mc:Choice>
+    <mc:Fallback>
+      <p:transition spd="med">
+        <p:fade/>
+      </p:transition>
+    </mc:Fallback>
+  </mc:AlternateContent>
+</p:sld>
+</file>
+
+<file path=ppt/slides/slide13.xml><?xml version="1.0" encoding="utf-8"?>
+<p:sld xmlns:a="http://schemas.openxmlformats.org/drawingml/2006/main" xmlns:r="http://schemas.openxmlformats.org/officeDocument/2006/relationships" xmlns:p="http://schemas.openxmlformats.org/presentationml/2006/main">
+  <p:cSld>
+    <p:spTree>
+      <p:nvGrpSpPr>
+        <p:cNvPr id="1" name="">
+          <a:extLst>
+            <a:ext uri="{FF2B5EF4-FFF2-40B4-BE49-F238E27FC236}">
+              <a16:creationId xmlns:a16="http://schemas.microsoft.com/office/drawing/2014/main" id="{4BE1253C-61ED-95EB-83F6-02E88404FF3D}"/>
+            </a:ext>
+          </a:extLst>
+        </p:cNvPr>
+        <p:cNvGrpSpPr/>
+        <p:nvPr/>
+      </p:nvGrpSpPr>
+      <p:grpSpPr>
+        <a:xfrm>
+          <a:off x="0" y="0"/>
+          <a:ext cx="0" cy="0"/>
+          <a:chOff x="0" y="0"/>
+          <a:chExt cx="0" cy="0"/>
+        </a:xfrm>
+      </p:grpSpPr>
+      <p:sp>
+        <p:nvSpPr>
+          <p:cNvPr id="2" name="Title 1">
+            <a:extLst>
+              <a:ext uri="{FF2B5EF4-FFF2-40B4-BE49-F238E27FC236}">
+                <a16:creationId xmlns:a16="http://schemas.microsoft.com/office/drawing/2014/main" id="{7887892D-7999-15A6-E547-43B3116D95F6}"/>
+              </a:ext>
+            </a:extLst>
+          </p:cNvPr>
+          <p:cNvSpPr>
+            <a:spLocks noGrp="1"/>
+          </p:cNvSpPr>
+          <p:nvPr>
+            <p:ph type="ctrTitle"/>
+          </p:nvPr>
+        </p:nvSpPr>
+        <p:spPr>
+          <a:xfrm>
+            <a:off x="1053852" y="0"/>
+            <a:ext cx="8735325" cy="756568"/>
+          </a:xfrm>
+        </p:spPr>
+        <p:txBody>
+          <a:bodyPr>
+            <a:normAutofit/>
+          </a:bodyPr>
+          <a:lstStyle/>
+          <a:p>
+            <a:pPr algn="ctr"/>
+            <a:r>
+              <a:rPr lang="en-US" sz="3600" dirty="0">
+                <a:solidFill>
+                  <a:schemeClr val="accent1"/>
+                </a:solidFill>
+              </a:rPr>
+              <a:t>GANTT CHART</a:t>
+            </a:r>
+            <a:endParaRPr lang="en-PK" sz="3600" dirty="0">
+              <a:solidFill>
+                <a:schemeClr val="accent1"/>
+              </a:solidFill>
+            </a:endParaRPr>
+          </a:p>
+        </p:txBody>
+      </p:sp>
+      <p:pic>
+        <p:nvPicPr>
+          <p:cNvPr id="9" name="Picture 8">
+            <a:extLst>
+              <a:ext uri="{FF2B5EF4-FFF2-40B4-BE49-F238E27FC236}">
+                <a16:creationId xmlns:a16="http://schemas.microsoft.com/office/drawing/2014/main" id="{D562977B-5F06-12E1-E0CA-469A0EF301FF}"/>
+              </a:ext>
+            </a:extLst>
+          </p:cNvPr>
+          <p:cNvPicPr>
+            <a:picLocks noChangeAspect="1"/>
+          </p:cNvPicPr>
+          <p:nvPr/>
+        </p:nvPicPr>
+        <p:blipFill>
+          <a:blip r:embed="rId2"/>
+          <a:stretch>
+            <a:fillRect/>
+          </a:stretch>
+        </p:blipFill>
+        <p:spPr>
+          <a:xfrm>
+            <a:off x="1917948" y="775054"/>
+            <a:ext cx="7692684" cy="5754834"/>
+          </a:xfrm>
+          <a:prstGeom prst="rect">
+            <a:avLst/>
+          </a:prstGeom>
+        </p:spPr>
+      </p:pic>
+    </p:spTree>
+    <p:extLst>
+      <p:ext uri="{BB962C8B-B14F-4D97-AF65-F5344CB8AC3E}">
+        <p14:creationId xmlns:p14="http://schemas.microsoft.com/office/powerpoint/2010/main" val="507796417"/>
+      </p:ext>
+    </p:extLst>
+  </p:cSld>
+  <p:clrMapOvr>
+    <a:masterClrMapping/>
+  </p:clrMapOvr>
+  <mc:AlternateContent xmlns:mc="http://schemas.openxmlformats.org/markup-compatibility/2006" xmlns:p14="http://schemas.microsoft.com/office/powerpoint/2010/main">
+    <mc:Choice Requires="p14">
+      <p:transition spd="med" p14:dur="700">
+        <p:fade/>
+      </p:transition>
+    </mc:Choice>
+    <mc:Fallback xmlns="">
+      <p:transition spd="med">
+        <p:fade/>
+      </p:transition>
+    </mc:Fallback>
+  </mc:AlternateContent>
+</p:sld>
+</file>
+
+<file path=ppt/slides/slide14.xml><?xml version="1.0" encoding="utf-8"?>
 <p:sld xmlns:a="http://schemas.openxmlformats.org/drawingml/2006/main" xmlns:r="http://schemas.openxmlformats.org/officeDocument/2006/relationships" xmlns:p="http://schemas.openxmlformats.org/presentationml/2006/main">
   <p:cSld>
     <p:spTree>
@@ -5830,7 +7783,7 @@
 </p:sld>
 </file>
 
-<file path=ppt/slides/slide12.xml><?xml version="1.0" encoding="utf-8"?>
+<file path=ppt/slides/slide15.xml><?xml version="1.0" encoding="utf-8"?>
 <p:sld xmlns:a="http://schemas.openxmlformats.org/drawingml/2006/main" xmlns:r="http://schemas.openxmlformats.org/officeDocument/2006/relationships" xmlns:p="http://schemas.openxmlformats.org/presentationml/2006/main">
   <p:cSld>
     <p:spTree>
@@ -6447,338 +8400,6 @@
         <p:cNvPr id="1" name="">
           <a:extLst>
             <a:ext uri="{FF2B5EF4-FFF2-40B4-BE49-F238E27FC236}">
-              <a16:creationId xmlns:a16="http://schemas.microsoft.com/office/drawing/2014/main" id="{2E6E975E-860D-6646-38DB-C172C7242DC3}"/>
-            </a:ext>
-          </a:extLst>
-        </p:cNvPr>
-        <p:cNvGrpSpPr/>
-        <p:nvPr/>
-      </p:nvGrpSpPr>
-      <p:grpSpPr>
-        <a:xfrm>
-          <a:off x="0" y="0"/>
-          <a:ext cx="0" cy="0"/>
-          <a:chOff x="0" y="0"/>
-          <a:chExt cx="0" cy="0"/>
-        </a:xfrm>
-      </p:grpSpPr>
-      <p:sp>
-        <p:nvSpPr>
-          <p:cNvPr id="13" name="Title 12">
-            <a:extLst>
-              <a:ext uri="{FF2B5EF4-FFF2-40B4-BE49-F238E27FC236}">
-                <a16:creationId xmlns:a16="http://schemas.microsoft.com/office/drawing/2014/main" id="{C00FDE62-58DD-D34A-1D60-31C6EC1CD56E}"/>
-              </a:ext>
-            </a:extLst>
-          </p:cNvPr>
-          <p:cNvSpPr>
-            <a:spLocks noGrp="1"/>
-          </p:cNvSpPr>
-          <p:nvPr>
-            <p:ph type="title"/>
-          </p:nvPr>
-        </p:nvSpPr>
-        <p:spPr/>
-        <p:txBody>
-          <a:bodyPr>
-            <a:normAutofit/>
-          </a:bodyPr>
-          <a:lstStyle/>
-          <a:p>
-            <a:br>
-              <a:rPr lang="en-US" dirty="0"/>
-            </a:br>
-            <a:r>
-              <a:rPr lang="en-US" dirty="0">
-                <a:solidFill>
-                  <a:schemeClr val="accent1">
-                    <a:lumMod val="20000"/>
-                    <a:lumOff val="80000"/>
-                  </a:schemeClr>
-                </a:solidFill>
-              </a:rPr>
-              <a:t>What makes Dilithium post-quantum?</a:t>
-            </a:r>
-          </a:p>
-        </p:txBody>
-      </p:sp>
-      <p:sp>
-        <p:nvSpPr>
-          <p:cNvPr id="14" name="Content Placeholder 13">
-            <a:extLst>
-              <a:ext uri="{FF2B5EF4-FFF2-40B4-BE49-F238E27FC236}">
-                <a16:creationId xmlns:a16="http://schemas.microsoft.com/office/drawing/2014/main" id="{8B12B221-DEE4-54F8-8F5D-F6413EDE4CDF}"/>
-              </a:ext>
-            </a:extLst>
-          </p:cNvPr>
-          <p:cNvSpPr>
-            <a:spLocks noGrp="1"/>
-          </p:cNvSpPr>
-          <p:nvPr>
-            <p:ph idx="1"/>
-          </p:nvPr>
-        </p:nvSpPr>
-        <p:spPr/>
-        <p:txBody>
-          <a:bodyPr/>
-          <a:lstStyle/>
-          <a:p>
-            <a:r>
-              <a:rPr lang="en-US" sz="2400" dirty="0"/>
-              <a:t>Based on lattice problems  (for e.g. Shortest Vector , closest vector)</a:t>
-            </a:r>
-          </a:p>
-          <a:p>
-            <a:r>
-              <a:rPr lang="en-US" sz="2400" dirty="0"/>
-              <a:t>Extremely difficult to solve in high dimensions.</a:t>
-            </a:r>
-          </a:p>
-          <a:p>
-            <a:r>
-              <a:rPr lang="en-US" sz="2400" dirty="0"/>
-              <a:t>Not vulnerable to Shor’s algorithm</a:t>
-            </a:r>
-          </a:p>
-          <a:p>
-            <a:r>
-              <a:rPr lang="en-US" sz="2400" dirty="0"/>
-              <a:t>Standardized by NIST</a:t>
-            </a:r>
-          </a:p>
-        </p:txBody>
-      </p:sp>
-      <p:sp>
-        <p:nvSpPr>
-          <p:cNvPr id="3" name="Rectangle 2">
-            <a:extLst>
-              <a:ext uri="{FF2B5EF4-FFF2-40B4-BE49-F238E27FC236}">
-                <a16:creationId xmlns:a16="http://schemas.microsoft.com/office/drawing/2014/main" id="{D7A4470B-454D-0A61-04B5-9D71CEABDC02}"/>
-              </a:ext>
-            </a:extLst>
-          </p:cNvPr>
-          <p:cNvSpPr>
-            <a:spLocks noChangeArrowheads="1"/>
-          </p:cNvSpPr>
-          <p:nvPr/>
-        </p:nvSpPr>
-        <p:spPr bwMode="auto">
-          <a:xfrm>
-            <a:off x="0" y="0"/>
-            <a:ext cx="12188825" cy="0"/>
-          </a:xfrm>
-          <a:prstGeom prst="rect">
-            <a:avLst/>
-          </a:prstGeom>
-          <a:noFill/>
-          <a:ln>
-            <a:noFill/>
-          </a:ln>
-          <a:effectLst/>
-          <a:extLst>
-            <a:ext uri="{909E8E84-426E-40DD-AFC4-6F175D3DCCD1}">
-              <a14:hiddenFill xmlns:a14="http://schemas.microsoft.com/office/drawing/2010/main">
-                <a:solidFill>
-                  <a:schemeClr val="accent1"/>
-                </a:solidFill>
-              </a14:hiddenFill>
-            </a:ext>
-            <a:ext uri="{91240B29-F687-4F45-9708-019B960494DF}">
-              <a14:hiddenLine xmlns:a14="http://schemas.microsoft.com/office/drawing/2010/main" w="9525">
-                <a:solidFill>
-                  <a:schemeClr val="tx1"/>
-                </a:solidFill>
-                <a:miter lim="800000"/>
-                <a:headEnd/>
-                <a:tailEnd/>
-              </a14:hiddenLine>
-            </a:ext>
-            <a:ext uri="{AF507438-7753-43E0-B8FC-AC1667EBCBE1}">
-              <a14:hiddenEffects xmlns:a14="http://schemas.microsoft.com/office/drawing/2010/main">
-                <a:effectLst>
-                  <a:outerShdw dist="35921" dir="2700000" algn="ctr" rotWithShape="0">
-                    <a:schemeClr val="bg2"/>
-                  </a:outerShdw>
-                </a:effectLst>
-              </a14:hiddenEffects>
-            </a:ext>
-          </a:extLst>
-        </p:spPr>
-        <p:txBody>
-          <a:bodyPr vert="horz" wrap="none" lIns="91440" tIns="45720" rIns="91440" bIns="45720" numCol="1" anchor="ctr" anchorCtr="0" compatLnSpc="1">
-            <a:prstTxWarp prst="textNoShape">
-              <a:avLst/>
-            </a:prstTxWarp>
-            <a:spAutoFit/>
-          </a:bodyPr>
-          <a:lstStyle/>
-          <a:p>
-            <a:pPr marL="0" marR="0" lvl="0" indent="0" algn="l" defTabSz="914400" rtl="0" eaLnBrk="0" fontAlgn="base" latinLnBrk="0" hangingPunct="0">
-              <a:lnSpc>
-                <a:spcPct val="100000"/>
-              </a:lnSpc>
-              <a:spcBef>
-                <a:spcPct val="0"/>
-              </a:spcBef>
-              <a:spcAft>
-                <a:spcPct val="0"/>
-              </a:spcAft>
-              <a:buClrTx/>
-              <a:buSzTx/>
-              <a:buFontTx/>
-              <a:buChar char="•"/>
-              <a:tabLst/>
-            </a:pPr>
-            <a:r>
-              <a:rPr kumimoji="0" lang="en-PK" altLang="en-PK" sz="1800" b="0" i="0" u="none" strike="noStrike" cap="none" normalizeH="0" baseline="0">
-                <a:ln>
-                  <a:noFill/>
-                </a:ln>
-                <a:solidFill>
-                  <a:schemeClr val="tx1"/>
-                </a:solidFill>
-                <a:effectLst/>
-                <a:latin typeface="Arial" panose="020B0604020202020204" pitchFamily="34" charset="0"/>
-              </a:rPr>
-              <a:t>Classical schemes (RSA, ECC) rely on </a:t>
-            </a:r>
-            <a:r>
-              <a:rPr kumimoji="0" lang="en-PK" altLang="en-PK" sz="1800" b="1" i="0" u="none" strike="noStrike" cap="none" normalizeH="0" baseline="0">
-                <a:ln>
-                  <a:noFill/>
-                </a:ln>
-                <a:solidFill>
-                  <a:schemeClr val="tx1"/>
-                </a:solidFill>
-                <a:effectLst/>
-                <a:latin typeface="Arial" panose="020B0604020202020204" pitchFamily="34" charset="0"/>
-              </a:rPr>
-              <a:t>hard math problems</a:t>
-            </a:r>
-            <a:r>
-              <a:rPr kumimoji="0" lang="en-PK" altLang="en-PK" sz="1800" b="0" i="0" u="none" strike="noStrike" cap="none" normalizeH="0" baseline="0">
-                <a:ln>
-                  <a:noFill/>
-                </a:ln>
-                <a:solidFill>
-                  <a:schemeClr val="tx1"/>
-                </a:solidFill>
-                <a:effectLst/>
-                <a:latin typeface="Arial" panose="020B0604020202020204" pitchFamily="34" charset="0"/>
-              </a:rPr>
-              <a:t>.</a:t>
-            </a:r>
-          </a:p>
-          <a:p>
-            <a:pPr marL="0" marR="0" lvl="0" indent="0" algn="l" defTabSz="914400" rtl="0" eaLnBrk="0" fontAlgn="base" latinLnBrk="0" hangingPunct="0">
-              <a:lnSpc>
-                <a:spcPct val="100000"/>
-              </a:lnSpc>
-              <a:spcBef>
-                <a:spcPct val="0"/>
-              </a:spcBef>
-              <a:spcAft>
-                <a:spcPct val="0"/>
-              </a:spcAft>
-              <a:buClrTx/>
-              <a:buSzTx/>
-              <a:buFontTx/>
-              <a:buChar char="•"/>
-              <a:tabLst/>
-            </a:pPr>
-            <a:endParaRPr kumimoji="0" lang="en-PK" altLang="en-PK" sz="1800" b="0" i="0" u="none" strike="noStrike" cap="none" normalizeH="0" baseline="0">
-              <a:ln>
-                <a:noFill/>
-              </a:ln>
-              <a:solidFill>
-                <a:schemeClr val="tx1"/>
-              </a:solidFill>
-              <a:effectLst/>
-              <a:latin typeface="Arial" panose="020B0604020202020204" pitchFamily="34" charset="0"/>
-            </a:endParaRPr>
-          </a:p>
-        </p:txBody>
-      </p:sp>
-      <p:pic>
-        <p:nvPicPr>
-          <p:cNvPr id="4102" name="Picture 6" descr="Keystone of Post-Quantum Cryptography">
-            <a:extLst>
-              <a:ext uri="{FF2B5EF4-FFF2-40B4-BE49-F238E27FC236}">
-                <a16:creationId xmlns:a16="http://schemas.microsoft.com/office/drawing/2014/main" id="{0026BBA5-C3CC-99B8-0AD0-4E8A181114FF}"/>
-              </a:ext>
-            </a:extLst>
-          </p:cNvPr>
-          <p:cNvPicPr>
-            <a:picLocks noChangeAspect="1" noChangeArrowheads="1"/>
-          </p:cNvPicPr>
-          <p:nvPr/>
-        </p:nvPicPr>
-        <p:blipFill>
-          <a:blip r:embed="rId2">
-            <a:extLst>
-              <a:ext uri="{28A0092B-C50C-407E-A947-70E740481C1C}">
-                <a14:useLocalDpi xmlns:a14="http://schemas.microsoft.com/office/drawing/2010/main" val="0"/>
-              </a:ext>
-            </a:extLst>
-          </a:blip>
-          <a:srcRect/>
-          <a:stretch>
-            <a:fillRect/>
-          </a:stretch>
-        </p:blipFill>
-        <p:spPr bwMode="auto">
-          <a:xfrm>
-            <a:off x="7966620" y="2852936"/>
-            <a:ext cx="2880320" cy="2893179"/>
-          </a:xfrm>
-          <a:prstGeom prst="rect">
-            <a:avLst/>
-          </a:prstGeom>
-          <a:noFill/>
-          <a:extLst>
-            <a:ext uri="{909E8E84-426E-40DD-AFC4-6F175D3DCCD1}">
-              <a14:hiddenFill xmlns:a14="http://schemas.microsoft.com/office/drawing/2010/main">
-                <a:solidFill>
-                  <a:srgbClr val="FFFFFF"/>
-                </a:solidFill>
-              </a14:hiddenFill>
-            </a:ext>
-          </a:extLst>
-        </p:spPr>
-      </p:pic>
-    </p:spTree>
-    <p:extLst>
-      <p:ext uri="{BB962C8B-B14F-4D97-AF65-F5344CB8AC3E}">
-        <p14:creationId xmlns:p14="http://schemas.microsoft.com/office/powerpoint/2010/main" val="2460290198"/>
-      </p:ext>
-    </p:extLst>
-  </p:cSld>
-  <p:clrMapOvr>
-    <a:masterClrMapping/>
-  </p:clrMapOvr>
-  <mc:AlternateContent xmlns:mc="http://schemas.openxmlformats.org/markup-compatibility/2006" xmlns:p14="http://schemas.microsoft.com/office/powerpoint/2010/main">
-    <mc:Choice Requires="p14">
-      <p:transition spd="med" p14:dur="700">
-        <p:fade/>
-      </p:transition>
-    </mc:Choice>
-    <mc:Fallback xmlns="">
-      <p:transition spd="med">
-        <p:fade/>
-      </p:transition>
-    </mc:Fallback>
-  </mc:AlternateContent>
-</p:sld>
-</file>
-
-<file path=ppt/slides/slide5.xml><?xml version="1.0" encoding="utf-8"?>
-<p:sld xmlns:a="http://schemas.openxmlformats.org/drawingml/2006/main" xmlns:r="http://schemas.openxmlformats.org/officeDocument/2006/relationships" xmlns:p="http://schemas.openxmlformats.org/presentationml/2006/main">
-  <p:cSld>
-    <p:spTree>
-      <p:nvGrpSpPr>
-        <p:cNvPr id="1" name="">
-          <a:extLst>
-            <a:ext uri="{FF2B5EF4-FFF2-40B4-BE49-F238E27FC236}">
               <a16:creationId xmlns:a16="http://schemas.microsoft.com/office/drawing/2014/main" id="{6A8CC239-9215-EAD3-052C-784A231AAF5C}"/>
             </a:ext>
           </a:extLst>
@@ -7064,7 +8685,7 @@
 </p:sld>
 </file>
 
-<file path=ppt/slides/slide6.xml><?xml version="1.0" encoding="utf-8"?>
+<file path=ppt/slides/slide5.xml><?xml version="1.0" encoding="utf-8"?>
 <p:sld xmlns:a="http://schemas.openxmlformats.org/drawingml/2006/main" xmlns:r="http://schemas.openxmlformats.org/officeDocument/2006/relationships" xmlns:p="http://schemas.openxmlformats.org/presentationml/2006/main">
   <p:cSld>
     <p:spTree>
@@ -7518,7 +9139,7 @@
 </p:sld>
 </file>
 
-<file path=ppt/slides/slide7.xml><?xml version="1.0" encoding="utf-8"?>
+<file path=ppt/slides/slide6.xml><?xml version="1.0" encoding="utf-8"?>
 <p:sld xmlns:a="http://schemas.openxmlformats.org/drawingml/2006/main" xmlns:r="http://schemas.openxmlformats.org/officeDocument/2006/relationships" xmlns:p="http://schemas.openxmlformats.org/presentationml/2006/main">
   <p:cSld>
     <p:spTree>
@@ -7817,130 +9438,7 @@
 </p:sld>
 </file>
 
-<file path=ppt/slides/slide8.xml><?xml version="1.0" encoding="utf-8"?>
-<p:sld xmlns:a="http://schemas.openxmlformats.org/drawingml/2006/main" xmlns:r="http://schemas.openxmlformats.org/officeDocument/2006/relationships" xmlns:p="http://schemas.openxmlformats.org/presentationml/2006/main">
-  <p:cSld>
-    <p:spTree>
-      <p:nvGrpSpPr>
-        <p:cNvPr id="1" name="">
-          <a:extLst>
-            <a:ext uri="{FF2B5EF4-FFF2-40B4-BE49-F238E27FC236}">
-              <a16:creationId xmlns:a16="http://schemas.microsoft.com/office/drawing/2014/main" id="{4BE1253C-61ED-95EB-83F6-02E88404FF3D}"/>
-            </a:ext>
-          </a:extLst>
-        </p:cNvPr>
-        <p:cNvGrpSpPr/>
-        <p:nvPr/>
-      </p:nvGrpSpPr>
-      <p:grpSpPr>
-        <a:xfrm>
-          <a:off x="0" y="0"/>
-          <a:ext cx="0" cy="0"/>
-          <a:chOff x="0" y="0"/>
-          <a:chExt cx="0" cy="0"/>
-        </a:xfrm>
-      </p:grpSpPr>
-      <p:sp>
-        <p:nvSpPr>
-          <p:cNvPr id="2" name="Title 1">
-            <a:extLst>
-              <a:ext uri="{FF2B5EF4-FFF2-40B4-BE49-F238E27FC236}">
-                <a16:creationId xmlns:a16="http://schemas.microsoft.com/office/drawing/2014/main" id="{7887892D-7999-15A6-E547-43B3116D95F6}"/>
-              </a:ext>
-            </a:extLst>
-          </p:cNvPr>
-          <p:cNvSpPr>
-            <a:spLocks noGrp="1"/>
-          </p:cNvSpPr>
-          <p:nvPr>
-            <p:ph type="ctrTitle"/>
-          </p:nvPr>
-        </p:nvSpPr>
-        <p:spPr>
-          <a:xfrm>
-            <a:off x="1053852" y="0"/>
-            <a:ext cx="8735325" cy="756568"/>
-          </a:xfrm>
-        </p:spPr>
-        <p:txBody>
-          <a:bodyPr>
-            <a:normAutofit/>
-          </a:bodyPr>
-          <a:lstStyle/>
-          <a:p>
-            <a:pPr algn="ctr"/>
-            <a:r>
-              <a:rPr lang="en-US" sz="3600" dirty="0">
-                <a:solidFill>
-                  <a:schemeClr val="accent1"/>
-                </a:solidFill>
-              </a:rPr>
-              <a:t>GANTT CHART</a:t>
-            </a:r>
-            <a:endParaRPr lang="en-PK" sz="3600" dirty="0">
-              <a:solidFill>
-                <a:schemeClr val="accent1"/>
-              </a:solidFill>
-            </a:endParaRPr>
-          </a:p>
-        </p:txBody>
-      </p:sp>
-      <p:pic>
-        <p:nvPicPr>
-          <p:cNvPr id="9" name="Picture 8">
-            <a:extLst>
-              <a:ext uri="{FF2B5EF4-FFF2-40B4-BE49-F238E27FC236}">
-                <a16:creationId xmlns:a16="http://schemas.microsoft.com/office/drawing/2014/main" id="{D562977B-5F06-12E1-E0CA-469A0EF301FF}"/>
-              </a:ext>
-            </a:extLst>
-          </p:cNvPr>
-          <p:cNvPicPr>
-            <a:picLocks noChangeAspect="1"/>
-          </p:cNvPicPr>
-          <p:nvPr/>
-        </p:nvPicPr>
-        <p:blipFill>
-          <a:blip r:embed="rId2"/>
-          <a:stretch>
-            <a:fillRect/>
-          </a:stretch>
-        </p:blipFill>
-        <p:spPr>
-          <a:xfrm>
-            <a:off x="1917948" y="775054"/>
-            <a:ext cx="7692684" cy="5754834"/>
-          </a:xfrm>
-          <a:prstGeom prst="rect">
-            <a:avLst/>
-          </a:prstGeom>
-        </p:spPr>
-      </p:pic>
-    </p:spTree>
-    <p:extLst>
-      <p:ext uri="{BB962C8B-B14F-4D97-AF65-F5344CB8AC3E}">
-        <p14:creationId xmlns:p14="http://schemas.microsoft.com/office/powerpoint/2010/main" val="507796417"/>
-      </p:ext>
-    </p:extLst>
-  </p:cSld>
-  <p:clrMapOvr>
-    <a:masterClrMapping/>
-  </p:clrMapOvr>
-  <mc:AlternateContent xmlns:mc="http://schemas.openxmlformats.org/markup-compatibility/2006" xmlns:p14="http://schemas.microsoft.com/office/powerpoint/2010/main">
-    <mc:Choice Requires="p14">
-      <p:transition spd="med" p14:dur="700">
-        <p:fade/>
-      </p:transition>
-    </mc:Choice>
-    <mc:Fallback xmlns="">
-      <p:transition spd="med">
-        <p:fade/>
-      </p:transition>
-    </mc:Fallback>
-  </mc:AlternateContent>
-</p:sld>
-</file>
-
-<file path=ppt/slides/slide9.xml><?xml version="1.0" encoding="utf-8"?>
+<file path=ppt/slides/slide7.xml><?xml version="1.0" encoding="utf-8"?>
 <p:sld xmlns:a="http://schemas.openxmlformats.org/drawingml/2006/main" xmlns:r="http://schemas.openxmlformats.org/officeDocument/2006/relationships" xmlns:p="http://schemas.openxmlformats.org/presentationml/2006/main">
   <p:cSld>
     <p:spTree>
@@ -8030,7 +9528,7 @@
         </p:blipFill>
         <p:spPr bwMode="auto">
           <a:xfrm>
-            <a:off x="2061964" y="770383"/>
+            <a:off x="2133972" y="756568"/>
             <a:ext cx="6984777" cy="5826969"/>
           </a:xfrm>
           <a:prstGeom prst="rect">
@@ -8049,13 +9547,1237 @@
   <p:clrMapOvr>
     <a:masterClrMapping/>
   </p:clrMapOvr>
-  <mc:AlternateContent xmlns:mc="http://schemas.openxmlformats.org/markup-compatibility/2006">
-    <mc:Choice xmlns:p14="http://schemas.microsoft.com/office/powerpoint/2010/main" Requires="p14">
+  <mc:AlternateContent xmlns:mc="http://schemas.openxmlformats.org/markup-compatibility/2006" xmlns:p14="http://schemas.microsoft.com/office/powerpoint/2010/main">
+    <mc:Choice Requires="p14">
       <p:transition spd="med" p14:dur="700">
         <p:fade/>
       </p:transition>
     </mc:Choice>
-    <mc:Fallback>
+    <mc:Fallback xmlns="">
+      <p:transition spd="med">
+        <p:fade/>
+      </p:transition>
+    </mc:Fallback>
+  </mc:AlternateContent>
+</p:sld>
+</file>
+
+<file path=ppt/slides/slide8.xml><?xml version="1.0" encoding="utf-8"?>
+<p:sld xmlns:a="http://schemas.openxmlformats.org/drawingml/2006/main" xmlns:r="http://schemas.openxmlformats.org/officeDocument/2006/relationships" xmlns:p="http://schemas.openxmlformats.org/presentationml/2006/main">
+  <p:cSld>
+    <p:spTree>
+      <p:nvGrpSpPr>
+        <p:cNvPr id="1" name="">
+          <a:extLst>
+            <a:ext uri="{FF2B5EF4-FFF2-40B4-BE49-F238E27FC236}">
+              <a16:creationId xmlns:a16="http://schemas.microsoft.com/office/drawing/2014/main" id="{5DFBA20C-7563-087C-658C-9299E2531ECA}"/>
+            </a:ext>
+          </a:extLst>
+        </p:cNvPr>
+        <p:cNvGrpSpPr/>
+        <p:nvPr/>
+      </p:nvGrpSpPr>
+      <p:grpSpPr>
+        <a:xfrm>
+          <a:off x="0" y="0"/>
+          <a:ext cx="0" cy="0"/>
+          <a:chOff x="0" y="0"/>
+          <a:chExt cx="0" cy="0"/>
+        </a:xfrm>
+      </p:grpSpPr>
+      <p:sp>
+        <p:nvSpPr>
+          <p:cNvPr id="2" name="Title 1">
+            <a:extLst>
+              <a:ext uri="{FF2B5EF4-FFF2-40B4-BE49-F238E27FC236}">
+                <a16:creationId xmlns:a16="http://schemas.microsoft.com/office/drawing/2014/main" id="{89D4BC4C-96EA-F45C-8CAC-FBB75059BE6C}"/>
+              </a:ext>
+            </a:extLst>
+          </p:cNvPr>
+          <p:cNvSpPr>
+            <a:spLocks noGrp="1"/>
+          </p:cNvSpPr>
+          <p:nvPr>
+            <p:ph type="ctrTitle"/>
+          </p:nvPr>
+        </p:nvSpPr>
+        <p:spPr>
+          <a:xfrm>
+            <a:off x="1053852" y="34506"/>
+            <a:ext cx="8735325" cy="756568"/>
+          </a:xfrm>
+        </p:spPr>
+        <p:txBody>
+          <a:bodyPr>
+            <a:normAutofit/>
+          </a:bodyPr>
+          <a:lstStyle/>
+          <a:p>
+            <a:pPr algn="ctr"/>
+            <a:r>
+              <a:rPr lang="en-US" sz="3600" dirty="0" err="1">
+                <a:solidFill>
+                  <a:schemeClr val="accent1"/>
+                </a:solidFill>
+              </a:rPr>
+              <a:t>Dilithium</a:t>
+            </a:r>
+            <a:r>
+              <a:rPr lang="en-US" sz="3600" dirty="0">
+                <a:solidFill>
+                  <a:schemeClr val="accent1"/>
+                </a:solidFill>
+              </a:rPr>
+              <a:t> High-Level Architecture</a:t>
+            </a:r>
+            <a:endParaRPr lang="en-PK" sz="3600" dirty="0">
+              <a:solidFill>
+                <a:schemeClr val="accent1"/>
+              </a:solidFill>
+            </a:endParaRPr>
+          </a:p>
+        </p:txBody>
+      </p:sp>
+      <p:pic>
+        <p:nvPicPr>
+          <p:cNvPr id="5" name="Picture 4">
+            <a:extLst>
+              <a:ext uri="{FF2B5EF4-FFF2-40B4-BE49-F238E27FC236}">
+                <a16:creationId xmlns:a16="http://schemas.microsoft.com/office/drawing/2014/main" id="{88A32EA7-F5C3-DF67-8C83-9EF34FEA2D8F}"/>
+              </a:ext>
+            </a:extLst>
+          </p:cNvPr>
+          <p:cNvPicPr>
+            <a:picLocks noChangeAspect="1"/>
+          </p:cNvPicPr>
+          <p:nvPr/>
+        </p:nvPicPr>
+        <p:blipFill>
+          <a:blip r:embed="rId2"/>
+          <a:stretch>
+            <a:fillRect/>
+          </a:stretch>
+        </p:blipFill>
+        <p:spPr>
+          <a:xfrm>
+            <a:off x="2068246" y="908720"/>
+            <a:ext cx="6706536" cy="5553850"/>
+          </a:xfrm>
+          <a:prstGeom prst="rect">
+            <a:avLst/>
+          </a:prstGeom>
+        </p:spPr>
+      </p:pic>
+      <p:sp>
+        <p:nvSpPr>
+          <p:cNvPr id="6" name="TextBox 5">
+            <a:extLst>
+              <a:ext uri="{FF2B5EF4-FFF2-40B4-BE49-F238E27FC236}">
+                <a16:creationId xmlns:a16="http://schemas.microsoft.com/office/drawing/2014/main" id="{6EAECE4F-8045-73FF-FAAE-EBBC0C417926}"/>
+              </a:ext>
+            </a:extLst>
+          </p:cNvPr>
+          <p:cNvSpPr txBox="1"/>
+          <p:nvPr/>
+        </p:nvSpPr>
+        <p:spPr>
+          <a:xfrm>
+            <a:off x="9334772" y="5589240"/>
+            <a:ext cx="2088232" cy="646331"/>
+          </a:xfrm>
+          <a:prstGeom prst="rect">
+            <a:avLst/>
+          </a:prstGeom>
+          <a:noFill/>
+        </p:spPr>
+        <p:txBody>
+          <a:bodyPr wrap="square" rtlCol="0">
+            <a:spAutoFit/>
+          </a:bodyPr>
+          <a:lstStyle/>
+          <a:p>
+            <a:r>
+              <a:rPr lang="en-US" sz="1200" dirty="0"/>
+              <a:t>Fig. </a:t>
+            </a:r>
+            <a:r>
+              <a:rPr lang="en-US" sz="1200" dirty="0" err="1"/>
+              <a:t>Dilithium</a:t>
+            </a:r>
+            <a:r>
+              <a:rPr lang="en-US" sz="1200" dirty="0"/>
+              <a:t> High-Level Architecture. Reproduced from [4]</a:t>
+            </a:r>
+          </a:p>
+        </p:txBody>
+      </p:sp>
+    </p:spTree>
+    <p:extLst>
+      <p:ext uri="{BB962C8B-B14F-4D97-AF65-F5344CB8AC3E}">
+        <p14:creationId xmlns:p14="http://schemas.microsoft.com/office/powerpoint/2010/main" val="3478977026"/>
+      </p:ext>
+    </p:extLst>
+  </p:cSld>
+  <p:clrMapOvr>
+    <a:masterClrMapping/>
+  </p:clrMapOvr>
+  <mc:AlternateContent xmlns:mc="http://schemas.openxmlformats.org/markup-compatibility/2006" xmlns:p14="http://schemas.microsoft.com/office/powerpoint/2010/main">
+    <mc:Choice Requires="p14">
+      <p:transition spd="med" p14:dur="700">
+        <p:fade/>
+      </p:transition>
+    </mc:Choice>
+    <mc:Fallback xmlns="">
+      <p:transition spd="med">
+        <p:fade/>
+      </p:transition>
+    </mc:Fallback>
+  </mc:AlternateContent>
+</p:sld>
+</file>
+
+<file path=ppt/slides/slide9.xml><?xml version="1.0" encoding="utf-8"?>
+<p:sld xmlns:a="http://schemas.openxmlformats.org/drawingml/2006/main" xmlns:r="http://schemas.openxmlformats.org/officeDocument/2006/relationships" xmlns:p="http://schemas.openxmlformats.org/presentationml/2006/main">
+  <p:cSld>
+    <p:spTree>
+      <p:nvGrpSpPr>
+        <p:cNvPr id="1" name="">
+          <a:extLst>
+            <a:ext uri="{FF2B5EF4-FFF2-40B4-BE49-F238E27FC236}">
+              <a16:creationId xmlns:a16="http://schemas.microsoft.com/office/drawing/2014/main" id="{4E92F861-CA69-949B-1653-77B76E0FA4D1}"/>
+            </a:ext>
+          </a:extLst>
+        </p:cNvPr>
+        <p:cNvGrpSpPr/>
+        <p:nvPr/>
+      </p:nvGrpSpPr>
+      <p:grpSpPr>
+        <a:xfrm>
+          <a:off x="0" y="0"/>
+          <a:ext cx="0" cy="0"/>
+          <a:chOff x="0" y="0"/>
+          <a:chExt cx="0" cy="0"/>
+        </a:xfrm>
+      </p:grpSpPr>
+      <p:sp>
+        <p:nvSpPr>
+          <p:cNvPr id="13" name="Title 12">
+            <a:extLst>
+              <a:ext uri="{FF2B5EF4-FFF2-40B4-BE49-F238E27FC236}">
+                <a16:creationId xmlns:a16="http://schemas.microsoft.com/office/drawing/2014/main" id="{91B6D81A-E85B-EBBF-27B9-2B4D69AA3E50}"/>
+              </a:ext>
+            </a:extLst>
+          </p:cNvPr>
+          <p:cNvSpPr>
+            <a:spLocks noGrp="1"/>
+          </p:cNvSpPr>
+          <p:nvPr>
+            <p:ph type="title"/>
+          </p:nvPr>
+        </p:nvSpPr>
+        <p:spPr/>
+        <p:txBody>
+          <a:bodyPr>
+            <a:normAutofit/>
+          </a:bodyPr>
+          <a:lstStyle/>
+          <a:p>
+            <a:br>
+              <a:rPr lang="en-US" dirty="0">
+                <a:solidFill>
+                  <a:schemeClr val="accent1">
+                    <a:lumMod val="20000"/>
+                    <a:lumOff val="80000"/>
+                  </a:schemeClr>
+                </a:solidFill>
+              </a:rPr>
+            </a:br>
+            <a:r>
+              <a:rPr lang="en-US" dirty="0" err="1">
+                <a:solidFill>
+                  <a:schemeClr val="accent1">
+                    <a:lumMod val="20000"/>
+                    <a:lumOff val="80000"/>
+                  </a:schemeClr>
+                </a:solidFill>
+              </a:rPr>
+              <a:t>Dilithium</a:t>
+            </a:r>
+            <a:r>
+              <a:rPr lang="en-US" dirty="0">
+                <a:solidFill>
+                  <a:schemeClr val="accent1">
+                    <a:lumMod val="20000"/>
+                    <a:lumOff val="80000"/>
+                  </a:schemeClr>
+                </a:solidFill>
+              </a:rPr>
+              <a:t> Major Components</a:t>
+            </a:r>
+          </a:p>
+        </p:txBody>
+      </p:sp>
+      <p:sp>
+        <p:nvSpPr>
+          <p:cNvPr id="14" name="Content Placeholder 13">
+            <a:extLst>
+              <a:ext uri="{FF2B5EF4-FFF2-40B4-BE49-F238E27FC236}">
+                <a16:creationId xmlns:a16="http://schemas.microsoft.com/office/drawing/2014/main" id="{EBA5B21D-DEE7-6D40-7BAD-AD649EB645D3}"/>
+              </a:ext>
+            </a:extLst>
+          </p:cNvPr>
+          <p:cNvSpPr>
+            <a:spLocks noGrp="1"/>
+          </p:cNvSpPr>
+          <p:nvPr>
+            <p:ph idx="1"/>
+          </p:nvPr>
+        </p:nvSpPr>
+        <p:spPr/>
+        <p:txBody>
+          <a:bodyPr>
+            <a:normAutofit/>
+          </a:bodyPr>
+          <a:lstStyle/>
+          <a:p>
+            <a:r>
+              <a:rPr lang="en-US" sz="2100" dirty="0"/>
+              <a:t>Keccak engine (SHAKE-128/256)				</a:t>
+            </a:r>
+          </a:p>
+          <a:p>
+            <a:r>
+              <a:rPr lang="en-US" sz="2100" dirty="0"/>
+              <a:t>Numeric Theoretic Transform (NTT) module  (Poly Multiplication)</a:t>
+            </a:r>
+          </a:p>
+          <a:p>
+            <a:r>
+              <a:rPr lang="en-US" sz="2100" dirty="0"/>
+              <a:t>Memory</a:t>
+            </a:r>
+          </a:p>
+          <a:p>
+            <a:r>
+              <a:rPr lang="en-US" sz="2100" dirty="0"/>
+              <a:t>Sampler</a:t>
+            </a:r>
+          </a:p>
+          <a:p>
+            <a:r>
+              <a:rPr lang="en-US" sz="2100" dirty="0"/>
+              <a:t>Rounding/decomposition logic</a:t>
+            </a:r>
+          </a:p>
+          <a:p>
+            <a:r>
+              <a:rPr lang="en-US" sz="2100" dirty="0" err="1"/>
+              <a:t>Dilithium</a:t>
+            </a:r>
+            <a:r>
+              <a:rPr lang="en-US" sz="2100" dirty="0"/>
+              <a:t> Main Controller</a:t>
+            </a:r>
+          </a:p>
+          <a:p>
+            <a:endParaRPr lang="en-US" sz="2100" dirty="0"/>
+          </a:p>
+          <a:p>
+            <a:endParaRPr lang="en-US" sz="2100" dirty="0"/>
+          </a:p>
+          <a:p>
+            <a:endParaRPr lang="en-US" sz="2100" dirty="0"/>
+          </a:p>
+          <a:p>
+            <a:endParaRPr lang="en-US" sz="2100" dirty="0"/>
+          </a:p>
+          <a:p>
+            <a:endParaRPr lang="en-US" sz="2100" dirty="0"/>
+          </a:p>
+        </p:txBody>
+      </p:sp>
+      <p:sp>
+        <p:nvSpPr>
+          <p:cNvPr id="3" name="Rectangle 2">
+            <a:extLst>
+              <a:ext uri="{FF2B5EF4-FFF2-40B4-BE49-F238E27FC236}">
+                <a16:creationId xmlns:a16="http://schemas.microsoft.com/office/drawing/2014/main" id="{A6E33B56-8E1D-9EFF-D2D4-52AC92406CF9}"/>
+              </a:ext>
+            </a:extLst>
+          </p:cNvPr>
+          <p:cNvSpPr>
+            <a:spLocks noChangeArrowheads="1"/>
+          </p:cNvSpPr>
+          <p:nvPr/>
+        </p:nvSpPr>
+        <p:spPr bwMode="auto">
+          <a:xfrm>
+            <a:off x="0" y="0"/>
+            <a:ext cx="12188825" cy="0"/>
+          </a:xfrm>
+          <a:prstGeom prst="rect">
+            <a:avLst/>
+          </a:prstGeom>
+          <a:noFill/>
+          <a:ln>
+            <a:noFill/>
+          </a:ln>
+          <a:effectLst/>
+          <a:extLst>
+            <a:ext uri="{909E8E84-426E-40DD-AFC4-6F175D3DCCD1}">
+              <a14:hiddenFill xmlns:a14="http://schemas.microsoft.com/office/drawing/2010/main">
+                <a:solidFill>
+                  <a:schemeClr val="accent1"/>
+                </a:solidFill>
+              </a14:hiddenFill>
+            </a:ext>
+            <a:ext uri="{91240B29-F687-4F45-9708-019B960494DF}">
+              <a14:hiddenLine xmlns:a14="http://schemas.microsoft.com/office/drawing/2010/main" w="9525">
+                <a:solidFill>
+                  <a:schemeClr val="tx1"/>
+                </a:solidFill>
+                <a:miter lim="800000"/>
+                <a:headEnd/>
+                <a:tailEnd/>
+              </a14:hiddenLine>
+            </a:ext>
+            <a:ext uri="{AF507438-7753-43E0-B8FC-AC1667EBCBE1}">
+              <a14:hiddenEffects xmlns:a14="http://schemas.microsoft.com/office/drawing/2010/main">
+                <a:effectLst>
+                  <a:outerShdw dist="35921" dir="2700000" algn="ctr" rotWithShape="0">
+                    <a:schemeClr val="bg2"/>
+                  </a:outerShdw>
+                </a:effectLst>
+              </a14:hiddenEffects>
+            </a:ext>
+          </a:extLst>
+        </p:spPr>
+        <p:txBody>
+          <a:bodyPr vert="horz" wrap="none" lIns="91440" tIns="45720" rIns="91440" bIns="45720" numCol="1" anchor="ctr" anchorCtr="0" compatLnSpc="1">
+            <a:prstTxWarp prst="textNoShape">
+              <a:avLst/>
+            </a:prstTxWarp>
+            <a:spAutoFit/>
+          </a:bodyPr>
+          <a:lstStyle/>
+          <a:p>
+            <a:pPr marL="0" marR="0" lvl="0" indent="0" algn="l" defTabSz="914400" rtl="0" eaLnBrk="0" fontAlgn="base" latinLnBrk="0" hangingPunct="0">
+              <a:lnSpc>
+                <a:spcPct val="100000"/>
+              </a:lnSpc>
+              <a:spcBef>
+                <a:spcPct val="0"/>
+              </a:spcBef>
+              <a:spcAft>
+                <a:spcPct val="0"/>
+              </a:spcAft>
+              <a:buClrTx/>
+              <a:buSzTx/>
+              <a:buFontTx/>
+              <a:buChar char="•"/>
+              <a:tabLst/>
+            </a:pPr>
+            <a:r>
+              <a:rPr kumimoji="0" lang="en-PK" altLang="en-PK" sz="1800" b="0" i="0" u="none" strike="noStrike" cap="none" normalizeH="0" baseline="0">
+                <a:ln>
+                  <a:noFill/>
+                </a:ln>
+                <a:solidFill>
+                  <a:schemeClr val="tx1"/>
+                </a:solidFill>
+                <a:effectLst/>
+                <a:latin typeface="Arial" panose="020B0604020202020204" pitchFamily="34" charset="0"/>
+              </a:rPr>
+              <a:t>Classical schemes (RSA, ECC) rely on </a:t>
+            </a:r>
+            <a:r>
+              <a:rPr kumimoji="0" lang="en-PK" altLang="en-PK" sz="1800" b="1" i="0" u="none" strike="noStrike" cap="none" normalizeH="0" baseline="0">
+                <a:ln>
+                  <a:noFill/>
+                </a:ln>
+                <a:solidFill>
+                  <a:schemeClr val="tx1"/>
+                </a:solidFill>
+                <a:effectLst/>
+                <a:latin typeface="Arial" panose="020B0604020202020204" pitchFamily="34" charset="0"/>
+              </a:rPr>
+              <a:t>hard math problems</a:t>
+            </a:r>
+            <a:r>
+              <a:rPr kumimoji="0" lang="en-PK" altLang="en-PK" sz="1800" b="0" i="0" u="none" strike="noStrike" cap="none" normalizeH="0" baseline="0">
+                <a:ln>
+                  <a:noFill/>
+                </a:ln>
+                <a:solidFill>
+                  <a:schemeClr val="tx1"/>
+                </a:solidFill>
+                <a:effectLst/>
+                <a:latin typeface="Arial" panose="020B0604020202020204" pitchFamily="34" charset="0"/>
+              </a:rPr>
+              <a:t>.</a:t>
+            </a:r>
+          </a:p>
+          <a:p>
+            <a:pPr marL="0" marR="0" lvl="0" indent="0" algn="l" defTabSz="914400" rtl="0" eaLnBrk="0" fontAlgn="base" latinLnBrk="0" hangingPunct="0">
+              <a:lnSpc>
+                <a:spcPct val="100000"/>
+              </a:lnSpc>
+              <a:spcBef>
+                <a:spcPct val="0"/>
+              </a:spcBef>
+              <a:spcAft>
+                <a:spcPct val="0"/>
+              </a:spcAft>
+              <a:buClrTx/>
+              <a:buSzTx/>
+              <a:buFontTx/>
+              <a:buChar char="•"/>
+              <a:tabLst/>
+            </a:pPr>
+            <a:endParaRPr kumimoji="0" lang="en-PK" altLang="en-PK" sz="1800" b="0" i="0" u="none" strike="noStrike" cap="none" normalizeH="0" baseline="0">
+              <a:ln>
+                <a:noFill/>
+              </a:ln>
+              <a:solidFill>
+                <a:schemeClr val="tx1"/>
+              </a:solidFill>
+              <a:effectLst/>
+              <a:latin typeface="Arial" panose="020B0604020202020204" pitchFamily="34" charset="0"/>
+            </a:endParaRPr>
+          </a:p>
+        </p:txBody>
+      </p:sp>
+      <mc:AlternateContent xmlns:mc="http://schemas.openxmlformats.org/markup-compatibility/2006" xmlns:p14="http://schemas.microsoft.com/office/powerpoint/2010/main">
+        <mc:Choice Requires="p14">
+          <p:contentPart p14:bwMode="auto" r:id="rId2">
+            <p14:nvContentPartPr>
+              <p14:cNvPr id="19" name="Ink 18">
+                <a:extLst>
+                  <a:ext uri="{FF2B5EF4-FFF2-40B4-BE49-F238E27FC236}">
+                    <a16:creationId xmlns:a16="http://schemas.microsoft.com/office/drawing/2014/main" id="{7D38856B-5A55-9F92-6CB4-BDC49C6364D4}"/>
+                  </a:ext>
+                </a:extLst>
+              </p14:cNvPr>
+              <p14:cNvContentPartPr/>
+              <p14:nvPr/>
+            </p14:nvContentPartPr>
+            <p14:xfrm>
+              <a:off x="6579619" y="1784510"/>
+              <a:ext cx="648000" cy="197280"/>
+            </p14:xfrm>
+          </p:contentPart>
+        </mc:Choice>
+        <mc:Fallback xmlns="">
+          <p:pic>
+            <p:nvPicPr>
+              <p:cNvPr id="19" name="Ink 18">
+                <a:extLst>
+                  <a:ext uri="{FF2B5EF4-FFF2-40B4-BE49-F238E27FC236}">
+                    <a16:creationId xmlns:a16="http://schemas.microsoft.com/office/drawing/2014/main" id="{7D38856B-5A55-9F92-6CB4-BDC49C6364D4}"/>
+                  </a:ext>
+                </a:extLst>
+              </p:cNvPr>
+              <p:cNvPicPr/>
+              <p:nvPr/>
+            </p:nvPicPr>
+            <p:blipFill>
+              <a:blip r:embed="rId3"/>
+              <a:stretch>
+                <a:fillRect/>
+              </a:stretch>
+            </p:blipFill>
+            <p:spPr>
+              <a:xfrm>
+                <a:off x="6525979" y="1676510"/>
+                <a:ext cx="755640" cy="412920"/>
+              </a:xfrm>
+              <a:prstGeom prst="rect">
+                <a:avLst/>
+              </a:prstGeom>
+            </p:spPr>
+          </p:pic>
+        </mc:Fallback>
+      </mc:AlternateContent>
+      <mc:AlternateContent xmlns:mc="http://schemas.openxmlformats.org/markup-compatibility/2006" xmlns:p14="http://schemas.microsoft.com/office/powerpoint/2010/main">
+        <mc:Choice Requires="p14">
+          <p:contentPart p14:bwMode="auto" r:id="rId4">
+            <p14:nvContentPartPr>
+              <p14:cNvPr id="20" name="Ink 19">
+                <a:extLst>
+                  <a:ext uri="{FF2B5EF4-FFF2-40B4-BE49-F238E27FC236}">
+                    <a16:creationId xmlns:a16="http://schemas.microsoft.com/office/drawing/2014/main" id="{92EDFBAC-3F91-3A45-9EC9-0DD0B00B2F6B}"/>
+                  </a:ext>
+                </a:extLst>
+              </p14:cNvPr>
+              <p14:cNvContentPartPr/>
+              <p14:nvPr/>
+            </p14:nvContentPartPr>
+            <p14:xfrm>
+              <a:off x="6862219" y="1879910"/>
+              <a:ext cx="443160" cy="18000"/>
+            </p14:xfrm>
+          </p:contentPart>
+        </mc:Choice>
+        <mc:Fallback xmlns="">
+          <p:pic>
+            <p:nvPicPr>
+              <p:cNvPr id="20" name="Ink 19">
+                <a:extLst>
+                  <a:ext uri="{FF2B5EF4-FFF2-40B4-BE49-F238E27FC236}">
+                    <a16:creationId xmlns:a16="http://schemas.microsoft.com/office/drawing/2014/main" id="{92EDFBAC-3F91-3A45-9EC9-0DD0B00B2F6B}"/>
+                  </a:ext>
+                </a:extLst>
+              </p:cNvPr>
+              <p:cNvPicPr/>
+              <p:nvPr/>
+            </p:nvPicPr>
+            <p:blipFill>
+              <a:blip r:embed="rId5"/>
+              <a:stretch>
+                <a:fillRect/>
+              </a:stretch>
+            </p:blipFill>
+            <p:spPr>
+              <a:xfrm>
+                <a:off x="6808219" y="1771910"/>
+                <a:ext cx="550800" cy="233640"/>
+              </a:xfrm>
+              <a:prstGeom prst="rect">
+                <a:avLst/>
+              </a:prstGeom>
+            </p:spPr>
+          </p:pic>
+        </mc:Fallback>
+      </mc:AlternateContent>
+      <mc:AlternateContent xmlns:mc="http://schemas.openxmlformats.org/markup-compatibility/2006" xmlns:p14="http://schemas.microsoft.com/office/powerpoint/2010/main">
+        <mc:Choice Requires="p14">
+          <p:contentPart p14:bwMode="auto" r:id="rId6">
+            <p14:nvContentPartPr>
+              <p14:cNvPr id="22" name="Ink 21">
+                <a:extLst>
+                  <a:ext uri="{FF2B5EF4-FFF2-40B4-BE49-F238E27FC236}">
+                    <a16:creationId xmlns:a16="http://schemas.microsoft.com/office/drawing/2014/main" id="{83430293-4B97-B789-DE87-3B0F1E44CFED}"/>
+                  </a:ext>
+                </a:extLst>
+              </p14:cNvPr>
+              <p14:cNvContentPartPr/>
+              <p14:nvPr/>
+            </p14:nvContentPartPr>
+            <p14:xfrm>
+              <a:off x="1683259" y="1862630"/>
+              <a:ext cx="3632400" cy="9000"/>
+            </p14:xfrm>
+          </p:contentPart>
+        </mc:Choice>
+        <mc:Fallback xmlns="">
+          <p:pic>
+            <p:nvPicPr>
+              <p:cNvPr id="22" name="Ink 21">
+                <a:extLst>
+                  <a:ext uri="{FF2B5EF4-FFF2-40B4-BE49-F238E27FC236}">
+                    <a16:creationId xmlns:a16="http://schemas.microsoft.com/office/drawing/2014/main" id="{83430293-4B97-B789-DE87-3B0F1E44CFED}"/>
+                  </a:ext>
+                </a:extLst>
+              </p:cNvPr>
+              <p:cNvPicPr/>
+              <p:nvPr/>
+            </p:nvPicPr>
+            <p:blipFill>
+              <a:blip r:embed="rId7"/>
+              <a:stretch>
+                <a:fillRect/>
+              </a:stretch>
+            </p:blipFill>
+            <p:spPr>
+              <a:xfrm>
+                <a:off x="1629259" y="1754630"/>
+                <a:ext cx="3740040" cy="224640"/>
+              </a:xfrm>
+              <a:prstGeom prst="rect">
+                <a:avLst/>
+              </a:prstGeom>
+            </p:spPr>
+          </p:pic>
+        </mc:Fallback>
+      </mc:AlternateContent>
+      <mc:AlternateContent xmlns:mc="http://schemas.openxmlformats.org/markup-compatibility/2006" xmlns:p14="http://schemas.microsoft.com/office/powerpoint/2010/main">
+        <mc:Choice Requires="p14">
+          <p:contentPart p14:bwMode="auto" r:id="rId8">
+            <p14:nvContentPartPr>
+              <p14:cNvPr id="23" name="Ink 22">
+                <a:extLst>
+                  <a:ext uri="{FF2B5EF4-FFF2-40B4-BE49-F238E27FC236}">
+                    <a16:creationId xmlns:a16="http://schemas.microsoft.com/office/drawing/2014/main" id="{B6634B98-6E51-B366-5919-EB3F03D1FA11}"/>
+                  </a:ext>
+                </a:extLst>
+              </p14:cNvPr>
+              <p14:cNvContentPartPr/>
+              <p14:nvPr/>
+            </p14:nvContentPartPr>
+            <p14:xfrm>
+              <a:off x="1683259" y="1879910"/>
+              <a:ext cx="3588840" cy="94680"/>
+            </p14:xfrm>
+          </p:contentPart>
+        </mc:Choice>
+        <mc:Fallback xmlns="">
+          <p:pic>
+            <p:nvPicPr>
+              <p:cNvPr id="23" name="Ink 22">
+                <a:extLst>
+                  <a:ext uri="{FF2B5EF4-FFF2-40B4-BE49-F238E27FC236}">
+                    <a16:creationId xmlns:a16="http://schemas.microsoft.com/office/drawing/2014/main" id="{B6634B98-6E51-B366-5919-EB3F03D1FA11}"/>
+                  </a:ext>
+                </a:extLst>
+              </p:cNvPr>
+              <p:cNvPicPr/>
+              <p:nvPr/>
+            </p:nvPicPr>
+            <p:blipFill>
+              <a:blip r:embed="rId9"/>
+              <a:stretch>
+                <a:fillRect/>
+              </a:stretch>
+            </p:blipFill>
+            <p:spPr>
+              <a:xfrm>
+                <a:off x="1629259" y="1771910"/>
+                <a:ext cx="3696480" cy="310320"/>
+              </a:xfrm>
+              <a:prstGeom prst="rect">
+                <a:avLst/>
+              </a:prstGeom>
+            </p:spPr>
+          </p:pic>
+        </mc:Fallback>
+      </mc:AlternateContent>
+      <mc:AlternateContent xmlns:mc="http://schemas.openxmlformats.org/markup-compatibility/2006" xmlns:p14="http://schemas.microsoft.com/office/powerpoint/2010/main">
+        <mc:Choice Requires="p14">
+          <p:contentPart p14:bwMode="auto" r:id="rId10">
+            <p14:nvContentPartPr>
+              <p14:cNvPr id="24" name="Ink 23">
+                <a:extLst>
+                  <a:ext uri="{FF2B5EF4-FFF2-40B4-BE49-F238E27FC236}">
+                    <a16:creationId xmlns:a16="http://schemas.microsoft.com/office/drawing/2014/main" id="{9B7A955A-ECD2-27C2-3127-3E9F8F64474E}"/>
+                  </a:ext>
+                </a:extLst>
+              </p14:cNvPr>
+              <p14:cNvContentPartPr/>
+              <p14:nvPr/>
+            </p14:nvContentPartPr>
+            <p14:xfrm>
+              <a:off x="981844" y="2108150"/>
+              <a:ext cx="7995240" cy="430200"/>
+            </p14:xfrm>
+          </p:contentPart>
+        </mc:Choice>
+        <mc:Fallback xmlns="">
+          <p:pic>
+            <p:nvPicPr>
+              <p:cNvPr id="24" name="Ink 23">
+                <a:extLst>
+                  <a:ext uri="{FF2B5EF4-FFF2-40B4-BE49-F238E27FC236}">
+                    <a16:creationId xmlns:a16="http://schemas.microsoft.com/office/drawing/2014/main" id="{9B7A955A-ECD2-27C2-3127-3E9F8F64474E}"/>
+                  </a:ext>
+                </a:extLst>
+              </p:cNvPr>
+              <p:cNvPicPr/>
+              <p:nvPr/>
+            </p:nvPicPr>
+            <p:blipFill>
+              <a:blip r:embed="rId11"/>
+              <a:stretch>
+                <a:fillRect/>
+              </a:stretch>
+            </p:blipFill>
+            <p:spPr>
+              <a:xfrm>
+                <a:off x="927844" y="2000510"/>
+                <a:ext cx="8102880" cy="645840"/>
+              </a:xfrm>
+              <a:prstGeom prst="rect">
+                <a:avLst/>
+              </a:prstGeom>
+            </p:spPr>
+          </p:pic>
+        </mc:Fallback>
+      </mc:AlternateContent>
+      <mc:AlternateContent xmlns:mc="http://schemas.openxmlformats.org/markup-compatibility/2006" xmlns:p14="http://schemas.microsoft.com/office/powerpoint/2010/main">
+        <mc:Choice Requires="p14">
+          <p:contentPart p14:bwMode="auto" r:id="rId12">
+            <p14:nvContentPartPr>
+              <p14:cNvPr id="25" name="Ink 24">
+                <a:extLst>
+                  <a:ext uri="{FF2B5EF4-FFF2-40B4-BE49-F238E27FC236}">
+                    <a16:creationId xmlns:a16="http://schemas.microsoft.com/office/drawing/2014/main" id="{EC12B54C-505C-C92D-44A8-2687CCCD7BC9}"/>
+                  </a:ext>
+                </a:extLst>
+              </p14:cNvPr>
+              <p14:cNvContentPartPr/>
+              <p14:nvPr/>
+            </p14:nvContentPartPr>
+            <p14:xfrm>
+              <a:off x="1345939" y="1871270"/>
+              <a:ext cx="4723920" cy="198000"/>
+            </p14:xfrm>
+          </p:contentPart>
+        </mc:Choice>
+        <mc:Fallback xmlns="">
+          <p:pic>
+            <p:nvPicPr>
+              <p:cNvPr id="25" name="Ink 24">
+                <a:extLst>
+                  <a:ext uri="{FF2B5EF4-FFF2-40B4-BE49-F238E27FC236}">
+                    <a16:creationId xmlns:a16="http://schemas.microsoft.com/office/drawing/2014/main" id="{EC12B54C-505C-C92D-44A8-2687CCCD7BC9}"/>
+                  </a:ext>
+                </a:extLst>
+              </p:cNvPr>
+              <p:cNvPicPr/>
+              <p:nvPr/>
+            </p:nvPicPr>
+            <p:blipFill>
+              <a:blip r:embed="rId13"/>
+              <a:stretch>
+                <a:fillRect/>
+              </a:stretch>
+            </p:blipFill>
+            <p:spPr>
+              <a:xfrm>
+                <a:off x="1292299" y="1763270"/>
+                <a:ext cx="4831560" cy="413640"/>
+              </a:xfrm>
+              <a:prstGeom prst="rect">
+                <a:avLst/>
+              </a:prstGeom>
+            </p:spPr>
+          </p:pic>
+        </mc:Fallback>
+      </mc:AlternateContent>
+      <mc:AlternateContent xmlns:mc="http://schemas.openxmlformats.org/markup-compatibility/2006" xmlns:p14="http://schemas.microsoft.com/office/powerpoint/2010/main">
+        <mc:Choice Requires="p14">
+          <p:contentPart p14:bwMode="auto" r:id="rId14">
+            <p14:nvContentPartPr>
+              <p14:cNvPr id="26" name="Ink 25">
+                <a:extLst>
+                  <a:ext uri="{FF2B5EF4-FFF2-40B4-BE49-F238E27FC236}">
+                    <a16:creationId xmlns:a16="http://schemas.microsoft.com/office/drawing/2014/main" id="{1DED07D1-CB05-BEFF-B56F-06A7CC9D74E9}"/>
+                  </a:ext>
+                </a:extLst>
+              </p14:cNvPr>
+              <p14:cNvContentPartPr/>
+              <p14:nvPr/>
+            </p14:nvContentPartPr>
+            <p14:xfrm>
+              <a:off x="8394739" y="2357990"/>
+              <a:ext cx="381960" cy="93960"/>
+            </p14:xfrm>
+          </p:contentPart>
+        </mc:Choice>
+        <mc:Fallback xmlns="">
+          <p:pic>
+            <p:nvPicPr>
+              <p:cNvPr id="26" name="Ink 25">
+                <a:extLst>
+                  <a:ext uri="{FF2B5EF4-FFF2-40B4-BE49-F238E27FC236}">
+                    <a16:creationId xmlns:a16="http://schemas.microsoft.com/office/drawing/2014/main" id="{1DED07D1-CB05-BEFF-B56F-06A7CC9D74E9}"/>
+                  </a:ext>
+                </a:extLst>
+              </p:cNvPr>
+              <p:cNvPicPr/>
+              <p:nvPr/>
+            </p:nvPicPr>
+            <p:blipFill>
+              <a:blip r:embed="rId15"/>
+              <a:stretch>
+                <a:fillRect/>
+              </a:stretch>
+            </p:blipFill>
+            <p:spPr>
+              <a:xfrm>
+                <a:off x="8340739" y="2250350"/>
+                <a:ext cx="489600" cy="309600"/>
+              </a:xfrm>
+              <a:prstGeom prst="rect">
+                <a:avLst/>
+              </a:prstGeom>
+            </p:spPr>
+          </p:pic>
+        </mc:Fallback>
+      </mc:AlternateContent>
+      <mc:AlternateContent xmlns:mc="http://schemas.openxmlformats.org/markup-compatibility/2006" xmlns:p14="http://schemas.microsoft.com/office/powerpoint/2010/main">
+        <mc:Choice Requires="p14">
+          <p:contentPart p14:bwMode="auto" r:id="rId16">
+            <p14:nvContentPartPr>
+              <p14:cNvPr id="33" name="Ink 32">
+                <a:extLst>
+                  <a:ext uri="{FF2B5EF4-FFF2-40B4-BE49-F238E27FC236}">
+                    <a16:creationId xmlns:a16="http://schemas.microsoft.com/office/drawing/2014/main" id="{CCF1E7FC-FA64-B39A-4BD6-522BCB34D436}"/>
+                  </a:ext>
+                </a:extLst>
+              </p14:cNvPr>
+              <p14:cNvContentPartPr/>
+              <p14:nvPr/>
+            </p14:nvContentPartPr>
+            <p14:xfrm>
+              <a:off x="3255379" y="2469230"/>
+              <a:ext cx="360" cy="360"/>
+            </p14:xfrm>
+          </p:contentPart>
+        </mc:Choice>
+        <mc:Fallback xmlns="">
+          <p:pic>
+            <p:nvPicPr>
+              <p:cNvPr id="33" name="Ink 32">
+                <a:extLst>
+                  <a:ext uri="{FF2B5EF4-FFF2-40B4-BE49-F238E27FC236}">
+                    <a16:creationId xmlns:a16="http://schemas.microsoft.com/office/drawing/2014/main" id="{CCF1E7FC-FA64-B39A-4BD6-522BCB34D436}"/>
+                  </a:ext>
+                </a:extLst>
+              </p:cNvPr>
+              <p:cNvPicPr/>
+              <p:nvPr/>
+            </p:nvPicPr>
+            <p:blipFill>
+              <a:blip r:embed="rId17"/>
+              <a:stretch>
+                <a:fillRect/>
+              </a:stretch>
+            </p:blipFill>
+            <p:spPr>
+              <a:xfrm>
+                <a:off x="3201739" y="2361590"/>
+                <a:ext cx="108000" cy="216000"/>
+              </a:xfrm>
+              <a:prstGeom prst="rect">
+                <a:avLst/>
+              </a:prstGeom>
+            </p:spPr>
+          </p:pic>
+        </mc:Fallback>
+      </mc:AlternateContent>
+      <mc:AlternateContent xmlns:mc="http://schemas.openxmlformats.org/markup-compatibility/2006" xmlns:p14="http://schemas.microsoft.com/office/powerpoint/2010/main">
+        <mc:Choice Requires="p14">
+          <p:contentPart p14:bwMode="auto" r:id="rId18">
+            <p14:nvContentPartPr>
+              <p14:cNvPr id="34" name="Ink 33">
+                <a:extLst>
+                  <a:ext uri="{FF2B5EF4-FFF2-40B4-BE49-F238E27FC236}">
+                    <a16:creationId xmlns:a16="http://schemas.microsoft.com/office/drawing/2014/main" id="{CD76DFC4-F64D-FC88-89C7-9E3E5487B1BC}"/>
+                  </a:ext>
+                </a:extLst>
+              </p14:cNvPr>
+              <p14:cNvContentPartPr/>
+              <p14:nvPr/>
+            </p14:nvContentPartPr>
+            <p14:xfrm>
+              <a:off x="1948219" y="2366990"/>
+              <a:ext cx="360" cy="360"/>
+            </p14:xfrm>
+          </p:contentPart>
+        </mc:Choice>
+        <mc:Fallback xmlns="">
+          <p:pic>
+            <p:nvPicPr>
+              <p:cNvPr id="34" name="Ink 33">
+                <a:extLst>
+                  <a:ext uri="{FF2B5EF4-FFF2-40B4-BE49-F238E27FC236}">
+                    <a16:creationId xmlns:a16="http://schemas.microsoft.com/office/drawing/2014/main" id="{CD76DFC4-F64D-FC88-89C7-9E3E5487B1BC}"/>
+                  </a:ext>
+                </a:extLst>
+              </p:cNvPr>
+              <p:cNvPicPr/>
+              <p:nvPr/>
+            </p:nvPicPr>
+            <p:blipFill>
+              <a:blip r:embed="rId17"/>
+              <a:stretch>
+                <a:fillRect/>
+              </a:stretch>
+            </p:blipFill>
+            <p:spPr>
+              <a:xfrm>
+                <a:off x="1894219" y="2258990"/>
+                <a:ext cx="108000" cy="216000"/>
+              </a:xfrm>
+              <a:prstGeom prst="rect">
+                <a:avLst/>
+              </a:prstGeom>
+            </p:spPr>
+          </p:pic>
+        </mc:Fallback>
+      </mc:AlternateContent>
+      <mc:AlternateContent xmlns:mc="http://schemas.openxmlformats.org/markup-compatibility/2006" xmlns:p14="http://schemas.microsoft.com/office/powerpoint/2010/main">
+        <mc:Choice Requires="p14">
+          <p:contentPart p14:bwMode="auto" r:id="rId19">
+            <p14:nvContentPartPr>
+              <p14:cNvPr id="35" name="Ink 34">
+                <a:extLst>
+                  <a:ext uri="{FF2B5EF4-FFF2-40B4-BE49-F238E27FC236}">
+                    <a16:creationId xmlns:a16="http://schemas.microsoft.com/office/drawing/2014/main" id="{C5425807-6480-6E5B-1D72-E08F9C2F3886}"/>
+                  </a:ext>
+                </a:extLst>
+              </p14:cNvPr>
+              <p14:cNvContentPartPr/>
+              <p14:nvPr/>
+            </p14:nvContentPartPr>
+            <p14:xfrm>
+              <a:off x="1948219" y="2366990"/>
+              <a:ext cx="360" cy="360"/>
+            </p14:xfrm>
+          </p:contentPart>
+        </mc:Choice>
+        <mc:Fallback xmlns="">
+          <p:pic>
+            <p:nvPicPr>
+              <p:cNvPr id="35" name="Ink 34">
+                <a:extLst>
+                  <a:ext uri="{FF2B5EF4-FFF2-40B4-BE49-F238E27FC236}">
+                    <a16:creationId xmlns:a16="http://schemas.microsoft.com/office/drawing/2014/main" id="{C5425807-6480-6E5B-1D72-E08F9C2F3886}"/>
+                  </a:ext>
+                </a:extLst>
+              </p:cNvPr>
+              <p:cNvPicPr/>
+              <p:nvPr/>
+            </p:nvPicPr>
+            <p:blipFill>
+              <a:blip r:embed="rId17"/>
+              <a:stretch>
+                <a:fillRect/>
+              </a:stretch>
+            </p:blipFill>
+            <p:spPr>
+              <a:xfrm>
+                <a:off x="1894219" y="2258990"/>
+                <a:ext cx="108000" cy="216000"/>
+              </a:xfrm>
+              <a:prstGeom prst="rect">
+                <a:avLst/>
+              </a:prstGeom>
+            </p:spPr>
+          </p:pic>
+        </mc:Fallback>
+      </mc:AlternateContent>
+      <mc:AlternateContent xmlns:mc="http://schemas.openxmlformats.org/markup-compatibility/2006" xmlns:p14="http://schemas.microsoft.com/office/powerpoint/2010/main">
+        <mc:Choice Requires="p14">
+          <p:contentPart p14:bwMode="auto" r:id="rId20">
+            <p14:nvContentPartPr>
+              <p14:cNvPr id="36" name="Ink 35">
+                <a:extLst>
+                  <a:ext uri="{FF2B5EF4-FFF2-40B4-BE49-F238E27FC236}">
+                    <a16:creationId xmlns:a16="http://schemas.microsoft.com/office/drawing/2014/main" id="{9BDD51D3-4E38-B184-79D5-DA95E37AAFFD}"/>
+                  </a:ext>
+                </a:extLst>
+              </p14:cNvPr>
+              <p14:cNvContentPartPr/>
+              <p14:nvPr/>
+            </p14:nvContentPartPr>
+            <p14:xfrm>
+              <a:off x="1631779" y="1853990"/>
+              <a:ext cx="360" cy="360"/>
+            </p14:xfrm>
+          </p:contentPart>
+        </mc:Choice>
+        <mc:Fallback xmlns="">
+          <p:pic>
+            <p:nvPicPr>
+              <p:cNvPr id="36" name="Ink 35">
+                <a:extLst>
+                  <a:ext uri="{FF2B5EF4-FFF2-40B4-BE49-F238E27FC236}">
+                    <a16:creationId xmlns:a16="http://schemas.microsoft.com/office/drawing/2014/main" id="{9BDD51D3-4E38-B184-79D5-DA95E37AAFFD}"/>
+                  </a:ext>
+                </a:extLst>
+              </p:cNvPr>
+              <p:cNvPicPr/>
+              <p:nvPr/>
+            </p:nvPicPr>
+            <p:blipFill>
+              <a:blip r:embed="rId17"/>
+              <a:stretch>
+                <a:fillRect/>
+              </a:stretch>
+            </p:blipFill>
+            <p:spPr>
+              <a:xfrm>
+                <a:off x="1578139" y="1745990"/>
+                <a:ext cx="108000" cy="216000"/>
+              </a:xfrm>
+              <a:prstGeom prst="rect">
+                <a:avLst/>
+              </a:prstGeom>
+            </p:spPr>
+          </p:pic>
+        </mc:Fallback>
+      </mc:AlternateContent>
+      <mc:AlternateContent xmlns:mc="http://schemas.openxmlformats.org/markup-compatibility/2006" xmlns:p14="http://schemas.microsoft.com/office/powerpoint/2010/main">
+        <mc:Choice Requires="p14">
+          <p:contentPart p14:bwMode="auto" r:id="rId21">
+            <p14:nvContentPartPr>
+              <p14:cNvPr id="37" name="Ink 36">
+                <a:extLst>
+                  <a:ext uri="{FF2B5EF4-FFF2-40B4-BE49-F238E27FC236}">
+                    <a16:creationId xmlns:a16="http://schemas.microsoft.com/office/drawing/2014/main" id="{02AC71A0-6D66-187A-17FE-EBA0328F16BC}"/>
+                  </a:ext>
+                </a:extLst>
+              </p14:cNvPr>
+              <p14:cNvContentPartPr/>
+              <p14:nvPr/>
+            </p14:nvContentPartPr>
+            <p14:xfrm>
+              <a:off x="1631779" y="1853990"/>
+              <a:ext cx="360" cy="360"/>
+            </p14:xfrm>
+          </p:contentPart>
+        </mc:Choice>
+        <mc:Fallback xmlns="">
+          <p:pic>
+            <p:nvPicPr>
+              <p:cNvPr id="37" name="Ink 36">
+                <a:extLst>
+                  <a:ext uri="{FF2B5EF4-FFF2-40B4-BE49-F238E27FC236}">
+                    <a16:creationId xmlns:a16="http://schemas.microsoft.com/office/drawing/2014/main" id="{02AC71A0-6D66-187A-17FE-EBA0328F16BC}"/>
+                  </a:ext>
+                </a:extLst>
+              </p:cNvPr>
+              <p:cNvPicPr/>
+              <p:nvPr/>
+            </p:nvPicPr>
+            <p:blipFill>
+              <a:blip r:embed="rId17"/>
+              <a:stretch>
+                <a:fillRect/>
+              </a:stretch>
+            </p:blipFill>
+            <p:spPr>
+              <a:xfrm>
+                <a:off x="1578139" y="1745990"/>
+                <a:ext cx="108000" cy="216000"/>
+              </a:xfrm>
+              <a:prstGeom prst="rect">
+                <a:avLst/>
+              </a:prstGeom>
+            </p:spPr>
+          </p:pic>
+        </mc:Fallback>
+      </mc:AlternateContent>
+      <mc:AlternateContent xmlns:mc="http://schemas.openxmlformats.org/markup-compatibility/2006" xmlns:p14="http://schemas.microsoft.com/office/powerpoint/2010/main">
+        <mc:Choice Requires="p14">
+          <p:contentPart p14:bwMode="auto" r:id="rId22">
+            <p14:nvContentPartPr>
+              <p14:cNvPr id="42" name="Ink 41">
+                <a:extLst>
+                  <a:ext uri="{FF2B5EF4-FFF2-40B4-BE49-F238E27FC236}">
+                    <a16:creationId xmlns:a16="http://schemas.microsoft.com/office/drawing/2014/main" id="{CF0B4A2A-5184-EE42-BF1A-B9B715920D76}"/>
+                  </a:ext>
+                </a:extLst>
+              </p14:cNvPr>
+              <p14:cNvContentPartPr/>
+              <p14:nvPr/>
+            </p14:nvContentPartPr>
+            <p14:xfrm>
+              <a:off x="1147939" y="2784230"/>
+              <a:ext cx="2022840" cy="258120"/>
+            </p14:xfrm>
+          </p:contentPart>
+        </mc:Choice>
+        <mc:Fallback xmlns="">
+          <p:pic>
+            <p:nvPicPr>
+              <p:cNvPr id="42" name="Ink 41">
+                <a:extLst>
+                  <a:ext uri="{FF2B5EF4-FFF2-40B4-BE49-F238E27FC236}">
+                    <a16:creationId xmlns:a16="http://schemas.microsoft.com/office/drawing/2014/main" id="{CF0B4A2A-5184-EE42-BF1A-B9B715920D76}"/>
+                  </a:ext>
+                </a:extLst>
+              </p:cNvPr>
+              <p:cNvPicPr/>
+              <p:nvPr/>
+            </p:nvPicPr>
+            <p:blipFill>
+              <a:blip r:embed="rId23"/>
+              <a:stretch>
+                <a:fillRect/>
+              </a:stretch>
+            </p:blipFill>
+            <p:spPr>
+              <a:xfrm>
+                <a:off x="1094299" y="2676590"/>
+                <a:ext cx="2130480" cy="473760"/>
+              </a:xfrm>
+              <a:prstGeom prst="rect">
+                <a:avLst/>
+              </a:prstGeom>
+            </p:spPr>
+          </p:pic>
+        </mc:Fallback>
+      </mc:AlternateContent>
+      <mc:AlternateContent xmlns:mc="http://schemas.openxmlformats.org/markup-compatibility/2006" xmlns:p14="http://schemas.microsoft.com/office/powerpoint/2010/main">
+        <mc:Choice Requires="p14">
+          <p:contentPart p14:bwMode="auto" r:id="rId24">
+            <p14:nvContentPartPr>
+              <p14:cNvPr id="46" name="Ink 45">
+                <a:extLst>
+                  <a:ext uri="{FF2B5EF4-FFF2-40B4-BE49-F238E27FC236}">
+                    <a16:creationId xmlns:a16="http://schemas.microsoft.com/office/drawing/2014/main" id="{177FAFFE-1C8C-3942-AF0E-13FBB0004A1A}"/>
+                  </a:ext>
+                </a:extLst>
+              </p14:cNvPr>
+              <p14:cNvContentPartPr/>
+              <p14:nvPr/>
+            </p14:nvContentPartPr>
+            <p14:xfrm>
+              <a:off x="2359339" y="2834630"/>
+              <a:ext cx="349920" cy="28080"/>
+            </p14:xfrm>
+          </p:contentPart>
+        </mc:Choice>
+        <mc:Fallback xmlns="">
+          <p:pic>
+            <p:nvPicPr>
+              <p:cNvPr id="46" name="Ink 45">
+                <a:extLst>
+                  <a:ext uri="{FF2B5EF4-FFF2-40B4-BE49-F238E27FC236}">
+                    <a16:creationId xmlns:a16="http://schemas.microsoft.com/office/drawing/2014/main" id="{177FAFFE-1C8C-3942-AF0E-13FBB0004A1A}"/>
+                  </a:ext>
+                </a:extLst>
+              </p:cNvPr>
+              <p:cNvPicPr/>
+              <p:nvPr/>
+            </p:nvPicPr>
+            <p:blipFill>
+              <a:blip r:embed="rId25"/>
+              <a:stretch>
+                <a:fillRect/>
+              </a:stretch>
+            </p:blipFill>
+            <p:spPr>
+              <a:xfrm>
+                <a:off x="2305339" y="2726630"/>
+                <a:ext cx="457560" cy="243720"/>
+              </a:xfrm>
+              <a:prstGeom prst="rect">
+                <a:avLst/>
+              </a:prstGeom>
+            </p:spPr>
+          </p:pic>
+        </mc:Fallback>
+      </mc:AlternateContent>
+    </p:spTree>
+    <p:extLst>
+      <p:ext uri="{BB962C8B-B14F-4D97-AF65-F5344CB8AC3E}">
+        <p14:creationId xmlns:p14="http://schemas.microsoft.com/office/powerpoint/2010/main" val="4231224507"/>
+      </p:ext>
+    </p:extLst>
+  </p:cSld>
+  <p:clrMapOvr>
+    <a:masterClrMapping/>
+  </p:clrMapOvr>
+  <mc:AlternateContent xmlns:mc="http://schemas.openxmlformats.org/markup-compatibility/2006" xmlns:p14="http://schemas.microsoft.com/office/powerpoint/2010/main">
+    <mc:Choice Requires="p14">
+      <p:transition spd="med" p14:dur="700">
+        <p:fade/>
+      </p:transition>
+    </mc:Choice>
+    <mc:Fallback xmlns="">
       <p:transition spd="med">
         <p:fade/>
       </p:transition>
@@ -9015,151 +11737,6 @@
 </file>
 
 <file path=customXml/item1.xml><?xml version="1.0" encoding="utf-8"?>
-<p:properties xmlns:p="http://schemas.microsoft.com/office/2006/metadata/properties" xmlns:xsi="http://www.w3.org/2001/XMLSchema-instance" xmlns:pc="http://schemas.microsoft.com/office/infopath/2007/PartnerControls">
-  <documentManagement>
-    <LocPublishedLinkedAssetsLookup xmlns="4873beb7-5857-4685-be1f-d57550cc96cc" xsi:nil="true"/>
-    <ApprovalStatus xmlns="4873beb7-5857-4685-be1f-d57550cc96cc">InProgress</ApprovalStatus>
-    <MarketSpecific xmlns="4873beb7-5857-4685-be1f-d57550cc96cc">false</MarketSpecific>
-    <LocComments xmlns="4873beb7-5857-4685-be1f-d57550cc96cc" xsi:nil="true"/>
-    <LocLastLocAttemptVersionTypeLookup xmlns="4873beb7-5857-4685-be1f-d57550cc96cc" xsi:nil="true"/>
-    <DirectSourceMarket xmlns="4873beb7-5857-4685-be1f-d57550cc96cc" xsi:nil="true"/>
-    <ThumbnailAssetId xmlns="4873beb7-5857-4685-be1f-d57550cc96cc" xsi:nil="true"/>
-    <PrimaryImageGen xmlns="4873beb7-5857-4685-be1f-d57550cc96cc">false</PrimaryImageGen>
-    <LocNewPublishedVersionLookup xmlns="4873beb7-5857-4685-be1f-d57550cc96cc" xsi:nil="true"/>
-    <LegacyData xmlns="4873beb7-5857-4685-be1f-d57550cc96cc" xsi:nil="true"/>
-    <LocRecommendedHandoff xmlns="4873beb7-5857-4685-be1f-d57550cc96cc" xsi:nil="true"/>
-    <BusinessGroup xmlns="4873beb7-5857-4685-be1f-d57550cc96cc" xsi:nil="true"/>
-    <BlockPublish xmlns="4873beb7-5857-4685-be1f-d57550cc96cc">false</BlockPublish>
-    <TPFriendlyName xmlns="4873beb7-5857-4685-be1f-d57550cc96cc" xsi:nil="true"/>
-    <LocOverallPublishStatusLookup xmlns="4873beb7-5857-4685-be1f-d57550cc96cc" xsi:nil="true"/>
-    <NumericId xmlns="4873beb7-5857-4685-be1f-d57550cc96cc" xsi:nil="true"/>
-    <APEditor xmlns="4873beb7-5857-4685-be1f-d57550cc96cc">
-      <UserInfo>
-        <DisplayName/>
-        <AccountId xsi:nil="true"/>
-        <AccountType/>
-      </UserInfo>
-    </APEditor>
-    <SourceTitle xmlns="4873beb7-5857-4685-be1f-d57550cc96cc" xsi:nil="true"/>
-    <OpenTemplate xmlns="4873beb7-5857-4685-be1f-d57550cc96cc">true</OpenTemplate>
-    <LocOverallLocStatusLookup xmlns="4873beb7-5857-4685-be1f-d57550cc96cc" xsi:nil="true"/>
-    <UALocComments xmlns="4873beb7-5857-4685-be1f-d57550cc96cc" xsi:nil="true"/>
-    <ParentAssetId xmlns="4873beb7-5857-4685-be1f-d57550cc96cc" xsi:nil="true"/>
-    <IntlLangReviewDate xmlns="4873beb7-5857-4685-be1f-d57550cc96cc" xsi:nil="true"/>
-    <FeatureTagsTaxHTField0 xmlns="4873beb7-5857-4685-be1f-d57550cc96cc">
-      <Terms xmlns="http://schemas.microsoft.com/office/infopath/2007/PartnerControls"/>
-    </FeatureTagsTaxHTField0>
-    <PublishStatusLookup xmlns="4873beb7-5857-4685-be1f-d57550cc96cc">
-      <Value>1345093</Value>
-    </PublishStatusLookup>
-    <Providers xmlns="4873beb7-5857-4685-be1f-d57550cc96cc" xsi:nil="true"/>
-    <MachineTranslated xmlns="4873beb7-5857-4685-be1f-d57550cc96cc">false</MachineTranslated>
-    <OriginalSourceMarket xmlns="4873beb7-5857-4685-be1f-d57550cc96cc" xsi:nil="true"/>
-    <APDescription xmlns="4873beb7-5857-4685-be1f-d57550cc96cc">This simple template design works for technology and  businesses, but it's versatile enough to use in other contexts.  It features multiple slide layouts designed for widescreen (16x9 resolution) and includes a sample SmartArt list and chart that are easily editable.</APDescription>
-    <ClipArtFilename xmlns="4873beb7-5857-4685-be1f-d57550cc96cc" xsi:nil="true"/>
-    <ContentItem xmlns="4873beb7-5857-4685-be1f-d57550cc96cc" xsi:nil="true"/>
-    <TPInstallLocation xmlns="4873beb7-5857-4685-be1f-d57550cc96cc" xsi:nil="true"/>
-    <PublishTargets xmlns="4873beb7-5857-4685-be1f-d57550cc96cc">OfficeOnlineVNext</PublishTargets>
-    <TimesCloned xmlns="4873beb7-5857-4685-be1f-d57550cc96cc" xsi:nil="true"/>
-    <AssetStart xmlns="4873beb7-5857-4685-be1f-d57550cc96cc">2011-11-26T00:30:00+00:00</AssetStart>
-    <Provider xmlns="4873beb7-5857-4685-be1f-d57550cc96cc" xsi:nil="true"/>
-    <AcquiredFrom xmlns="4873beb7-5857-4685-be1f-d57550cc96cc">Internal MS</AcquiredFrom>
-    <FriendlyTitle xmlns="4873beb7-5857-4685-be1f-d57550cc96cc" xsi:nil="true"/>
-    <LastHandOff xmlns="4873beb7-5857-4685-be1f-d57550cc96cc" xsi:nil="true"/>
-    <TPClientViewer xmlns="4873beb7-5857-4685-be1f-d57550cc96cc" xsi:nil="true"/>
-    <TemplateStatus xmlns="4873beb7-5857-4685-be1f-d57550cc96cc">Complete</TemplateStatus>
-    <Downloads xmlns="4873beb7-5857-4685-be1f-d57550cc96cc">0</Downloads>
-    <OOCacheId xmlns="4873beb7-5857-4685-be1f-d57550cc96cc" xsi:nil="true"/>
-    <IsDeleted xmlns="4873beb7-5857-4685-be1f-d57550cc96cc">false</IsDeleted>
-    <LocPublishedDependentAssetsLookup xmlns="4873beb7-5857-4685-be1f-d57550cc96cc" xsi:nil="true"/>
-    <TPExecutable xmlns="4873beb7-5857-4685-be1f-d57550cc96cc" xsi:nil="true"/>
-    <EditorialTags xmlns="4873beb7-5857-4685-be1f-d57550cc96cc" xsi:nil="true"/>
-    <SubmitterId xmlns="4873beb7-5857-4685-be1f-d57550cc96cc" xsi:nil="true"/>
-    <ApprovalLog xmlns="4873beb7-5857-4685-be1f-d57550cc96cc" xsi:nil="true"/>
-    <AssetType xmlns="4873beb7-5857-4685-be1f-d57550cc96cc">TP</AssetType>
-    <BugNumber xmlns="4873beb7-5857-4685-be1f-d57550cc96cc" xsi:nil="true"/>
-    <CSXSubmissionDate xmlns="4873beb7-5857-4685-be1f-d57550cc96cc" xsi:nil="true"/>
-    <CSXUpdate xmlns="4873beb7-5857-4685-be1f-d57550cc96cc">false</CSXUpdate>
-    <Milestone xmlns="4873beb7-5857-4685-be1f-d57550cc96cc" xsi:nil="true"/>
-    <RecommendationsModifier xmlns="4873beb7-5857-4685-be1f-d57550cc96cc" xsi:nil="true"/>
-    <OriginAsset xmlns="4873beb7-5857-4685-be1f-d57550cc96cc" xsi:nil="true"/>
-    <TPComponent xmlns="4873beb7-5857-4685-be1f-d57550cc96cc" xsi:nil="true"/>
-    <AssetId xmlns="4873beb7-5857-4685-be1f-d57550cc96cc">TP102787989</AssetId>
-    <IntlLocPriority xmlns="4873beb7-5857-4685-be1f-d57550cc96cc" xsi:nil="true"/>
-    <PolicheckWords xmlns="4873beb7-5857-4685-be1f-d57550cc96cc" xsi:nil="true"/>
-    <TPLaunchHelpLink xmlns="4873beb7-5857-4685-be1f-d57550cc96cc" xsi:nil="true"/>
-    <TPApplication xmlns="4873beb7-5857-4685-be1f-d57550cc96cc" xsi:nil="true"/>
-    <CrawlForDependencies xmlns="4873beb7-5857-4685-be1f-d57550cc96cc">false</CrawlForDependencies>
-    <HandoffToMSDN xmlns="4873beb7-5857-4685-be1f-d57550cc96cc" xsi:nil="true"/>
-    <PlannedPubDate xmlns="4873beb7-5857-4685-be1f-d57550cc96cc" xsi:nil="true"/>
-    <IntlLangReviewer xmlns="4873beb7-5857-4685-be1f-d57550cc96cc" xsi:nil="true"/>
-    <TrustLevel xmlns="4873beb7-5857-4685-be1f-d57550cc96cc">1 Microsoft Managed Content</TrustLevel>
-    <LocLastLocAttemptVersionLookup xmlns="4873beb7-5857-4685-be1f-d57550cc96cc">694266</LocLastLocAttemptVersionLookup>
-    <LocProcessedForHandoffsLookup xmlns="4873beb7-5857-4685-be1f-d57550cc96cc" xsi:nil="true"/>
-    <IsSearchable xmlns="4873beb7-5857-4685-be1f-d57550cc96cc">true</IsSearchable>
-    <TemplateTemplateType xmlns="4873beb7-5857-4685-be1f-d57550cc96cc">PowerPoint Presentation Template</TemplateTemplateType>
-    <CampaignTagsTaxHTField0 xmlns="4873beb7-5857-4685-be1f-d57550cc96cc">
-      <Terms xmlns="http://schemas.microsoft.com/office/infopath/2007/PartnerControls"/>
-    </CampaignTagsTaxHTField0>
-    <TPNamespace xmlns="4873beb7-5857-4685-be1f-d57550cc96cc" xsi:nil="true"/>
-    <LocOverallPreviewStatusLookup xmlns="4873beb7-5857-4685-be1f-d57550cc96cc" xsi:nil="true"/>
-    <TaxCatchAll xmlns="4873beb7-5857-4685-be1f-d57550cc96cc"/>
-    <Markets xmlns="4873beb7-5857-4685-be1f-d57550cc96cc"/>
-    <UAProjectedTotalWords xmlns="4873beb7-5857-4685-be1f-d57550cc96cc" xsi:nil="true"/>
-    <IntlLangReview xmlns="4873beb7-5857-4685-be1f-d57550cc96cc" xsi:nil="true"/>
-    <OutputCachingOn xmlns="4873beb7-5857-4685-be1f-d57550cc96cc">false</OutputCachingOn>
-    <AverageRating xmlns="4873beb7-5857-4685-be1f-d57550cc96cc" xsi:nil="true"/>
-    <APAuthor xmlns="4873beb7-5857-4685-be1f-d57550cc96cc">
-      <UserInfo>
-        <DisplayName>REDMOND\kristaa</DisplayName>
-        <AccountId>136</AccountId>
-        <AccountType/>
-      </UserInfo>
-    </APAuthor>
-    <LocManualTestRequired xmlns="4873beb7-5857-4685-be1f-d57550cc96cc">false</LocManualTestRequired>
-    <TPCommandLine xmlns="4873beb7-5857-4685-be1f-d57550cc96cc" xsi:nil="true"/>
-    <TPAppVersion xmlns="4873beb7-5857-4685-be1f-d57550cc96cc" xsi:nil="true"/>
-    <EditorialStatus xmlns="4873beb7-5857-4685-be1f-d57550cc96cc">Complete</EditorialStatus>
-    <LastModifiedDateTime xmlns="4873beb7-5857-4685-be1f-d57550cc96cc" xsi:nil="true"/>
-    <ScenarioTagsTaxHTField0 xmlns="4873beb7-5857-4685-be1f-d57550cc96cc">
-      <Terms xmlns="http://schemas.microsoft.com/office/infopath/2007/PartnerControls"/>
-    </ScenarioTagsTaxHTField0>
-    <LocProcessedForMarketsLookup xmlns="4873beb7-5857-4685-be1f-d57550cc96cc" xsi:nil="true"/>
-    <TPLaunchHelpLinkType xmlns="4873beb7-5857-4685-be1f-d57550cc96cc">Template</TPLaunchHelpLinkType>
-    <OriginalRelease xmlns="4873beb7-5857-4685-be1f-d57550cc96cc">15</OriginalRelease>
-    <LocalizationTagsTaxHTField0 xmlns="4873beb7-5857-4685-be1f-d57550cc96cc">
-      <Terms xmlns="http://schemas.microsoft.com/office/infopath/2007/PartnerControls"/>
-    </LocalizationTagsTaxHTField0>
-    <UACurrentWords xmlns="4873beb7-5857-4685-be1f-d57550cc96cc" xsi:nil="true"/>
-    <ArtSampleDocs xmlns="4873beb7-5857-4685-be1f-d57550cc96cc" xsi:nil="true"/>
-    <UALocRecommendation xmlns="4873beb7-5857-4685-be1f-d57550cc96cc">Localize</UALocRecommendation>
-    <Manager xmlns="4873beb7-5857-4685-be1f-d57550cc96cc" xsi:nil="true"/>
-    <LocOverallHandbackStatusLookup xmlns="4873beb7-5857-4685-be1f-d57550cc96cc" xsi:nil="true"/>
-    <ShowIn xmlns="4873beb7-5857-4685-be1f-d57550cc96cc">Show everywhere</ShowIn>
-    <UANotes xmlns="4873beb7-5857-4685-be1f-d57550cc96cc" xsi:nil="true"/>
-    <InternalTagsTaxHTField0 xmlns="4873beb7-5857-4685-be1f-d57550cc96cc">
-      <Terms xmlns="http://schemas.microsoft.com/office/infopath/2007/PartnerControls"/>
-    </InternalTagsTaxHTField0>
-    <CSXHash xmlns="4873beb7-5857-4685-be1f-d57550cc96cc" xsi:nil="true"/>
-    <VoteCount xmlns="4873beb7-5857-4685-be1f-d57550cc96cc" xsi:nil="true"/>
-    <AssetExpire xmlns="4873beb7-5857-4685-be1f-d57550cc96cc">2029-05-12T07:00:00+00:00</AssetExpire>
-    <DSATActionTaken xmlns="4873beb7-5857-4685-be1f-d57550cc96cc" xsi:nil="true"/>
-    <CSXSubmissionMarket xmlns="4873beb7-5857-4685-be1f-d57550cc96cc" xsi:nil="true"/>
-    <LocMarketGroupTiers2 xmlns="4873beb7-5857-4685-be1f-d57550cc96cc" xsi:nil="true"/>
-  </documentManagement>
-</p:properties>
-</file>
-
-<file path=customXml/item2.xml><?xml version="1.0" encoding="utf-8"?>
-<?mso-contentType ?>
-<FormTemplates xmlns="http://schemas.microsoft.com/sharepoint/v3/contenttype/forms">
-  <Display>DocumentLibraryForm</Display>
-  <Edit>AssetEditForm</Edit>
-  <New>DocumentLibraryForm</New>
-</FormTemplates>
-</file>
-
-<file path=customXml/item3.xml><?xml version="1.0" encoding="utf-8"?>
 <ct:contentTypeSchema xmlns:ct="http://schemas.microsoft.com/office/2006/metadata/contentType" xmlns:ma="http://schemas.microsoft.com/office/2006/metadata/properties/metaAttributes" ct:_="" ma:_="" ma:contentTypeName="TemplateFile" ma:contentTypeID="0x0101006EDDDB5EE6D98C44930B742096920B300400F5B6D36B3EF94B4E9A635CDF2A18F5B8" ma:contentTypeVersion="72" ma:contentTypeDescription="Create a new document." ma:contentTypeScope="" ma:versionID="a23e56308344d904b51738559c3d67c9">
   <xsd:schema xmlns:xsd="http://www.w3.org/2001/XMLSchema" xmlns:xs="http://www.w3.org/2001/XMLSchema" xmlns:p="http://schemas.microsoft.com/office/2006/metadata/properties" xmlns:ns2="4873beb7-5857-4685-be1f-d57550cc96cc" targetNamespace="http://schemas.microsoft.com/office/2006/metadata/properties" ma:root="true" ma:fieldsID="cd0908cc4600e77bf5da051303e00c8d" ns2:_="">
     <xsd:import namespace="4873beb7-5857-4685-be1f-d57550cc96cc"/>
@@ -10199,7 +12776,170 @@
 </ct:contentTypeSchema>
 </file>
 
+<file path=customXml/item2.xml><?xml version="1.0" encoding="utf-8"?>
+<p:properties xmlns:p="http://schemas.microsoft.com/office/2006/metadata/properties" xmlns:xsi="http://www.w3.org/2001/XMLSchema-instance" xmlns:pc="http://schemas.microsoft.com/office/infopath/2007/PartnerControls">
+  <documentManagement>
+    <LocPublishedLinkedAssetsLookup xmlns="4873beb7-5857-4685-be1f-d57550cc96cc" xsi:nil="true"/>
+    <ApprovalStatus xmlns="4873beb7-5857-4685-be1f-d57550cc96cc">InProgress</ApprovalStatus>
+    <MarketSpecific xmlns="4873beb7-5857-4685-be1f-d57550cc96cc">false</MarketSpecific>
+    <LocComments xmlns="4873beb7-5857-4685-be1f-d57550cc96cc" xsi:nil="true"/>
+    <LocLastLocAttemptVersionTypeLookup xmlns="4873beb7-5857-4685-be1f-d57550cc96cc" xsi:nil="true"/>
+    <DirectSourceMarket xmlns="4873beb7-5857-4685-be1f-d57550cc96cc" xsi:nil="true"/>
+    <ThumbnailAssetId xmlns="4873beb7-5857-4685-be1f-d57550cc96cc" xsi:nil="true"/>
+    <PrimaryImageGen xmlns="4873beb7-5857-4685-be1f-d57550cc96cc">false</PrimaryImageGen>
+    <LocNewPublishedVersionLookup xmlns="4873beb7-5857-4685-be1f-d57550cc96cc" xsi:nil="true"/>
+    <LegacyData xmlns="4873beb7-5857-4685-be1f-d57550cc96cc" xsi:nil="true"/>
+    <LocRecommendedHandoff xmlns="4873beb7-5857-4685-be1f-d57550cc96cc" xsi:nil="true"/>
+    <BusinessGroup xmlns="4873beb7-5857-4685-be1f-d57550cc96cc" xsi:nil="true"/>
+    <BlockPublish xmlns="4873beb7-5857-4685-be1f-d57550cc96cc">false</BlockPublish>
+    <TPFriendlyName xmlns="4873beb7-5857-4685-be1f-d57550cc96cc" xsi:nil="true"/>
+    <LocOverallPublishStatusLookup xmlns="4873beb7-5857-4685-be1f-d57550cc96cc" xsi:nil="true"/>
+    <NumericId xmlns="4873beb7-5857-4685-be1f-d57550cc96cc" xsi:nil="true"/>
+    <APEditor xmlns="4873beb7-5857-4685-be1f-d57550cc96cc">
+      <UserInfo>
+        <DisplayName/>
+        <AccountId xsi:nil="true"/>
+        <AccountType/>
+      </UserInfo>
+    </APEditor>
+    <SourceTitle xmlns="4873beb7-5857-4685-be1f-d57550cc96cc" xsi:nil="true"/>
+    <OpenTemplate xmlns="4873beb7-5857-4685-be1f-d57550cc96cc">true</OpenTemplate>
+    <LocOverallLocStatusLookup xmlns="4873beb7-5857-4685-be1f-d57550cc96cc" xsi:nil="true"/>
+    <UALocComments xmlns="4873beb7-5857-4685-be1f-d57550cc96cc" xsi:nil="true"/>
+    <ParentAssetId xmlns="4873beb7-5857-4685-be1f-d57550cc96cc" xsi:nil="true"/>
+    <IntlLangReviewDate xmlns="4873beb7-5857-4685-be1f-d57550cc96cc" xsi:nil="true"/>
+    <FeatureTagsTaxHTField0 xmlns="4873beb7-5857-4685-be1f-d57550cc96cc">
+      <Terms xmlns="http://schemas.microsoft.com/office/infopath/2007/PartnerControls"/>
+    </FeatureTagsTaxHTField0>
+    <PublishStatusLookup xmlns="4873beb7-5857-4685-be1f-d57550cc96cc">
+      <Value>1345093</Value>
+    </PublishStatusLookup>
+    <Providers xmlns="4873beb7-5857-4685-be1f-d57550cc96cc" xsi:nil="true"/>
+    <MachineTranslated xmlns="4873beb7-5857-4685-be1f-d57550cc96cc">false</MachineTranslated>
+    <OriginalSourceMarket xmlns="4873beb7-5857-4685-be1f-d57550cc96cc" xsi:nil="true"/>
+    <APDescription xmlns="4873beb7-5857-4685-be1f-d57550cc96cc">This simple template design works for technology and  businesses, but it's versatile enough to use in other contexts.  It features multiple slide layouts designed for widescreen (16x9 resolution) and includes a sample SmartArt list and chart that are easily editable.</APDescription>
+    <ClipArtFilename xmlns="4873beb7-5857-4685-be1f-d57550cc96cc" xsi:nil="true"/>
+    <ContentItem xmlns="4873beb7-5857-4685-be1f-d57550cc96cc" xsi:nil="true"/>
+    <TPInstallLocation xmlns="4873beb7-5857-4685-be1f-d57550cc96cc" xsi:nil="true"/>
+    <PublishTargets xmlns="4873beb7-5857-4685-be1f-d57550cc96cc">OfficeOnlineVNext</PublishTargets>
+    <TimesCloned xmlns="4873beb7-5857-4685-be1f-d57550cc96cc" xsi:nil="true"/>
+    <AssetStart xmlns="4873beb7-5857-4685-be1f-d57550cc96cc">2011-11-26T00:30:00+00:00</AssetStart>
+    <Provider xmlns="4873beb7-5857-4685-be1f-d57550cc96cc" xsi:nil="true"/>
+    <AcquiredFrom xmlns="4873beb7-5857-4685-be1f-d57550cc96cc">Internal MS</AcquiredFrom>
+    <FriendlyTitle xmlns="4873beb7-5857-4685-be1f-d57550cc96cc" xsi:nil="true"/>
+    <LastHandOff xmlns="4873beb7-5857-4685-be1f-d57550cc96cc" xsi:nil="true"/>
+    <TPClientViewer xmlns="4873beb7-5857-4685-be1f-d57550cc96cc" xsi:nil="true"/>
+    <TemplateStatus xmlns="4873beb7-5857-4685-be1f-d57550cc96cc">Complete</TemplateStatus>
+    <Downloads xmlns="4873beb7-5857-4685-be1f-d57550cc96cc">0</Downloads>
+    <OOCacheId xmlns="4873beb7-5857-4685-be1f-d57550cc96cc" xsi:nil="true"/>
+    <IsDeleted xmlns="4873beb7-5857-4685-be1f-d57550cc96cc">false</IsDeleted>
+    <LocPublishedDependentAssetsLookup xmlns="4873beb7-5857-4685-be1f-d57550cc96cc" xsi:nil="true"/>
+    <TPExecutable xmlns="4873beb7-5857-4685-be1f-d57550cc96cc" xsi:nil="true"/>
+    <EditorialTags xmlns="4873beb7-5857-4685-be1f-d57550cc96cc" xsi:nil="true"/>
+    <SubmitterId xmlns="4873beb7-5857-4685-be1f-d57550cc96cc" xsi:nil="true"/>
+    <ApprovalLog xmlns="4873beb7-5857-4685-be1f-d57550cc96cc" xsi:nil="true"/>
+    <AssetType xmlns="4873beb7-5857-4685-be1f-d57550cc96cc">TP</AssetType>
+    <BugNumber xmlns="4873beb7-5857-4685-be1f-d57550cc96cc" xsi:nil="true"/>
+    <CSXSubmissionDate xmlns="4873beb7-5857-4685-be1f-d57550cc96cc" xsi:nil="true"/>
+    <CSXUpdate xmlns="4873beb7-5857-4685-be1f-d57550cc96cc">false</CSXUpdate>
+    <Milestone xmlns="4873beb7-5857-4685-be1f-d57550cc96cc" xsi:nil="true"/>
+    <RecommendationsModifier xmlns="4873beb7-5857-4685-be1f-d57550cc96cc" xsi:nil="true"/>
+    <OriginAsset xmlns="4873beb7-5857-4685-be1f-d57550cc96cc" xsi:nil="true"/>
+    <TPComponent xmlns="4873beb7-5857-4685-be1f-d57550cc96cc" xsi:nil="true"/>
+    <AssetId xmlns="4873beb7-5857-4685-be1f-d57550cc96cc">TP102787989</AssetId>
+    <IntlLocPriority xmlns="4873beb7-5857-4685-be1f-d57550cc96cc" xsi:nil="true"/>
+    <PolicheckWords xmlns="4873beb7-5857-4685-be1f-d57550cc96cc" xsi:nil="true"/>
+    <TPLaunchHelpLink xmlns="4873beb7-5857-4685-be1f-d57550cc96cc" xsi:nil="true"/>
+    <TPApplication xmlns="4873beb7-5857-4685-be1f-d57550cc96cc" xsi:nil="true"/>
+    <CrawlForDependencies xmlns="4873beb7-5857-4685-be1f-d57550cc96cc">false</CrawlForDependencies>
+    <HandoffToMSDN xmlns="4873beb7-5857-4685-be1f-d57550cc96cc" xsi:nil="true"/>
+    <PlannedPubDate xmlns="4873beb7-5857-4685-be1f-d57550cc96cc" xsi:nil="true"/>
+    <IntlLangReviewer xmlns="4873beb7-5857-4685-be1f-d57550cc96cc" xsi:nil="true"/>
+    <TrustLevel xmlns="4873beb7-5857-4685-be1f-d57550cc96cc">1 Microsoft Managed Content</TrustLevel>
+    <LocLastLocAttemptVersionLookup xmlns="4873beb7-5857-4685-be1f-d57550cc96cc">694266</LocLastLocAttemptVersionLookup>
+    <LocProcessedForHandoffsLookup xmlns="4873beb7-5857-4685-be1f-d57550cc96cc" xsi:nil="true"/>
+    <IsSearchable xmlns="4873beb7-5857-4685-be1f-d57550cc96cc">true</IsSearchable>
+    <TemplateTemplateType xmlns="4873beb7-5857-4685-be1f-d57550cc96cc">PowerPoint Presentation Template</TemplateTemplateType>
+    <CampaignTagsTaxHTField0 xmlns="4873beb7-5857-4685-be1f-d57550cc96cc">
+      <Terms xmlns="http://schemas.microsoft.com/office/infopath/2007/PartnerControls"/>
+    </CampaignTagsTaxHTField0>
+    <TPNamespace xmlns="4873beb7-5857-4685-be1f-d57550cc96cc" xsi:nil="true"/>
+    <LocOverallPreviewStatusLookup xmlns="4873beb7-5857-4685-be1f-d57550cc96cc" xsi:nil="true"/>
+    <TaxCatchAll xmlns="4873beb7-5857-4685-be1f-d57550cc96cc"/>
+    <Markets xmlns="4873beb7-5857-4685-be1f-d57550cc96cc"/>
+    <UAProjectedTotalWords xmlns="4873beb7-5857-4685-be1f-d57550cc96cc" xsi:nil="true"/>
+    <IntlLangReview xmlns="4873beb7-5857-4685-be1f-d57550cc96cc" xsi:nil="true"/>
+    <OutputCachingOn xmlns="4873beb7-5857-4685-be1f-d57550cc96cc">false</OutputCachingOn>
+    <AverageRating xmlns="4873beb7-5857-4685-be1f-d57550cc96cc" xsi:nil="true"/>
+    <APAuthor xmlns="4873beb7-5857-4685-be1f-d57550cc96cc">
+      <UserInfo>
+        <DisplayName>REDMOND\kristaa</DisplayName>
+        <AccountId>136</AccountId>
+        <AccountType/>
+      </UserInfo>
+    </APAuthor>
+    <LocManualTestRequired xmlns="4873beb7-5857-4685-be1f-d57550cc96cc">false</LocManualTestRequired>
+    <TPCommandLine xmlns="4873beb7-5857-4685-be1f-d57550cc96cc" xsi:nil="true"/>
+    <TPAppVersion xmlns="4873beb7-5857-4685-be1f-d57550cc96cc" xsi:nil="true"/>
+    <EditorialStatus xmlns="4873beb7-5857-4685-be1f-d57550cc96cc">Complete</EditorialStatus>
+    <LastModifiedDateTime xmlns="4873beb7-5857-4685-be1f-d57550cc96cc" xsi:nil="true"/>
+    <ScenarioTagsTaxHTField0 xmlns="4873beb7-5857-4685-be1f-d57550cc96cc">
+      <Terms xmlns="http://schemas.microsoft.com/office/infopath/2007/PartnerControls"/>
+    </ScenarioTagsTaxHTField0>
+    <LocProcessedForMarketsLookup xmlns="4873beb7-5857-4685-be1f-d57550cc96cc" xsi:nil="true"/>
+    <TPLaunchHelpLinkType xmlns="4873beb7-5857-4685-be1f-d57550cc96cc">Template</TPLaunchHelpLinkType>
+    <OriginalRelease xmlns="4873beb7-5857-4685-be1f-d57550cc96cc">15</OriginalRelease>
+    <LocalizationTagsTaxHTField0 xmlns="4873beb7-5857-4685-be1f-d57550cc96cc">
+      <Terms xmlns="http://schemas.microsoft.com/office/infopath/2007/PartnerControls"/>
+    </LocalizationTagsTaxHTField0>
+    <UACurrentWords xmlns="4873beb7-5857-4685-be1f-d57550cc96cc" xsi:nil="true"/>
+    <ArtSampleDocs xmlns="4873beb7-5857-4685-be1f-d57550cc96cc" xsi:nil="true"/>
+    <UALocRecommendation xmlns="4873beb7-5857-4685-be1f-d57550cc96cc">Localize</UALocRecommendation>
+    <Manager xmlns="4873beb7-5857-4685-be1f-d57550cc96cc" xsi:nil="true"/>
+    <LocOverallHandbackStatusLookup xmlns="4873beb7-5857-4685-be1f-d57550cc96cc" xsi:nil="true"/>
+    <ShowIn xmlns="4873beb7-5857-4685-be1f-d57550cc96cc">Show everywhere</ShowIn>
+    <UANotes xmlns="4873beb7-5857-4685-be1f-d57550cc96cc" xsi:nil="true"/>
+    <InternalTagsTaxHTField0 xmlns="4873beb7-5857-4685-be1f-d57550cc96cc">
+      <Terms xmlns="http://schemas.microsoft.com/office/infopath/2007/PartnerControls"/>
+    </InternalTagsTaxHTField0>
+    <CSXHash xmlns="4873beb7-5857-4685-be1f-d57550cc96cc" xsi:nil="true"/>
+    <VoteCount xmlns="4873beb7-5857-4685-be1f-d57550cc96cc" xsi:nil="true"/>
+    <AssetExpire xmlns="4873beb7-5857-4685-be1f-d57550cc96cc">2029-05-12T07:00:00+00:00</AssetExpire>
+    <DSATActionTaken xmlns="4873beb7-5857-4685-be1f-d57550cc96cc" xsi:nil="true"/>
+    <CSXSubmissionMarket xmlns="4873beb7-5857-4685-be1f-d57550cc96cc" xsi:nil="true"/>
+    <LocMarketGroupTiers2 xmlns="4873beb7-5857-4685-be1f-d57550cc96cc" xsi:nil="true"/>
+  </documentManagement>
+</p:properties>
+</file>
+
+<file path=customXml/item3.xml><?xml version="1.0" encoding="utf-8"?>
+<?mso-contentType ?>
+<FormTemplates xmlns="http://schemas.microsoft.com/sharepoint/v3/contenttype/forms">
+  <Display>DocumentLibraryForm</Display>
+  <Edit>AssetEditForm</Edit>
+  <New>DocumentLibraryForm</New>
+</FormTemplates>
+</file>
+
 <file path=customXml/itemProps1.xml><?xml version="1.0" encoding="utf-8"?>
+<ds:datastoreItem xmlns:ds="http://schemas.openxmlformats.org/officeDocument/2006/customXml" ds:itemID="{A09BF4D4-EF60-4196-BFC3-9462D607978C}">
+  <ds:schemaRefs>
+    <ds:schemaRef ds:uri="http://schemas.microsoft.com/office/2006/metadata/contentType"/>
+    <ds:schemaRef ds:uri="http://schemas.microsoft.com/office/2006/metadata/properties/metaAttributes"/>
+    <ds:schemaRef ds:uri="http://www.w3.org/2001/XMLSchema"/>
+    <ds:schemaRef ds:uri="http://schemas.microsoft.com/office/2006/metadata/properties"/>
+    <ds:schemaRef ds:uri="4873beb7-5857-4685-be1f-d57550cc96cc"/>
+    <ds:schemaRef ds:uri="http://schemas.microsoft.com/office/2006/documentManagement/types"/>
+    <ds:schemaRef ds:uri="http://schemas.microsoft.com/office/infopath/2007/PartnerControls"/>
+    <ds:schemaRef ds:uri="http://schemas.openxmlformats.org/package/2006/metadata/core-properties"/>
+    <ds:schemaRef ds:uri="http://purl.org/dc/elements/1.1/"/>
+    <ds:schemaRef ds:uri="http://purl.org/dc/terms/"/>
+    <ds:schemaRef ds:uri="http://schemas.microsoft.com/internal/obd"/>
+  </ds:schemaRefs>
+</ds:datastoreItem>
+</file>
+
+<file path=customXml/itemProps2.xml><?xml version="1.0" encoding="utf-8"?>
 <ds:datastoreItem xmlns:ds="http://schemas.openxmlformats.org/officeDocument/2006/customXml" ds:itemID="{60C67BEE-D13F-4BD2-98A5-34D8A0977F68}">
   <ds:schemaRefs>
     <ds:schemaRef ds:uri="4873beb7-5857-4685-be1f-d57550cc96cc"/>
@@ -10215,28 +12955,10 @@
 </ds:datastoreItem>
 </file>
 
-<file path=customXml/itemProps2.xml><?xml version="1.0" encoding="utf-8"?>
+<file path=customXml/itemProps3.xml><?xml version="1.0" encoding="utf-8"?>
 <ds:datastoreItem xmlns:ds="http://schemas.openxmlformats.org/officeDocument/2006/customXml" ds:itemID="{3836F65B-1B07-41EE-A0E8-BC6EF3855225}">
   <ds:schemaRefs>
     <ds:schemaRef ds:uri="http://schemas.microsoft.com/sharepoint/v3/contenttype/forms"/>
   </ds:schemaRefs>
 </ds:datastoreItem>
-</file>
-
-<file path=customXml/itemProps3.xml><?xml version="1.0" encoding="utf-8"?>
-<ds:datastoreItem xmlns:ds="http://schemas.openxmlformats.org/officeDocument/2006/customXml" ds:itemID="{A09BF4D4-EF60-4196-BFC3-9462D607978C}">
-  <ds:schemaRefs>
-    <ds:schemaRef ds:uri="http://schemas.microsoft.com/office/2006/metadata/contentType"/>
-    <ds:schemaRef ds:uri="http://schemas.microsoft.com/office/2006/metadata/properties/metaAttributes"/>
-    <ds:schemaRef ds:uri="http://www.w3.org/2001/XMLSchema"/>
-    <ds:schemaRef ds:uri="http://schemas.microsoft.com/office/2006/metadata/properties"/>
-    <ds:schemaRef ds:uri="4873beb7-5857-4685-be1f-d57550cc96cc"/>
-    <ds:schemaRef ds:uri="http://schemas.microsoft.com/office/2006/documentManagement/types"/>
-    <ds:schemaRef ds:uri="http://schemas.microsoft.com/office/infopath/2007/PartnerControls"/>
-    <ds:schemaRef ds:uri="http://schemas.openxmlformats.org/package/2006/metadata/core-properties"/>
-    <ds:schemaRef ds:uri="http://purl.org/dc/elements/1.1/"/>
-    <ds:schemaRef ds:uri="http://purl.org/dc/terms/"/>
-    <ds:schemaRef ds:uri="http://schemas.microsoft.com/internal/obd"/>
-  </ds:schemaRefs>
-</ds:datastoreItem>
 </file>
</xml_diff>